<commit_message>
Add RetinaNet detection examples to deck + PDF, lower conf threshold
- Add 'RetinaNet in Action' slide with real Pi/USB hub detections
- Export pitch deck to PDF for easy sharing
- Lower CONF_THRESHOLD 0.35 -> 0.25 for better demo detection rate
- Add retinanet_demo.py inference visualization script

Co-Authored-By: Claude Opus 4.8 <noreply@anthropic.com>
</commit_message>
<xml_diff>
--- a/presentation/dc_ops_pitch.pptx
+++ b/presentation/dc_ops_pitch.pptx
@@ -18,9 +18,10 @@
     <p:sldId id="266" r:id="rId12"/>
     <p:sldId id="267" r:id="rId13"/>
     <p:sldId id="268" r:id="rId14"/>
+    <p:sldId id="269" r:id="rId15"/>
   </p:sldIdLst>
   <p:notesMasterIdLst>
-    <p:notesMasterId r:id="rId15"/>
+    <p:notesMasterId r:id="rId16"/>
   </p:notesMasterIdLst>
   <p:sldSz cx="12192000" cy="6858000"/>
   <p:notesSz cx="6858000" cy="12192000"/>
@@ -890,6 +891,94 @@
             <a:fld id="{F7021451-1387-4CA6-816F-3879F97B5CBC}" type="slidenum">
               <a:rPr lang="en-US"/>
               <a:t>13</a:t>
+            </a:fld>
+            <a:endParaRPr lang="en-US"/>
+          </a:p>
+        </p:txBody>
+      </p:sp>
+    </p:spTree>
+    <p:extLst>
+      <p:ext uri="{BB962C8B-B14F-4D97-AF65-F5344CB8AC3E}">
+        <p14:creationId xmlns:p14="http://schemas.microsoft.com/office/powerpoint/2010/main" val="1024086991"/>
+      </p:ext>
+    </p:extLst>
+  </p:cSld>
+  <p:clrMapOvr>
+    <a:masterClrMapping/>
+  </p:clrMapOvr>
+</p:notes>
+</file>
+
+<file path=ppt/notesSlides/notesSlide14.xml><?xml version="1.0" encoding="utf-8"?>
+<p:notes xmlns:a="http://schemas.openxmlformats.org/drawingml/2006/main" xmlns:r="http://schemas.openxmlformats.org/officeDocument/2006/relationships" xmlns:p="http://schemas.openxmlformats.org/presentationml/2006/main">
+  <p:cSld>
+    <p:spTree>
+      <p:nvGrpSpPr>
+        <p:cNvPr id="1" name=""/>
+        <p:cNvGrpSpPr/>
+        <p:nvPr/>
+      </p:nvGrpSpPr>
+      <p:grpSpPr>
+        <a:xfrm>
+          <a:off x="0" y="0"/>
+          <a:ext cx="0" cy="0"/>
+          <a:chOff x="0" y="0"/>
+          <a:chExt cx="0" cy="0"/>
+        </a:xfrm>
+      </p:grpSpPr>
+      <p:sp>
+        <p:nvSpPr>
+          <p:cNvPr id="2" name="Slide Image Placeholder 1"/>
+          <p:cNvSpPr>
+            <a:spLocks noGrp="1" noRot="1" noChangeAspect="1"/>
+          </p:cNvSpPr>
+          <p:nvPr>
+            <p:ph type="sldImg"/>
+          </p:nvPr>
+        </p:nvSpPr>
+        <p:spPr/>
+      </p:sp>
+      <p:sp>
+        <p:nvSpPr>
+          <p:cNvPr id="3" name="Notes Placeholder 2"/>
+          <p:cNvSpPr>
+            <a:spLocks noGrp="1"/>
+          </p:cNvSpPr>
+          <p:nvPr>
+            <p:ph type="body" idx="1"/>
+          </p:nvPr>
+        </p:nvSpPr>
+        <p:spPr/>
+        <p:txBody>
+          <a:bodyPr/>
+          <a:lstStyle/>
+          <a:p>
+            <a:r>
+              <a:rPr lang="en-US" dirty="0"/>
+              <a:t/>
+            </a:r>
+            <a:endParaRPr lang="en-US" dirty="0"/>
+          </a:p>
+        </p:txBody>
+      </p:sp>
+      <p:sp>
+        <p:nvSpPr>
+          <p:cNvPr id="4" name="Slide Number Placeholder 3"/>
+          <p:cNvSpPr>
+            <a:spLocks noGrp="1"/>
+          </p:cNvSpPr>
+          <p:nvPr>
+            <p:ph type="sldNum" sz="quarter" idx="10"/>
+          </p:nvPr>
+        </p:nvSpPr>
+        <p:spPr/>
+        <p:txBody>
+          <a:bodyPr/>
+          <a:lstStyle/>
+          <a:p>
+            <a:fld id="{F7021451-1387-4CA6-816F-3879F97B5CBC}" type="slidenum">
+              <a:rPr lang="en-US"/>
+              <a:t>14</a:t>
             </a:fld>
             <a:endParaRPr lang="en-US"/>
           </a:p>
@@ -2207,7 +2296,7 @@
                 <a:ea typeface="Arial Black" pitchFamily="34" charset="-122"/>
                 <a:cs typeface="Arial Black" pitchFamily="34" charset="-120"/>
               </a:rPr>
-              <a:t>RAG KNOWLEDGE OVERLAY</a:t>
+              <a:t>RETINANET IN ACTION</a:t>
             </a:r>
             <a:endParaRPr lang="en-US" sz="3600" dirty="0"/>
           </a:p>
@@ -2221,7 +2310,7 @@
         </p:nvSpPr>
         <p:spPr>
           <a:xfrm>
-            <a:off x="731520" y="1097280"/>
+            <a:off x="731520" y="1051560"/>
             <a:ext cx="10058400" cy="457200"/>
           </a:xfrm>
           <a:prstGeom prst="rect">
@@ -2238,438 +2327,102 @@
               <a:buNone/>
             </a:pPr>
             <a:r>
-              <a:rPr lang="en-US" sz="1800" dirty="0">
-                <a:solidFill>
-                  <a:srgbClr val="FFFFFF"/>
-                </a:solidFill>
-                <a:latin typeface="Arial" pitchFamily="34" charset="0"/>
-                <a:ea typeface="Arial" pitchFamily="34" charset="-122"/>
-                <a:cs typeface="Arial" pitchFamily="34" charset="-120"/>
-              </a:rPr>
-              <a:t>Detect → Embed → Retrieve → Display</a:t>
-            </a:r>
-            <a:endParaRPr lang="en-US" sz="1800" dirty="0"/>
-          </a:p>
-        </p:txBody>
-      </p:sp>
-      <p:sp>
-        <p:nvSpPr>
-          <p:cNvPr id="4" name="Shape 2"/>
-          <p:cNvSpPr/>
-          <p:nvPr/>
-        </p:nvSpPr>
-        <p:spPr>
-          <a:xfrm>
-            <a:off x="1371600" y="1828800"/>
-            <a:ext cx="5029200" cy="3200400"/>
-          </a:xfrm>
-          <a:prstGeom prst="roundRect">
-            <a:avLst>
-              <a:gd name="adj" fmla="val 4286"/>
-            </a:avLst>
-          </a:prstGeom>
-          <a:solidFill>
-            <a:srgbClr val="161B22"/>
-          </a:solidFill>
-          <a:ln w="25400">
-            <a:solidFill>
-              <a:srgbClr val="00E676"/>
-            </a:solidFill>
-            <a:prstDash val="solid"/>
-          </a:ln>
-        </p:spPr>
-      </p:sp>
-      <p:sp>
-        <p:nvSpPr>
-          <p:cNvPr id="5" name="Text 3"/>
-          <p:cNvSpPr/>
-          <p:nvPr/>
-        </p:nvSpPr>
-        <p:spPr>
-          <a:xfrm>
-            <a:off x="1554480" y="1920240"/>
-            <a:ext cx="4663440" cy="457200"/>
-          </a:xfrm>
-          <a:prstGeom prst="rect">
-            <a:avLst/>
-          </a:prstGeom>
-          <a:noFill/>
-          <a:ln/>
-        </p:spPr>
-        <p:txBody>
-          <a:bodyPr wrap="square" rtlCol="0" anchor="ctr"/>
-          <a:lstStyle/>
-          <a:p>
-            <a:pPr indent="0" marL="0">
-              <a:buNone/>
-            </a:pPr>
-            <a:r>
-              <a:rPr lang="en-US" sz="1600" b="1" dirty="0">
-                <a:solidFill>
-                  <a:srgbClr val="00E676"/>
-                </a:solidFill>
-                <a:latin typeface="Consolas" pitchFamily="34" charset="0"/>
-                <a:ea typeface="Consolas" pitchFamily="34" charset="-122"/>
-                <a:cs typeface="Consolas" pitchFamily="34" charset="-120"/>
-              </a:rPr>
-              <a:t>COMPUTE TRAY                           92%</a:t>
-            </a:r>
-            <a:endParaRPr lang="en-US" sz="1600" dirty="0"/>
-          </a:p>
-        </p:txBody>
-      </p:sp>
-      <p:sp>
-        <p:nvSpPr>
-          <p:cNvPr id="6" name="Text 4"/>
-          <p:cNvSpPr/>
-          <p:nvPr/>
-        </p:nvSpPr>
-        <p:spPr>
-          <a:xfrm>
-            <a:off x="1554480" y="2468880"/>
-            <a:ext cx="4663440" cy="2377440"/>
-          </a:xfrm>
-          <a:prstGeom prst="rect">
-            <a:avLst/>
-          </a:prstGeom>
-          <a:noFill/>
-          <a:ln/>
-        </p:spPr>
-        <p:txBody>
-          <a:bodyPr wrap="square" rtlCol="0" anchor="ctr"/>
-          <a:lstStyle/>
-          <a:p>
-            <a:pPr indent="0" marL="0">
-              <a:lnSpc>
-                <a:spcPct val="130000"/>
-              </a:lnSpc>
-              <a:buNone/>
-            </a:pPr>
-            <a:r>
-              <a:rPr lang="en-US" sz="1300" dirty="0">
+              <a:rPr lang="en-US" sz="1500" dirty="0">
+                <a:solidFill>
+                  <a:srgbClr val="8B949E"/>
+                </a:solidFill>
+                <a:latin typeface="Arial" pitchFamily="34" charset="0"/>
+                <a:ea typeface="Arial" pitchFamily="34" charset="-122"/>
+                <a:cs typeface="Arial" pitchFamily="34" charset="-120"/>
+              </a:rPr>
+              <a:t>Real detections on a Raspberry Pi &amp; USB hub — mirrors our physical demo prop</a:t>
+            </a:r>
+            <a:endParaRPr lang="en-US" sz="1500" dirty="0"/>
+          </a:p>
+        </p:txBody>
+      </p:sp>
+      <p:pic>
+        <p:nvPicPr>
+          <p:cNvPr id="4" name="Image 0" descr="/Users/abhijitbetigeri/projects/DC-Ops/data/retinanet_demo/det_pc_ports_valid_20230515_214424.jpg">    </p:cNvPr>
+          <p:cNvPicPr>
+            <a:picLocks noChangeAspect="1"/>
+          </p:cNvPicPr>
+          <p:nvPr/>
+        </p:nvPicPr>
+        <p:blipFill>
+          <a:blip r:embed="rId1"/>
+          <a:srcRect l="0" r="0" t="0" b="0"/>
+          <a:stretch/>
+        </p:blipFill>
+        <p:spPr>
+          <a:xfrm>
+            <a:off x="731520" y="1645920"/>
+            <a:ext cx="5120640" cy="3840480"/>
+          </a:xfrm>
+          <a:prstGeom prst="rect">
+            <a:avLst/>
+          </a:prstGeom>
+        </p:spPr>
+      </p:pic>
+      <p:pic>
+        <p:nvPicPr>
+          <p:cNvPr id="5" name="Image 1" descr="/Users/abhijitbetigeri/projects/DC-Ops/data/retinanet_demo/det_pc_ports_valid_20230515_212627.jpg">    </p:cNvPr>
+          <p:cNvPicPr>
+            <a:picLocks noChangeAspect="1"/>
+          </p:cNvPicPr>
+          <p:nvPr/>
+        </p:nvPicPr>
+        <p:blipFill>
+          <a:blip r:embed="rId2"/>
+          <a:srcRect l="0" r="0" t="0" b="0"/>
+          <a:stretch/>
+        </p:blipFill>
+        <p:spPr>
+          <a:xfrm>
+            <a:off x="6217920" y="1645920"/>
+            <a:ext cx="5120640" cy="3840480"/>
+          </a:xfrm>
+          <a:prstGeom prst="rect">
+            <a:avLst/>
+          </a:prstGeom>
+        </p:spPr>
+      </p:pic>
+      <p:sp>
+        <p:nvSpPr>
+          <p:cNvPr id="6" name="Text 2"/>
+          <p:cNvSpPr/>
+          <p:nvPr/>
+        </p:nvSpPr>
+        <p:spPr>
+          <a:xfrm>
+            <a:off x="731520" y="5577840"/>
+            <a:ext cx="10058400" cy="365760"/>
+          </a:xfrm>
+          <a:prstGeom prst="rect">
+            <a:avLst/>
+          </a:prstGeom>
+          <a:noFill/>
+          <a:ln/>
+        </p:spPr>
+        <p:txBody>
+          <a:bodyPr wrap="square" rtlCol="0" anchor="ctr"/>
+          <a:lstStyle/>
+          <a:p>
+            <a:pPr algn="ctr" indent="0" marL="0">
+              <a:buNone/>
+            </a:pPr>
+            <a:r>
+              <a:rPr lang="en-US" sz="1300" i="1" dirty="0">
                 <a:solidFill>
                   <a:srgbClr val="C9D1D9"/>
                 </a:solidFill>
-                <a:latin typeface="Consolas" pitchFamily="34" charset="0"/>
-                <a:ea typeface="Consolas" pitchFamily="34" charset="-122"/>
-                <a:cs typeface="Consolas" pitchFamily="34" charset="-120"/>
-              </a:rPr>
-              <a:t>⚙️  2x Grace CPU, 4x B200 GPU, 192GB HBM3e</a:t>
+                <a:latin typeface="Arial" pitchFamily="34" charset="0"/>
+                <a:ea typeface="Arial" pitchFamily="34" charset="-122"/>
+                <a:cs typeface="Arial" pitchFamily="34" charset="-120"/>
+              </a:rPr>
+              <a:t>All USB + RJ45 ports detected as 'network port' — fully on-device</a:t>
             </a:r>
             <a:endParaRPr lang="en-US" sz="1300" dirty="0"/>
-          </a:p>
-          <a:p>
-            <a:pPr indent="0" marL="0">
-              <a:lnSpc>
-                <a:spcPct val="130000"/>
-              </a:lnSpc>
-              <a:buNone/>
-            </a:pPr>
-            <a:endParaRPr lang="en-US" sz="1300" dirty="0"/>
-          </a:p>
-          <a:p>
-            <a:pPr indent="0" marL="0">
-              <a:lnSpc>
-                <a:spcPct val="130000"/>
-              </a:lnSpc>
-              <a:buNone/>
-            </a:pPr>
-            <a:r>
-              <a:rPr lang="en-US" sz="1300" dirty="0">
-                <a:solidFill>
-                  <a:srgbClr val="C9D1D9"/>
-                </a:solidFill>
-                <a:latin typeface="Consolas" pitchFamily="34" charset="0"/>
-                <a:ea typeface="Consolas" pitchFamily="34" charset="-122"/>
-                <a:cs typeface="Consolas" pitchFamily="34" charset="-120"/>
-              </a:rPr>
-              <a:t>🟢  Green LED = healthy and operational</a:t>
-            </a:r>
-            <a:endParaRPr lang="en-US" sz="1300" dirty="0"/>
-          </a:p>
-          <a:p>
-            <a:pPr indent="0" marL="0">
-              <a:lnSpc>
-                <a:spcPct val="130000"/>
-              </a:lnSpc>
-              <a:buNone/>
-            </a:pPr>
-            <a:r>
-              <a:rPr lang="en-US" sz="1300" dirty="0">
-                <a:solidFill>
-                  <a:srgbClr val="C9D1D9"/>
-                </a:solidFill>
-                <a:latin typeface="Consolas" pitchFamily="34" charset="0"/>
-                <a:ea typeface="Consolas" pitchFamily="34" charset="-122"/>
-                <a:cs typeface="Consolas" pitchFamily="34" charset="-120"/>
-              </a:rPr>
-              <a:t>🟡  Amber LED = check BMC log, verify coolant</a:t>
-            </a:r>
-            <a:endParaRPr lang="en-US" sz="1300" dirty="0"/>
-          </a:p>
-          <a:p>
-            <a:pPr indent="0" marL="0">
-              <a:lnSpc>
-                <a:spcPct val="130000"/>
-              </a:lnSpc>
-              <a:buNone/>
-            </a:pPr>
-            <a:r>
-              <a:rPr lang="en-US" sz="1300" dirty="0">
-                <a:solidFill>
-                  <a:srgbClr val="C9D1D9"/>
-                </a:solidFill>
-                <a:latin typeface="Consolas" pitchFamily="34" charset="0"/>
-                <a:ea typeface="Consolas" pitchFamily="34" charset="-122"/>
-                <a:cs typeface="Consolas" pitchFamily="34" charset="-120"/>
-              </a:rPr>
-              <a:t>🔴  Red LED = critical hardware failure</a:t>
-            </a:r>
-            <a:endParaRPr lang="en-US" sz="1300" dirty="0"/>
-          </a:p>
-          <a:p>
-            <a:pPr indent="0" marL="0">
-              <a:lnSpc>
-                <a:spcPct val="130000"/>
-              </a:lnSpc>
-              <a:buNone/>
-            </a:pPr>
-            <a:endParaRPr lang="en-US" sz="1300" dirty="0"/>
-          </a:p>
-          <a:p>
-            <a:pPr indent="0" marL="0">
-              <a:lnSpc>
-                <a:spcPct val="130000"/>
-              </a:lnSpc>
-              <a:buNone/>
-            </a:pPr>
-            <a:r>
-              <a:rPr lang="en-US" sz="1300" dirty="0">
-                <a:solidFill>
-                  <a:srgbClr val="C9D1D9"/>
-                </a:solidFill>
-                <a:latin typeface="Consolas" pitchFamily="34" charset="0"/>
-                <a:ea typeface="Consolas" pitchFamily="34" charset="-122"/>
-                <a:cs typeface="Consolas" pitchFamily="34" charset="-120"/>
-              </a:rPr>
-              <a:t>🔧  Maintenance: check cold plate contact,</a:t>
-            </a:r>
-            <a:endParaRPr lang="en-US" sz="1300" dirty="0"/>
-          </a:p>
-          <a:p>
-            <a:pPr indent="0" marL="0">
-              <a:lnSpc>
-                <a:spcPct val="130000"/>
-              </a:lnSpc>
-              <a:buNone/>
-            </a:pPr>
-            <a:r>
-              <a:rPr lang="en-US" sz="1300" dirty="0">
-                <a:solidFill>
-                  <a:srgbClr val="C9D1D9"/>
-                </a:solidFill>
-                <a:latin typeface="Consolas" pitchFamily="34" charset="0"/>
-                <a:ea typeface="Consolas" pitchFamily="34" charset="-122"/>
-                <a:cs typeface="Consolas" pitchFamily="34" charset="-120"/>
-              </a:rPr>
-              <a:t>     verify NVLink connector seating</a:t>
-            </a:r>
-            <a:endParaRPr lang="en-US" sz="1300" dirty="0"/>
-          </a:p>
-        </p:txBody>
-      </p:sp>
-      <p:sp>
-        <p:nvSpPr>
-          <p:cNvPr id="7" name="Text 5"/>
-          <p:cNvSpPr/>
-          <p:nvPr/>
-        </p:nvSpPr>
-        <p:spPr>
-          <a:xfrm>
-            <a:off x="6858000" y="2011680"/>
-            <a:ext cx="4114800" cy="457200"/>
-          </a:xfrm>
-          <a:prstGeom prst="rect">
-            <a:avLst/>
-          </a:prstGeom>
-          <a:noFill/>
-          <a:ln/>
-        </p:spPr>
-        <p:txBody>
-          <a:bodyPr wrap="square" rtlCol="0" anchor="ctr"/>
-          <a:lstStyle/>
-          <a:p>
-            <a:pPr indent="0" marL="0">
-              <a:buNone/>
-            </a:pPr>
-            <a:r>
-              <a:rPr lang="en-US" sz="1400" dirty="0">
-                <a:solidFill>
-                  <a:srgbClr val="C9D1D9"/>
-                </a:solidFill>
-                <a:latin typeface="Arial" pitchFamily="34" charset="0"/>
-                <a:ea typeface="Arial" pitchFamily="34" charset="-122"/>
-                <a:cs typeface="Arial" pitchFamily="34" charset="-120"/>
-              </a:rPr>
-              <a:t>▸ 80 knowledge chunks</a:t>
-            </a:r>
-            <a:endParaRPr lang="en-US" sz="1400" dirty="0"/>
-          </a:p>
-        </p:txBody>
-      </p:sp>
-      <p:sp>
-        <p:nvSpPr>
-          <p:cNvPr id="8" name="Text 6"/>
-          <p:cNvSpPr/>
-          <p:nvPr/>
-        </p:nvSpPr>
-        <p:spPr>
-          <a:xfrm>
-            <a:off x="6858000" y="2514600"/>
-            <a:ext cx="4114800" cy="457200"/>
-          </a:xfrm>
-          <a:prstGeom prst="rect">
-            <a:avLst/>
-          </a:prstGeom>
-          <a:noFill/>
-          <a:ln/>
-        </p:spPr>
-        <p:txBody>
-          <a:bodyPr wrap="square" rtlCol="0" anchor="ctr"/>
-          <a:lstStyle/>
-          <a:p>
-            <a:pPr indent="0" marL="0">
-              <a:buNone/>
-            </a:pPr>
-            <a:r>
-              <a:rPr lang="en-US" sz="1400" dirty="0">
-                <a:solidFill>
-                  <a:srgbClr val="C9D1D9"/>
-                </a:solidFill>
-                <a:latin typeface="Arial" pitchFamily="34" charset="0"/>
-                <a:ea typeface="Arial" pitchFamily="34" charset="-122"/>
-                <a:cs typeface="Arial" pitchFamily="34" charset="-120"/>
-              </a:rPr>
-              <a:t>▸ CLIP ViT-B-32 embeddings</a:t>
-            </a:r>
-            <a:endParaRPr lang="en-US" sz="1400" dirty="0"/>
-          </a:p>
-        </p:txBody>
-      </p:sp>
-      <p:sp>
-        <p:nvSpPr>
-          <p:cNvPr id="9" name="Text 7"/>
-          <p:cNvSpPr/>
-          <p:nvPr/>
-        </p:nvSpPr>
-        <p:spPr>
-          <a:xfrm>
-            <a:off x="6858000" y="3017520"/>
-            <a:ext cx="4114800" cy="457200"/>
-          </a:xfrm>
-          <a:prstGeom prst="rect">
-            <a:avLst/>
-          </a:prstGeom>
-          <a:noFill/>
-          <a:ln/>
-        </p:spPr>
-        <p:txBody>
-          <a:bodyPr wrap="square" rtlCol="0" anchor="ctr"/>
-          <a:lstStyle/>
-          <a:p>
-            <a:pPr indent="0" marL="0">
-              <a:buNone/>
-            </a:pPr>
-            <a:r>
-              <a:rPr lang="en-US" sz="1400" dirty="0">
-                <a:solidFill>
-                  <a:srgbClr val="C9D1D9"/>
-                </a:solidFill>
-                <a:latin typeface="Arial" pitchFamily="34" charset="0"/>
-                <a:ea typeface="Arial" pitchFamily="34" charset="-122"/>
-                <a:cs typeface="Arial" pitchFamily="34" charset="-120"/>
-              </a:rPr>
-              <a:t>▸ FAISS vector index (160KB)</a:t>
-            </a:r>
-            <a:endParaRPr lang="en-US" sz="1400" dirty="0"/>
-          </a:p>
-        </p:txBody>
-      </p:sp>
-      <p:sp>
-        <p:nvSpPr>
-          <p:cNvPr id="10" name="Text 8"/>
-          <p:cNvSpPr/>
-          <p:nvPr/>
-        </p:nvSpPr>
-        <p:spPr>
-          <a:xfrm>
-            <a:off x="6858000" y="3520440"/>
-            <a:ext cx="4114800" cy="457200"/>
-          </a:xfrm>
-          <a:prstGeom prst="rect">
-            <a:avLst/>
-          </a:prstGeom>
-          <a:noFill/>
-          <a:ln/>
-        </p:spPr>
-        <p:txBody>
-          <a:bodyPr wrap="square" rtlCol="0" anchor="ctr"/>
-          <a:lstStyle/>
-          <a:p>
-            <a:pPr indent="0" marL="0">
-              <a:buNone/>
-            </a:pPr>
-            <a:r>
-              <a:rPr lang="en-US" sz="1400" dirty="0">
-                <a:solidFill>
-                  <a:srgbClr val="C9D1D9"/>
-                </a:solidFill>
-                <a:latin typeface="Arial" pitchFamily="34" charset="0"/>
-                <a:ea typeface="Arial" pitchFamily="34" charset="-122"/>
-                <a:cs typeface="Arial" pitchFamily="34" charset="-120"/>
-              </a:rPr>
-              <a:t>▸ NVL72-specific documentation</a:t>
-            </a:r>
-            <a:endParaRPr lang="en-US" sz="1400" dirty="0"/>
-          </a:p>
-        </p:txBody>
-      </p:sp>
-      <p:sp>
-        <p:nvSpPr>
-          <p:cNvPr id="11" name="Text 9"/>
-          <p:cNvSpPr/>
-          <p:nvPr/>
-        </p:nvSpPr>
-        <p:spPr>
-          <a:xfrm>
-            <a:off x="6858000" y="4023360"/>
-            <a:ext cx="4114800" cy="457200"/>
-          </a:xfrm>
-          <a:prstGeom prst="rect">
-            <a:avLst/>
-          </a:prstGeom>
-          <a:noFill/>
-          <a:ln/>
-        </p:spPr>
-        <p:txBody>
-          <a:bodyPr wrap="square" rtlCol="0" anchor="ctr"/>
-          <a:lstStyle/>
-          <a:p>
-            <a:pPr indent="0" marL="0">
-              <a:buNone/>
-            </a:pPr>
-            <a:r>
-              <a:rPr lang="en-US" sz="1400" dirty="0">
-                <a:solidFill>
-                  <a:srgbClr val="C9D1D9"/>
-                </a:solidFill>
-                <a:latin typeface="Arial" pitchFamily="34" charset="0"/>
-                <a:ea typeface="Arial" pitchFamily="34" charset="-122"/>
-                <a:cs typeface="Arial" pitchFamily="34" charset="-120"/>
-              </a:rPr>
-              <a:t>▸ All on-device, zero cloud</a:t>
-            </a:r>
-            <a:endParaRPr lang="en-US" sz="1400" dirty="0"/>
           </a:p>
         </p:txBody>
       </p:sp>
@@ -2738,7 +2491,7 @@
                 <a:ea typeface="Arial Black" pitchFamily="34" charset="-122"/>
                 <a:cs typeface="Arial Black" pitchFamily="34" charset="-120"/>
               </a:rPr>
-              <a:t>CPU vs NPU COMPARISON</a:t>
+              <a:t>RAG KNOWLEDGE OVERLAY</a:t>
             </a:r>
             <a:endParaRPr lang="en-US" sz="3600" dirty="0"/>
           </a:p>
@@ -2746,187 +2499,30 @@
       </p:sp>
       <p:sp>
         <p:nvSpPr>
-          <p:cNvPr id="3" name="Shape 1"/>
-          <p:cNvSpPr/>
-          <p:nvPr/>
-        </p:nvSpPr>
-        <p:spPr>
-          <a:xfrm>
-            <a:off x="731520" y="1188720"/>
-            <a:ext cx="10424160" cy="502920"/>
-          </a:xfrm>
-          <a:prstGeom prst="rect">
-            <a:avLst/>
-          </a:prstGeom>
-          <a:solidFill>
-            <a:srgbClr val="1E2761"/>
-          </a:solidFill>
-          <a:ln/>
-        </p:spPr>
-      </p:sp>
-      <p:sp>
-        <p:nvSpPr>
-          <p:cNvPr id="4" name="Text 2"/>
-          <p:cNvSpPr/>
-          <p:nvPr/>
-        </p:nvSpPr>
-        <p:spPr>
-          <a:xfrm>
-            <a:off x="822960" y="1188720"/>
-            <a:ext cx="3200400" cy="502920"/>
-          </a:xfrm>
-          <a:prstGeom prst="rect">
-            <a:avLst/>
-          </a:prstGeom>
-          <a:noFill/>
-          <a:ln/>
-        </p:spPr>
-        <p:txBody>
-          <a:bodyPr wrap="square" rtlCol="0" anchor="ctr"/>
-          <a:lstStyle/>
-          <a:p>
-            <a:pPr indent="0" marL="0">
-              <a:buNone/>
-            </a:pPr>
-            <a:r>
-              <a:rPr lang="en-US" sz="1400" b="1" dirty="0">
-                <a:solidFill>
-                  <a:srgbClr val="00E676"/>
-                </a:solidFill>
-                <a:latin typeface="Arial" pitchFamily="34" charset="0"/>
-                <a:ea typeface="Arial" pitchFamily="34" charset="-122"/>
-                <a:cs typeface="Arial" pitchFamily="34" charset="-120"/>
-              </a:rPr>
-              <a:t>Backend</a:t>
-            </a:r>
-            <a:endParaRPr lang="en-US" sz="1400" dirty="0"/>
-          </a:p>
-        </p:txBody>
-      </p:sp>
-      <p:sp>
-        <p:nvSpPr>
-          <p:cNvPr id="5" name="Text 3"/>
-          <p:cNvSpPr/>
-          <p:nvPr/>
-        </p:nvSpPr>
-        <p:spPr>
-          <a:xfrm>
-            <a:off x="4114800" y="1188720"/>
-            <a:ext cx="3200400" cy="502920"/>
-          </a:xfrm>
-          <a:prstGeom prst="rect">
-            <a:avLst/>
-          </a:prstGeom>
-          <a:noFill/>
-          <a:ln/>
-        </p:spPr>
-        <p:txBody>
-          <a:bodyPr wrap="square" rtlCol="0" anchor="ctr"/>
-          <a:lstStyle/>
-          <a:p>
-            <a:pPr indent="0" marL="0">
-              <a:buNone/>
-            </a:pPr>
-            <a:r>
-              <a:rPr lang="en-US" sz="1400" b="1" dirty="0">
-                <a:solidFill>
-                  <a:srgbClr val="00E676"/>
-                </a:solidFill>
-                <a:latin typeface="Arial" pitchFamily="34" charset="0"/>
-                <a:ea typeface="Arial" pitchFamily="34" charset="-122"/>
-                <a:cs typeface="Arial" pitchFamily="34" charset="-120"/>
-              </a:rPr>
-              <a:t>XNNPACK (CPU)</a:t>
-            </a:r>
-            <a:endParaRPr lang="en-US" sz="1400" dirty="0"/>
-          </a:p>
-        </p:txBody>
-      </p:sp>
-      <p:sp>
-        <p:nvSpPr>
-          <p:cNvPr id="6" name="Text 4"/>
-          <p:cNvSpPr/>
-          <p:nvPr/>
-        </p:nvSpPr>
-        <p:spPr>
-          <a:xfrm>
-            <a:off x="7315200" y="1188720"/>
-            <a:ext cx="3657600" cy="502920"/>
-          </a:xfrm>
-          <a:prstGeom prst="rect">
-            <a:avLst/>
-          </a:prstGeom>
-          <a:noFill/>
-          <a:ln/>
-        </p:spPr>
-        <p:txBody>
-          <a:bodyPr wrap="square" rtlCol="0" anchor="ctr"/>
-          <a:lstStyle/>
-          <a:p>
-            <a:pPr indent="0" marL="0">
-              <a:buNone/>
-            </a:pPr>
-            <a:r>
-              <a:rPr lang="en-US" sz="1400" b="1" dirty="0">
-                <a:solidFill>
-                  <a:srgbClr val="00E676"/>
-                </a:solidFill>
-                <a:latin typeface="Arial" pitchFamily="34" charset="0"/>
-                <a:ea typeface="Arial" pitchFamily="34" charset="-122"/>
-                <a:cs typeface="Arial" pitchFamily="34" charset="-120"/>
-              </a:rPr>
-              <a:t>QNN HTP (NPU)</a:t>
-            </a:r>
-            <a:endParaRPr lang="en-US" sz="1400" dirty="0"/>
-          </a:p>
-        </p:txBody>
-      </p:sp>
-      <p:sp>
-        <p:nvSpPr>
-          <p:cNvPr id="7" name="Shape 5"/>
-          <p:cNvSpPr/>
-          <p:nvPr/>
-        </p:nvSpPr>
-        <p:spPr>
-          <a:xfrm>
-            <a:off x="731520" y="1719072"/>
-            <a:ext cx="10424160" cy="502920"/>
-          </a:xfrm>
-          <a:prstGeom prst="rect">
-            <a:avLst/>
-          </a:prstGeom>
-          <a:solidFill>
-            <a:srgbClr val="0D1117"/>
-          </a:solidFill>
-          <a:ln/>
-        </p:spPr>
-      </p:sp>
-      <p:sp>
-        <p:nvSpPr>
-          <p:cNvPr id="8" name="Text 6"/>
-          <p:cNvSpPr/>
-          <p:nvPr/>
-        </p:nvSpPr>
-        <p:spPr>
-          <a:xfrm>
-            <a:off x="822960" y="1719072"/>
-            <a:ext cx="3200400" cy="502920"/>
-          </a:xfrm>
-          <a:prstGeom prst="rect">
-            <a:avLst/>
-          </a:prstGeom>
-          <a:noFill/>
-          <a:ln/>
-        </p:spPr>
-        <p:txBody>
-          <a:bodyPr wrap="square" rtlCol="0" anchor="ctr"/>
-          <a:lstStyle/>
-          <a:p>
-            <a:pPr indent="0" marL="0">
-              <a:buNone/>
-            </a:pPr>
-            <a:r>
-              <a:rPr lang="en-US" sz="1400" dirty="0">
+          <p:cNvPr id="3" name="Text 1"/>
+          <p:cNvSpPr/>
+          <p:nvPr/>
+        </p:nvSpPr>
+        <p:spPr>
+          <a:xfrm>
+            <a:off x="731520" y="1097280"/>
+            <a:ext cx="10058400" cy="457200"/>
+          </a:xfrm>
+          <a:prstGeom prst="rect">
+            <a:avLst/>
+          </a:prstGeom>
+          <a:noFill/>
+          <a:ln/>
+        </p:spPr>
+        <p:txBody>
+          <a:bodyPr wrap="square" rtlCol="0" anchor="ctr"/>
+          <a:lstStyle/>
+          <a:p>
+            <a:pPr indent="0" marL="0">
+              <a:buNone/>
+            </a:pPr>
+            <a:r>
+              <a:rPr lang="en-US" sz="1800" dirty="0">
                 <a:solidFill>
                   <a:srgbClr val="FFFFFF"/>
                 </a:solidFill>
@@ -2934,120 +2530,248 @@
                 <a:ea typeface="Arial" pitchFamily="34" charset="-122"/>
                 <a:cs typeface="Arial" pitchFamily="34" charset="-120"/>
               </a:rPr>
-              <a:t>Model</a:t>
-            </a:r>
-            <a:endParaRPr lang="en-US" sz="1400" dirty="0"/>
-          </a:p>
-        </p:txBody>
-      </p:sp>
-      <p:sp>
-        <p:nvSpPr>
-          <p:cNvPr id="9" name="Text 7"/>
-          <p:cNvSpPr/>
-          <p:nvPr/>
-        </p:nvSpPr>
-        <p:spPr>
-          <a:xfrm>
-            <a:off x="4114800" y="1719072"/>
-            <a:ext cx="3200400" cy="502920"/>
-          </a:xfrm>
-          <a:prstGeom prst="rect">
-            <a:avLst/>
-          </a:prstGeom>
-          <a:noFill/>
-          <a:ln/>
-        </p:spPr>
-        <p:txBody>
-          <a:bodyPr wrap="square" rtlCol="0" anchor="ctr"/>
-          <a:lstStyle/>
-          <a:p>
-            <a:pPr indent="0" marL="0">
-              <a:buNone/>
-            </a:pPr>
-            <a:r>
-              <a:rPr lang="en-US" sz="1400" dirty="0">
-                <a:solidFill>
-                  <a:srgbClr val="8B949E"/>
-                </a:solidFill>
-                <a:latin typeface="Arial" pitchFamily="34" charset="0"/>
-                <a:ea typeface="Arial" pitchFamily="34" charset="-122"/>
-                <a:cs typeface="Arial" pitchFamily="34" charset="-120"/>
-              </a:rPr>
-              <a:t>YOLOv8n-seg</a:t>
-            </a:r>
-            <a:endParaRPr lang="en-US" sz="1400" dirty="0"/>
-          </a:p>
-        </p:txBody>
-      </p:sp>
-      <p:sp>
-        <p:nvSpPr>
-          <p:cNvPr id="10" name="Text 8"/>
-          <p:cNvSpPr/>
-          <p:nvPr/>
-        </p:nvSpPr>
-        <p:spPr>
-          <a:xfrm>
-            <a:off x="7315200" y="1719072"/>
-            <a:ext cx="3657600" cy="502920"/>
-          </a:xfrm>
-          <a:prstGeom prst="rect">
-            <a:avLst/>
-          </a:prstGeom>
-          <a:noFill/>
-          <a:ln/>
-        </p:spPr>
-        <p:txBody>
-          <a:bodyPr wrap="square" rtlCol="0" anchor="ctr"/>
-          <a:lstStyle/>
-          <a:p>
-            <a:pPr indent="0" marL="0">
-              <a:buNone/>
-            </a:pPr>
-            <a:r>
-              <a:rPr lang="en-US" sz="1400" b="1" dirty="0">
-                <a:solidFill>
-                  <a:srgbClr val="00E676"/>
-                </a:solidFill>
-                <a:latin typeface="Arial" pitchFamily="34" charset="0"/>
-                <a:ea typeface="Arial" pitchFamily="34" charset="-122"/>
-                <a:cs typeface="Arial" pitchFamily="34" charset="-120"/>
-              </a:rPr>
-              <a:t>RetinaNet</a:t>
-            </a:r>
-            <a:endParaRPr lang="en-US" sz="1400" dirty="0"/>
-          </a:p>
-        </p:txBody>
-      </p:sp>
-      <p:sp>
-        <p:nvSpPr>
-          <p:cNvPr id="11" name="Shape 9"/>
-          <p:cNvSpPr/>
-          <p:nvPr/>
-        </p:nvSpPr>
-        <p:spPr>
-          <a:xfrm>
-            <a:off x="731520" y="2249424"/>
-            <a:ext cx="10424160" cy="502920"/>
-          </a:xfrm>
-          <a:prstGeom prst="rect">
-            <a:avLst/>
+              <a:t>Detect → Embed → Retrieve → Display</a:t>
+            </a:r>
+            <a:endParaRPr lang="en-US" sz="1800" dirty="0"/>
+          </a:p>
+        </p:txBody>
+      </p:sp>
+      <p:sp>
+        <p:nvSpPr>
+          <p:cNvPr id="4" name="Shape 2"/>
+          <p:cNvSpPr/>
+          <p:nvPr/>
+        </p:nvSpPr>
+        <p:spPr>
+          <a:xfrm>
+            <a:off x="1371600" y="1828800"/>
+            <a:ext cx="5029200" cy="3200400"/>
+          </a:xfrm>
+          <a:prstGeom prst="roundRect">
+            <a:avLst>
+              <a:gd name="adj" fmla="val 4286"/>
+            </a:avLst>
           </a:prstGeom>
           <a:solidFill>
             <a:srgbClr val="161B22"/>
           </a:solidFill>
-          <a:ln/>
-        </p:spPr>
-      </p:sp>
-      <p:sp>
-        <p:nvSpPr>
-          <p:cNvPr id="12" name="Text 10"/>
-          <p:cNvSpPr/>
-          <p:nvPr/>
-        </p:nvSpPr>
-        <p:spPr>
-          <a:xfrm>
-            <a:off x="822960" y="2249424"/>
-            <a:ext cx="3200400" cy="502920"/>
+          <a:ln w="25400">
+            <a:solidFill>
+              <a:srgbClr val="00E676"/>
+            </a:solidFill>
+            <a:prstDash val="solid"/>
+          </a:ln>
+        </p:spPr>
+      </p:sp>
+      <p:sp>
+        <p:nvSpPr>
+          <p:cNvPr id="5" name="Text 3"/>
+          <p:cNvSpPr/>
+          <p:nvPr/>
+        </p:nvSpPr>
+        <p:spPr>
+          <a:xfrm>
+            <a:off x="1554480" y="1920240"/>
+            <a:ext cx="4663440" cy="457200"/>
+          </a:xfrm>
+          <a:prstGeom prst="rect">
+            <a:avLst/>
+          </a:prstGeom>
+          <a:noFill/>
+          <a:ln/>
+        </p:spPr>
+        <p:txBody>
+          <a:bodyPr wrap="square" rtlCol="0" anchor="ctr"/>
+          <a:lstStyle/>
+          <a:p>
+            <a:pPr indent="0" marL="0">
+              <a:buNone/>
+            </a:pPr>
+            <a:r>
+              <a:rPr lang="en-US" sz="1600" b="1" dirty="0">
+                <a:solidFill>
+                  <a:srgbClr val="00E676"/>
+                </a:solidFill>
+                <a:latin typeface="Consolas" pitchFamily="34" charset="0"/>
+                <a:ea typeface="Consolas" pitchFamily="34" charset="-122"/>
+                <a:cs typeface="Consolas" pitchFamily="34" charset="-120"/>
+              </a:rPr>
+              <a:t>COMPUTE TRAY                           92%</a:t>
+            </a:r>
+            <a:endParaRPr lang="en-US" sz="1600" dirty="0"/>
+          </a:p>
+        </p:txBody>
+      </p:sp>
+      <p:sp>
+        <p:nvSpPr>
+          <p:cNvPr id="6" name="Text 4"/>
+          <p:cNvSpPr/>
+          <p:nvPr/>
+        </p:nvSpPr>
+        <p:spPr>
+          <a:xfrm>
+            <a:off x="1554480" y="2468880"/>
+            <a:ext cx="4663440" cy="2377440"/>
+          </a:xfrm>
+          <a:prstGeom prst="rect">
+            <a:avLst/>
+          </a:prstGeom>
+          <a:noFill/>
+          <a:ln/>
+        </p:spPr>
+        <p:txBody>
+          <a:bodyPr wrap="square" rtlCol="0" anchor="ctr"/>
+          <a:lstStyle/>
+          <a:p>
+            <a:pPr indent="0" marL="0">
+              <a:lnSpc>
+                <a:spcPct val="130000"/>
+              </a:lnSpc>
+              <a:buNone/>
+            </a:pPr>
+            <a:r>
+              <a:rPr lang="en-US" sz="1300" dirty="0">
+                <a:solidFill>
+                  <a:srgbClr val="C9D1D9"/>
+                </a:solidFill>
+                <a:latin typeface="Consolas" pitchFamily="34" charset="0"/>
+                <a:ea typeface="Consolas" pitchFamily="34" charset="-122"/>
+                <a:cs typeface="Consolas" pitchFamily="34" charset="-120"/>
+              </a:rPr>
+              <a:t>⚙️  2x Grace CPU, 4x B200 GPU, 192GB HBM3e</a:t>
+            </a:r>
+            <a:endParaRPr lang="en-US" sz="1300" dirty="0"/>
+          </a:p>
+          <a:p>
+            <a:pPr indent="0" marL="0">
+              <a:lnSpc>
+                <a:spcPct val="130000"/>
+              </a:lnSpc>
+              <a:buNone/>
+            </a:pPr>
+            <a:endParaRPr lang="en-US" sz="1300" dirty="0"/>
+          </a:p>
+          <a:p>
+            <a:pPr indent="0" marL="0">
+              <a:lnSpc>
+                <a:spcPct val="130000"/>
+              </a:lnSpc>
+              <a:buNone/>
+            </a:pPr>
+            <a:r>
+              <a:rPr lang="en-US" sz="1300" dirty="0">
+                <a:solidFill>
+                  <a:srgbClr val="C9D1D9"/>
+                </a:solidFill>
+                <a:latin typeface="Consolas" pitchFamily="34" charset="0"/>
+                <a:ea typeface="Consolas" pitchFamily="34" charset="-122"/>
+                <a:cs typeface="Consolas" pitchFamily="34" charset="-120"/>
+              </a:rPr>
+              <a:t>🟢  Green LED = healthy and operational</a:t>
+            </a:r>
+            <a:endParaRPr lang="en-US" sz="1300" dirty="0"/>
+          </a:p>
+          <a:p>
+            <a:pPr indent="0" marL="0">
+              <a:lnSpc>
+                <a:spcPct val="130000"/>
+              </a:lnSpc>
+              <a:buNone/>
+            </a:pPr>
+            <a:r>
+              <a:rPr lang="en-US" sz="1300" dirty="0">
+                <a:solidFill>
+                  <a:srgbClr val="C9D1D9"/>
+                </a:solidFill>
+                <a:latin typeface="Consolas" pitchFamily="34" charset="0"/>
+                <a:ea typeface="Consolas" pitchFamily="34" charset="-122"/>
+                <a:cs typeface="Consolas" pitchFamily="34" charset="-120"/>
+              </a:rPr>
+              <a:t>🟡  Amber LED = check BMC log, verify coolant</a:t>
+            </a:r>
+            <a:endParaRPr lang="en-US" sz="1300" dirty="0"/>
+          </a:p>
+          <a:p>
+            <a:pPr indent="0" marL="0">
+              <a:lnSpc>
+                <a:spcPct val="130000"/>
+              </a:lnSpc>
+              <a:buNone/>
+            </a:pPr>
+            <a:r>
+              <a:rPr lang="en-US" sz="1300" dirty="0">
+                <a:solidFill>
+                  <a:srgbClr val="C9D1D9"/>
+                </a:solidFill>
+                <a:latin typeface="Consolas" pitchFamily="34" charset="0"/>
+                <a:ea typeface="Consolas" pitchFamily="34" charset="-122"/>
+                <a:cs typeface="Consolas" pitchFamily="34" charset="-120"/>
+              </a:rPr>
+              <a:t>🔴  Red LED = critical hardware failure</a:t>
+            </a:r>
+            <a:endParaRPr lang="en-US" sz="1300" dirty="0"/>
+          </a:p>
+          <a:p>
+            <a:pPr indent="0" marL="0">
+              <a:lnSpc>
+                <a:spcPct val="130000"/>
+              </a:lnSpc>
+              <a:buNone/>
+            </a:pPr>
+            <a:endParaRPr lang="en-US" sz="1300" dirty="0"/>
+          </a:p>
+          <a:p>
+            <a:pPr indent="0" marL="0">
+              <a:lnSpc>
+                <a:spcPct val="130000"/>
+              </a:lnSpc>
+              <a:buNone/>
+            </a:pPr>
+            <a:r>
+              <a:rPr lang="en-US" sz="1300" dirty="0">
+                <a:solidFill>
+                  <a:srgbClr val="C9D1D9"/>
+                </a:solidFill>
+                <a:latin typeface="Consolas" pitchFamily="34" charset="0"/>
+                <a:ea typeface="Consolas" pitchFamily="34" charset="-122"/>
+                <a:cs typeface="Consolas" pitchFamily="34" charset="-120"/>
+              </a:rPr>
+              <a:t>🔧  Maintenance: check cold plate contact,</a:t>
+            </a:r>
+            <a:endParaRPr lang="en-US" sz="1300" dirty="0"/>
+          </a:p>
+          <a:p>
+            <a:pPr indent="0" marL="0">
+              <a:lnSpc>
+                <a:spcPct val="130000"/>
+              </a:lnSpc>
+              <a:buNone/>
+            </a:pPr>
+            <a:r>
+              <a:rPr lang="en-US" sz="1300" dirty="0">
+                <a:solidFill>
+                  <a:srgbClr val="C9D1D9"/>
+                </a:solidFill>
+                <a:latin typeface="Consolas" pitchFamily="34" charset="0"/>
+                <a:ea typeface="Consolas" pitchFamily="34" charset="-122"/>
+                <a:cs typeface="Consolas" pitchFamily="34" charset="-120"/>
+              </a:rPr>
+              <a:t>     verify NVLink connector seating</a:t>
+            </a:r>
+            <a:endParaRPr lang="en-US" sz="1300" dirty="0"/>
+          </a:p>
+        </p:txBody>
+      </p:sp>
+      <p:sp>
+        <p:nvSpPr>
+          <p:cNvPr id="7" name="Text 5"/>
+          <p:cNvSpPr/>
+          <p:nvPr/>
+        </p:nvSpPr>
+        <p:spPr>
+          <a:xfrm>
+            <a:off x="6858000" y="2011680"/>
+            <a:ext cx="4114800" cy="457200"/>
           </a:xfrm>
           <a:prstGeom prst="rect">
             <a:avLst/>
@@ -3065,13 +2789,13 @@
             <a:r>
               <a:rPr lang="en-US" sz="1400" dirty="0">
                 <a:solidFill>
-                  <a:srgbClr val="FFFFFF"/>
-                </a:solidFill>
-                <a:latin typeface="Arial" pitchFamily="34" charset="0"/>
-                <a:ea typeface="Arial" pitchFamily="34" charset="-122"/>
-                <a:cs typeface="Arial" pitchFamily="34" charset="-120"/>
-              </a:rPr>
-              <a:t>Size</a:t>
+                  <a:srgbClr val="C9D1D9"/>
+                </a:solidFill>
+                <a:latin typeface="Arial" pitchFamily="34" charset="0"/>
+                <a:ea typeface="Arial" pitchFamily="34" charset="-122"/>
+                <a:cs typeface="Arial" pitchFamily="34" charset="-120"/>
+              </a:rPr>
+              <a:t>▸ 80 knowledge chunks</a:t>
             </a:r>
             <a:endParaRPr lang="en-US" sz="1400" dirty="0"/>
           </a:p>
@@ -3079,14 +2803,14 @@
       </p:sp>
       <p:sp>
         <p:nvSpPr>
-          <p:cNvPr id="13" name="Text 11"/>
-          <p:cNvSpPr/>
-          <p:nvPr/>
-        </p:nvSpPr>
-        <p:spPr>
-          <a:xfrm>
-            <a:off x="4114800" y="2249424"/>
-            <a:ext cx="3200400" cy="502920"/>
+          <p:cNvPr id="8" name="Text 6"/>
+          <p:cNvSpPr/>
+          <p:nvPr/>
+        </p:nvSpPr>
+        <p:spPr>
+          <a:xfrm>
+            <a:off x="6858000" y="2514600"/>
+            <a:ext cx="4114800" cy="457200"/>
           </a:xfrm>
           <a:prstGeom prst="rect">
             <a:avLst/>
@@ -3104,13 +2828,13 @@
             <a:r>
               <a:rPr lang="en-US" sz="1400" dirty="0">
                 <a:solidFill>
-                  <a:srgbClr val="8B949E"/>
-                </a:solidFill>
-                <a:latin typeface="Arial" pitchFamily="34" charset="0"/>
-                <a:ea typeface="Arial" pitchFamily="34" charset="-122"/>
-                <a:cs typeface="Arial" pitchFamily="34" charset="-120"/>
-              </a:rPr>
-              <a:t>13 MB</a:t>
+                  <a:srgbClr val="C9D1D9"/>
+                </a:solidFill>
+                <a:latin typeface="Arial" pitchFamily="34" charset="0"/>
+                <a:ea typeface="Arial" pitchFamily="34" charset="-122"/>
+                <a:cs typeface="Arial" pitchFamily="34" charset="-120"/>
+              </a:rPr>
+              <a:t>▸ CLIP ViT-B-32 embeddings</a:t>
             </a:r>
             <a:endParaRPr lang="en-US" sz="1400" dirty="0"/>
           </a:p>
@@ -3118,38 +2842,38 @@
       </p:sp>
       <p:sp>
         <p:nvSpPr>
-          <p:cNvPr id="14" name="Text 12"/>
-          <p:cNvSpPr/>
-          <p:nvPr/>
-        </p:nvSpPr>
-        <p:spPr>
-          <a:xfrm>
-            <a:off x="7315200" y="2249424"/>
-            <a:ext cx="3657600" cy="502920"/>
-          </a:xfrm>
-          <a:prstGeom prst="rect">
-            <a:avLst/>
-          </a:prstGeom>
-          <a:noFill/>
-          <a:ln/>
-        </p:spPr>
-        <p:txBody>
-          <a:bodyPr wrap="square" rtlCol="0" anchor="ctr"/>
-          <a:lstStyle/>
-          <a:p>
-            <a:pPr indent="0" marL="0">
-              <a:buNone/>
-            </a:pPr>
-            <a:r>
-              <a:rPr lang="en-US" sz="1400" b="1" dirty="0">
-                <a:solidFill>
-                  <a:srgbClr val="00E676"/>
-                </a:solidFill>
-                <a:latin typeface="Arial" pitchFamily="34" charset="0"/>
-                <a:ea typeface="Arial" pitchFamily="34" charset="-122"/>
-                <a:cs typeface="Arial" pitchFamily="34" charset="-120"/>
-              </a:rPr>
-              <a:t>36 MB</a:t>
+          <p:cNvPr id="9" name="Text 7"/>
+          <p:cNvSpPr/>
+          <p:nvPr/>
+        </p:nvSpPr>
+        <p:spPr>
+          <a:xfrm>
+            <a:off x="6858000" y="3017520"/>
+            <a:ext cx="4114800" cy="457200"/>
+          </a:xfrm>
+          <a:prstGeom prst="rect">
+            <a:avLst/>
+          </a:prstGeom>
+          <a:noFill/>
+          <a:ln/>
+        </p:spPr>
+        <p:txBody>
+          <a:bodyPr wrap="square" rtlCol="0" anchor="ctr"/>
+          <a:lstStyle/>
+          <a:p>
+            <a:pPr indent="0" marL="0">
+              <a:buNone/>
+            </a:pPr>
+            <a:r>
+              <a:rPr lang="en-US" sz="1400" dirty="0">
+                <a:solidFill>
+                  <a:srgbClr val="C9D1D9"/>
+                </a:solidFill>
+                <a:latin typeface="Arial" pitchFamily="34" charset="0"/>
+                <a:ea typeface="Arial" pitchFamily="34" charset="-122"/>
+                <a:cs typeface="Arial" pitchFamily="34" charset="-120"/>
+              </a:rPr>
+              <a:t>▸ FAISS vector index (160KB)</a:t>
             </a:r>
             <a:endParaRPr lang="en-US" sz="1400" dirty="0"/>
           </a:p>
@@ -3157,34 +2881,14 @@
       </p:sp>
       <p:sp>
         <p:nvSpPr>
-          <p:cNvPr id="15" name="Shape 13"/>
-          <p:cNvSpPr/>
-          <p:nvPr/>
-        </p:nvSpPr>
-        <p:spPr>
-          <a:xfrm>
-            <a:off x="731520" y="2779776"/>
-            <a:ext cx="10424160" cy="502920"/>
-          </a:xfrm>
-          <a:prstGeom prst="rect">
-            <a:avLst/>
-          </a:prstGeom>
-          <a:solidFill>
-            <a:srgbClr val="0D1117"/>
-          </a:solidFill>
-          <a:ln/>
-        </p:spPr>
-      </p:sp>
-      <p:sp>
-        <p:nvSpPr>
-          <p:cNvPr id="16" name="Text 14"/>
-          <p:cNvSpPr/>
-          <p:nvPr/>
-        </p:nvSpPr>
-        <p:spPr>
-          <a:xfrm>
-            <a:off x="822960" y="2779776"/>
-            <a:ext cx="3200400" cy="502920"/>
+          <p:cNvPr id="10" name="Text 8"/>
+          <p:cNvSpPr/>
+          <p:nvPr/>
+        </p:nvSpPr>
+        <p:spPr>
+          <a:xfrm>
+            <a:off x="6858000" y="3520440"/>
+            <a:ext cx="4114800" cy="457200"/>
           </a:xfrm>
           <a:prstGeom prst="rect">
             <a:avLst/>
@@ -3202,13 +2906,13 @@
             <a:r>
               <a:rPr lang="en-US" sz="1400" dirty="0">
                 <a:solidFill>
-                  <a:srgbClr val="FFFFFF"/>
-                </a:solidFill>
-                <a:latin typeface="Arial" pitchFamily="34" charset="0"/>
-                <a:ea typeface="Arial" pitchFamily="34" charset="-122"/>
-                <a:cs typeface="Arial" pitchFamily="34" charset="-120"/>
-              </a:rPr>
-              <a:t>Quantization</a:t>
+                  <a:srgbClr val="C9D1D9"/>
+                </a:solidFill>
+                <a:latin typeface="Arial" pitchFamily="34" charset="0"/>
+                <a:ea typeface="Arial" pitchFamily="34" charset="-122"/>
+                <a:cs typeface="Arial" pitchFamily="34" charset="-120"/>
+              </a:rPr>
+              <a:t>▸ NVL72-specific documentation</a:t>
             </a:r>
             <a:endParaRPr lang="en-US" sz="1400" dirty="0"/>
           </a:p>
@@ -3216,14 +2920,14 @@
       </p:sp>
       <p:sp>
         <p:nvSpPr>
-          <p:cNvPr id="17" name="Text 15"/>
-          <p:cNvSpPr/>
-          <p:nvPr/>
-        </p:nvSpPr>
-        <p:spPr>
-          <a:xfrm>
-            <a:off x="4114800" y="2779776"/>
-            <a:ext cx="3200400" cy="502920"/>
+          <p:cNvPr id="11" name="Text 9"/>
+          <p:cNvSpPr/>
+          <p:nvPr/>
+        </p:nvSpPr>
+        <p:spPr>
+          <a:xfrm>
+            <a:off x="6858000" y="4023360"/>
+            <a:ext cx="4114800" cy="457200"/>
           </a:xfrm>
           <a:prstGeom prst="rect">
             <a:avLst/>
@@ -3241,600 +2945,13 @@
             <a:r>
               <a:rPr lang="en-US" sz="1400" dirty="0">
                 <a:solidFill>
-                  <a:srgbClr val="8B949E"/>
-                </a:solidFill>
-                <a:latin typeface="Arial" pitchFamily="34" charset="0"/>
-                <a:ea typeface="Arial" pitchFamily="34" charset="-122"/>
-                <a:cs typeface="Arial" pitchFamily="34" charset="-120"/>
-              </a:rPr>
-              <a:t>FP32</a:t>
-            </a:r>
-            <a:endParaRPr lang="en-US" sz="1400" dirty="0"/>
-          </a:p>
-        </p:txBody>
-      </p:sp>
-      <p:sp>
-        <p:nvSpPr>
-          <p:cNvPr id="18" name="Text 16"/>
-          <p:cNvSpPr/>
-          <p:nvPr/>
-        </p:nvSpPr>
-        <p:spPr>
-          <a:xfrm>
-            <a:off x="7315200" y="2779776"/>
-            <a:ext cx="3657600" cy="502920"/>
-          </a:xfrm>
-          <a:prstGeom prst="rect">
-            <a:avLst/>
-          </a:prstGeom>
-          <a:noFill/>
-          <a:ln/>
-        </p:spPr>
-        <p:txBody>
-          <a:bodyPr wrap="square" rtlCol="0" anchor="ctr"/>
-          <a:lstStyle/>
-          <a:p>
-            <a:pPr indent="0" marL="0">
-              <a:buNone/>
-            </a:pPr>
-            <a:r>
-              <a:rPr lang="en-US" sz="1400" b="1" dirty="0">
-                <a:solidFill>
-                  <a:srgbClr val="00E676"/>
-                </a:solidFill>
-                <a:latin typeface="Arial" pitchFamily="34" charset="0"/>
-                <a:ea typeface="Arial" pitchFamily="34" charset="-122"/>
-                <a:cs typeface="Arial" pitchFamily="34" charset="-120"/>
-              </a:rPr>
-              <a:t>INT8</a:t>
-            </a:r>
-            <a:endParaRPr lang="en-US" sz="1400" dirty="0"/>
-          </a:p>
-        </p:txBody>
-      </p:sp>
-      <p:sp>
-        <p:nvSpPr>
-          <p:cNvPr id="19" name="Shape 17"/>
-          <p:cNvSpPr/>
-          <p:nvPr/>
-        </p:nvSpPr>
-        <p:spPr>
-          <a:xfrm>
-            <a:off x="731520" y="3310128"/>
-            <a:ext cx="10424160" cy="502920"/>
-          </a:xfrm>
-          <a:prstGeom prst="rect">
-            <a:avLst/>
-          </a:prstGeom>
-          <a:solidFill>
-            <a:srgbClr val="161B22"/>
-          </a:solidFill>
-          <a:ln/>
-        </p:spPr>
-      </p:sp>
-      <p:sp>
-        <p:nvSpPr>
-          <p:cNvPr id="20" name="Text 18"/>
-          <p:cNvSpPr/>
-          <p:nvPr/>
-        </p:nvSpPr>
-        <p:spPr>
-          <a:xfrm>
-            <a:off x="822960" y="3310128"/>
-            <a:ext cx="3200400" cy="502920"/>
-          </a:xfrm>
-          <a:prstGeom prst="rect">
-            <a:avLst/>
-          </a:prstGeom>
-          <a:noFill/>
-          <a:ln/>
-        </p:spPr>
-        <p:txBody>
-          <a:bodyPr wrap="square" rtlCol="0" anchor="ctr"/>
-          <a:lstStyle/>
-          <a:p>
-            <a:pPr indent="0" marL="0">
-              <a:buNone/>
-            </a:pPr>
-            <a:r>
-              <a:rPr lang="en-US" sz="1400" dirty="0">
-                <a:solidFill>
-                  <a:srgbClr val="FFFFFF"/>
-                </a:solidFill>
-                <a:latin typeface="Arial" pitchFamily="34" charset="0"/>
-                <a:ea typeface="Arial" pitchFamily="34" charset="-122"/>
-                <a:cs typeface="Arial" pitchFamily="34" charset="-120"/>
-              </a:rPr>
-              <a:t>Est. Latency</a:t>
-            </a:r>
-            <a:endParaRPr lang="en-US" sz="1400" dirty="0"/>
-          </a:p>
-        </p:txBody>
-      </p:sp>
-      <p:sp>
-        <p:nvSpPr>
-          <p:cNvPr id="21" name="Text 19"/>
-          <p:cNvSpPr/>
-          <p:nvPr/>
-        </p:nvSpPr>
-        <p:spPr>
-          <a:xfrm>
-            <a:off x="4114800" y="3310128"/>
-            <a:ext cx="3200400" cy="502920"/>
-          </a:xfrm>
-          <a:prstGeom prst="rect">
-            <a:avLst/>
-          </a:prstGeom>
-          <a:noFill/>
-          <a:ln/>
-        </p:spPr>
-        <p:txBody>
-          <a:bodyPr wrap="square" rtlCol="0" anchor="ctr"/>
-          <a:lstStyle/>
-          <a:p>
-            <a:pPr indent="0" marL="0">
-              <a:buNone/>
-            </a:pPr>
-            <a:r>
-              <a:rPr lang="en-US" sz="1400" dirty="0">
-                <a:solidFill>
-                  <a:srgbClr val="8B949E"/>
-                </a:solidFill>
-                <a:latin typeface="Arial" pitchFamily="34" charset="0"/>
-                <a:ea typeface="Arial" pitchFamily="34" charset="-122"/>
-                <a:cs typeface="Arial" pitchFamily="34" charset="-120"/>
-              </a:rPr>
-              <a:t>~15-30ms</a:t>
-            </a:r>
-            <a:endParaRPr lang="en-US" sz="1400" dirty="0"/>
-          </a:p>
-        </p:txBody>
-      </p:sp>
-      <p:sp>
-        <p:nvSpPr>
-          <p:cNvPr id="22" name="Text 20"/>
-          <p:cNvSpPr/>
-          <p:nvPr/>
-        </p:nvSpPr>
-        <p:spPr>
-          <a:xfrm>
-            <a:off x="7315200" y="3310128"/>
-            <a:ext cx="3657600" cy="502920"/>
-          </a:xfrm>
-          <a:prstGeom prst="rect">
-            <a:avLst/>
-          </a:prstGeom>
-          <a:noFill/>
-          <a:ln/>
-        </p:spPr>
-        <p:txBody>
-          <a:bodyPr wrap="square" rtlCol="0" anchor="ctr"/>
-          <a:lstStyle/>
-          <a:p>
-            <a:pPr indent="0" marL="0">
-              <a:buNone/>
-            </a:pPr>
-            <a:r>
-              <a:rPr lang="en-US" sz="1400" b="1" dirty="0">
-                <a:solidFill>
-                  <a:srgbClr val="00E676"/>
-                </a:solidFill>
-                <a:latin typeface="Arial" pitchFamily="34" charset="0"/>
-                <a:ea typeface="Arial" pitchFamily="34" charset="-122"/>
-                <a:cs typeface="Arial" pitchFamily="34" charset="-120"/>
-              </a:rPr>
-              <a:t>~3-5ms</a:t>
-            </a:r>
-            <a:endParaRPr lang="en-US" sz="1400" dirty="0"/>
-          </a:p>
-        </p:txBody>
-      </p:sp>
-      <p:sp>
-        <p:nvSpPr>
-          <p:cNvPr id="23" name="Shape 21"/>
-          <p:cNvSpPr/>
-          <p:nvPr/>
-        </p:nvSpPr>
-        <p:spPr>
-          <a:xfrm>
-            <a:off x="731520" y="3840480"/>
-            <a:ext cx="10424160" cy="502920"/>
-          </a:xfrm>
-          <a:prstGeom prst="rect">
-            <a:avLst/>
-          </a:prstGeom>
-          <a:solidFill>
-            <a:srgbClr val="0D1117"/>
-          </a:solidFill>
-          <a:ln/>
-        </p:spPr>
-      </p:sp>
-      <p:sp>
-        <p:nvSpPr>
-          <p:cNvPr id="24" name="Text 22"/>
-          <p:cNvSpPr/>
-          <p:nvPr/>
-        </p:nvSpPr>
-        <p:spPr>
-          <a:xfrm>
-            <a:off x="822960" y="3840480"/>
-            <a:ext cx="3200400" cy="502920"/>
-          </a:xfrm>
-          <a:prstGeom prst="rect">
-            <a:avLst/>
-          </a:prstGeom>
-          <a:noFill/>
-          <a:ln/>
-        </p:spPr>
-        <p:txBody>
-          <a:bodyPr wrap="square" rtlCol="0" anchor="ctr"/>
-          <a:lstStyle/>
-          <a:p>
-            <a:pPr indent="0" marL="0">
-              <a:buNone/>
-            </a:pPr>
-            <a:r>
-              <a:rPr lang="en-US" sz="1400" dirty="0">
-                <a:solidFill>
-                  <a:srgbClr val="FFFFFF"/>
-                </a:solidFill>
-                <a:latin typeface="Arial" pitchFamily="34" charset="0"/>
-                <a:ea typeface="Arial" pitchFamily="34" charset="-122"/>
-                <a:cs typeface="Arial" pitchFamily="34" charset="-120"/>
-              </a:rPr>
-              <a:t>Est. FPS</a:t>
-            </a:r>
-            <a:endParaRPr lang="en-US" sz="1400" dirty="0"/>
-          </a:p>
-        </p:txBody>
-      </p:sp>
-      <p:sp>
-        <p:nvSpPr>
-          <p:cNvPr id="25" name="Text 23"/>
-          <p:cNvSpPr/>
-          <p:nvPr/>
-        </p:nvSpPr>
-        <p:spPr>
-          <a:xfrm>
-            <a:off x="4114800" y="3840480"/>
-            <a:ext cx="3200400" cy="502920"/>
-          </a:xfrm>
-          <a:prstGeom prst="rect">
-            <a:avLst/>
-          </a:prstGeom>
-          <a:noFill/>
-          <a:ln/>
-        </p:spPr>
-        <p:txBody>
-          <a:bodyPr wrap="square" rtlCol="0" anchor="ctr"/>
-          <a:lstStyle/>
-          <a:p>
-            <a:pPr indent="0" marL="0">
-              <a:buNone/>
-            </a:pPr>
-            <a:r>
-              <a:rPr lang="en-US" sz="1400" dirty="0">
-                <a:solidFill>
-                  <a:srgbClr val="8B949E"/>
-                </a:solidFill>
-                <a:latin typeface="Arial" pitchFamily="34" charset="0"/>
-                <a:ea typeface="Arial" pitchFamily="34" charset="-122"/>
-                <a:cs typeface="Arial" pitchFamily="34" charset="-120"/>
-              </a:rPr>
-              <a:t>~30-60</a:t>
-            </a:r>
-            <a:endParaRPr lang="en-US" sz="1400" dirty="0"/>
-          </a:p>
-        </p:txBody>
-      </p:sp>
-      <p:sp>
-        <p:nvSpPr>
-          <p:cNvPr id="26" name="Text 24"/>
-          <p:cNvSpPr/>
-          <p:nvPr/>
-        </p:nvSpPr>
-        <p:spPr>
-          <a:xfrm>
-            <a:off x="7315200" y="3840480"/>
-            <a:ext cx="3657600" cy="502920"/>
-          </a:xfrm>
-          <a:prstGeom prst="rect">
-            <a:avLst/>
-          </a:prstGeom>
-          <a:noFill/>
-          <a:ln/>
-        </p:spPr>
-        <p:txBody>
-          <a:bodyPr wrap="square" rtlCol="0" anchor="ctr"/>
-          <a:lstStyle/>
-          <a:p>
-            <a:pPr indent="0" marL="0">
-              <a:buNone/>
-            </a:pPr>
-            <a:r>
-              <a:rPr lang="en-US" sz="1400" b="1" dirty="0">
-                <a:solidFill>
-                  <a:srgbClr val="00E676"/>
-                </a:solidFill>
-                <a:latin typeface="Arial" pitchFamily="34" charset="0"/>
-                <a:ea typeface="Arial" pitchFamily="34" charset="-122"/>
-                <a:cs typeface="Arial" pitchFamily="34" charset="-120"/>
-              </a:rPr>
-              <a:t>~100+</a:t>
-            </a:r>
-            <a:endParaRPr lang="en-US" sz="1400" dirty="0"/>
-          </a:p>
-        </p:txBody>
-      </p:sp>
-      <p:sp>
-        <p:nvSpPr>
-          <p:cNvPr id="27" name="Shape 25"/>
-          <p:cNvSpPr/>
-          <p:nvPr/>
-        </p:nvSpPr>
-        <p:spPr>
-          <a:xfrm>
-            <a:off x="731520" y="4370832"/>
-            <a:ext cx="10424160" cy="502920"/>
-          </a:xfrm>
-          <a:prstGeom prst="rect">
-            <a:avLst/>
-          </a:prstGeom>
-          <a:solidFill>
-            <a:srgbClr val="161B22"/>
-          </a:solidFill>
-          <a:ln/>
-        </p:spPr>
-      </p:sp>
-      <p:sp>
-        <p:nvSpPr>
-          <p:cNvPr id="28" name="Text 26"/>
-          <p:cNvSpPr/>
-          <p:nvPr/>
-        </p:nvSpPr>
-        <p:spPr>
-          <a:xfrm>
-            <a:off x="822960" y="4370832"/>
-            <a:ext cx="3200400" cy="502920"/>
-          </a:xfrm>
-          <a:prstGeom prst="rect">
-            <a:avLst/>
-          </a:prstGeom>
-          <a:noFill/>
-          <a:ln/>
-        </p:spPr>
-        <p:txBody>
-          <a:bodyPr wrap="square" rtlCol="0" anchor="ctr"/>
-          <a:lstStyle/>
-          <a:p>
-            <a:pPr indent="0" marL="0">
-              <a:buNone/>
-            </a:pPr>
-            <a:r>
-              <a:rPr lang="en-US" sz="1400" dirty="0">
-                <a:solidFill>
-                  <a:srgbClr val="FFFFFF"/>
-                </a:solidFill>
-                <a:latin typeface="Arial" pitchFamily="34" charset="0"/>
-                <a:ea typeface="Arial" pitchFamily="34" charset="-122"/>
-                <a:cs typeface="Arial" pitchFamily="34" charset="-120"/>
-              </a:rPr>
-              <a:t>Power</a:t>
-            </a:r>
-            <a:endParaRPr lang="en-US" sz="1400" dirty="0"/>
-          </a:p>
-        </p:txBody>
-      </p:sp>
-      <p:sp>
-        <p:nvSpPr>
-          <p:cNvPr id="29" name="Text 27"/>
-          <p:cNvSpPr/>
-          <p:nvPr/>
-        </p:nvSpPr>
-        <p:spPr>
-          <a:xfrm>
-            <a:off x="4114800" y="4370832"/>
-            <a:ext cx="3200400" cy="502920"/>
-          </a:xfrm>
-          <a:prstGeom prst="rect">
-            <a:avLst/>
-          </a:prstGeom>
-          <a:noFill/>
-          <a:ln/>
-        </p:spPr>
-        <p:txBody>
-          <a:bodyPr wrap="square" rtlCol="0" anchor="ctr"/>
-          <a:lstStyle/>
-          <a:p>
-            <a:pPr indent="0" marL="0">
-              <a:buNone/>
-            </a:pPr>
-            <a:r>
-              <a:rPr lang="en-US" sz="1400" dirty="0">
-                <a:solidFill>
-                  <a:srgbClr val="8B949E"/>
-                </a:solidFill>
-                <a:latin typeface="Arial" pitchFamily="34" charset="0"/>
-                <a:ea typeface="Arial" pitchFamily="34" charset="-122"/>
-                <a:cs typeface="Arial" pitchFamily="34" charset="-120"/>
-              </a:rPr>
-              <a:t>Higher drain</a:t>
-            </a:r>
-            <a:endParaRPr lang="en-US" sz="1400" dirty="0"/>
-          </a:p>
-        </p:txBody>
-      </p:sp>
-      <p:sp>
-        <p:nvSpPr>
-          <p:cNvPr id="30" name="Text 28"/>
-          <p:cNvSpPr/>
-          <p:nvPr/>
-        </p:nvSpPr>
-        <p:spPr>
-          <a:xfrm>
-            <a:off x="7315200" y="4370832"/>
-            <a:ext cx="3657600" cy="502920"/>
-          </a:xfrm>
-          <a:prstGeom prst="rect">
-            <a:avLst/>
-          </a:prstGeom>
-          <a:noFill/>
-          <a:ln/>
-        </p:spPr>
-        <p:txBody>
-          <a:bodyPr wrap="square" rtlCol="0" anchor="ctr"/>
-          <a:lstStyle/>
-          <a:p>
-            <a:pPr indent="0" marL="0">
-              <a:buNone/>
-            </a:pPr>
-            <a:r>
-              <a:rPr lang="en-US" sz="1400" b="1" dirty="0">
-                <a:solidFill>
-                  <a:srgbClr val="00E676"/>
-                </a:solidFill>
-                <a:latin typeface="Arial" pitchFamily="34" charset="0"/>
-                <a:ea typeface="Arial" pitchFamily="34" charset="-122"/>
-                <a:cs typeface="Arial" pitchFamily="34" charset="-120"/>
-              </a:rPr>
-              <a:t>4-5x efficient</a:t>
-            </a:r>
-            <a:endParaRPr lang="en-US" sz="1400" dirty="0"/>
-          </a:p>
-        </p:txBody>
-      </p:sp>
-      <p:sp>
-        <p:nvSpPr>
-          <p:cNvPr id="31" name="Shape 29"/>
-          <p:cNvSpPr/>
-          <p:nvPr/>
-        </p:nvSpPr>
-        <p:spPr>
-          <a:xfrm>
-            <a:off x="731520" y="4901184"/>
-            <a:ext cx="10424160" cy="502920"/>
-          </a:xfrm>
-          <a:prstGeom prst="rect">
-            <a:avLst/>
-          </a:prstGeom>
-          <a:solidFill>
-            <a:srgbClr val="0D1117"/>
-          </a:solidFill>
-          <a:ln/>
-        </p:spPr>
-      </p:sp>
-      <p:sp>
-        <p:nvSpPr>
-          <p:cNvPr id="32" name="Text 30"/>
-          <p:cNvSpPr/>
-          <p:nvPr/>
-        </p:nvSpPr>
-        <p:spPr>
-          <a:xfrm>
-            <a:off x="822960" y="4901184"/>
-            <a:ext cx="3200400" cy="502920"/>
-          </a:xfrm>
-          <a:prstGeom prst="rect">
-            <a:avLst/>
-          </a:prstGeom>
-          <a:noFill/>
-          <a:ln/>
-        </p:spPr>
-        <p:txBody>
-          <a:bodyPr wrap="square" rtlCol="0" anchor="ctr"/>
-          <a:lstStyle/>
-          <a:p>
-            <a:pPr indent="0" marL="0">
-              <a:buNone/>
-            </a:pPr>
-            <a:r>
-              <a:rPr lang="en-US" sz="1400" dirty="0">
-                <a:solidFill>
-                  <a:srgbClr val="FFFFFF"/>
-                </a:solidFill>
-                <a:latin typeface="Arial" pitchFamily="34" charset="0"/>
-                <a:ea typeface="Arial" pitchFamily="34" charset="-122"/>
-                <a:cs typeface="Arial" pitchFamily="34" charset="-120"/>
-              </a:rPr>
-              <a:t>Hardware</a:t>
-            </a:r>
-            <a:endParaRPr lang="en-US" sz="1400" dirty="0"/>
-          </a:p>
-        </p:txBody>
-      </p:sp>
-      <p:sp>
-        <p:nvSpPr>
-          <p:cNvPr id="33" name="Text 31"/>
-          <p:cNvSpPr/>
-          <p:nvPr/>
-        </p:nvSpPr>
-        <p:spPr>
-          <a:xfrm>
-            <a:off x="4114800" y="4901184"/>
-            <a:ext cx="3200400" cy="502920"/>
-          </a:xfrm>
-          <a:prstGeom prst="rect">
-            <a:avLst/>
-          </a:prstGeom>
-          <a:noFill/>
-          <a:ln/>
-        </p:spPr>
-        <p:txBody>
-          <a:bodyPr wrap="square" rtlCol="0" anchor="ctr"/>
-          <a:lstStyle/>
-          <a:p>
-            <a:pPr indent="0" marL="0">
-              <a:buNone/>
-            </a:pPr>
-            <a:r>
-              <a:rPr lang="en-US" sz="1400" dirty="0">
-                <a:solidFill>
-                  <a:srgbClr val="8B949E"/>
-                </a:solidFill>
-                <a:latin typeface="Arial" pitchFamily="34" charset="0"/>
-                <a:ea typeface="Arial" pitchFamily="34" charset="-122"/>
-                <a:cs typeface="Arial" pitchFamily="34" charset="-120"/>
-              </a:rPr>
-              <a:t>ARM Kryo cores</a:t>
-            </a:r>
-            <a:endParaRPr lang="en-US" sz="1400" dirty="0"/>
-          </a:p>
-        </p:txBody>
-      </p:sp>
-      <p:sp>
-        <p:nvSpPr>
-          <p:cNvPr id="34" name="Text 32"/>
-          <p:cNvSpPr/>
-          <p:nvPr/>
-        </p:nvSpPr>
-        <p:spPr>
-          <a:xfrm>
-            <a:off x="7315200" y="4901184"/>
-            <a:ext cx="3657600" cy="502920"/>
-          </a:xfrm>
-          <a:prstGeom prst="rect">
-            <a:avLst/>
-          </a:prstGeom>
-          <a:noFill/>
-          <a:ln/>
-        </p:spPr>
-        <p:txBody>
-          <a:bodyPr wrap="square" rtlCol="0" anchor="ctr"/>
-          <a:lstStyle/>
-          <a:p>
-            <a:pPr indent="0" marL="0">
-              <a:buNone/>
-            </a:pPr>
-            <a:r>
-              <a:rPr lang="en-US" sz="1400" b="1" dirty="0">
-                <a:solidFill>
-                  <a:srgbClr val="00E676"/>
-                </a:solidFill>
-                <a:latin typeface="Arial" pitchFamily="34" charset="0"/>
-                <a:ea typeface="Arial" pitchFamily="34" charset="-122"/>
-                <a:cs typeface="Arial" pitchFamily="34" charset="-120"/>
-              </a:rPr>
-              <a:t>Hexagon HTP v79</a:t>
+                  <a:srgbClr val="C9D1D9"/>
+                </a:solidFill>
+                <a:latin typeface="Arial" pitchFamily="34" charset="0"/>
+                <a:ea typeface="Arial" pitchFamily="34" charset="-122"/>
+                <a:cs typeface="Arial" pitchFamily="34" charset="-120"/>
+              </a:rPr>
+              <a:t>▸ All on-device, zero cloud</a:t>
             </a:r>
             <a:endParaRPr lang="en-US" sz="1400" dirty="0"/>
           </a:p>
@@ -3905,7 +3022,7 @@
                 <a:ea typeface="Arial Black" pitchFamily="34" charset="-122"/>
                 <a:cs typeface="Arial Black" pitchFamily="34" charset="-120"/>
               </a:rPr>
-              <a:t>WHAT'S NEXT</a:t>
+              <a:t>CPU vs NPU COMPARISON</a:t>
             </a:r>
             <a:endParaRPr lang="en-US" sz="3600" dirty="0"/>
           </a:p>
@@ -3919,14 +3036,14 @@
         </p:nvSpPr>
         <p:spPr>
           <a:xfrm>
-            <a:off x="731520" y="1234440"/>
-            <a:ext cx="54864" cy="640080"/>
+            <a:off x="731520" y="1188720"/>
+            <a:ext cx="10424160" cy="502920"/>
           </a:xfrm>
           <a:prstGeom prst="rect">
             <a:avLst/>
           </a:prstGeom>
           <a:solidFill>
-            <a:srgbClr val="00E676"/>
+            <a:srgbClr val="1E2761"/>
           </a:solidFill>
           <a:ln/>
         </p:spPr>
@@ -3939,24 +3056,161 @@
         </p:nvSpPr>
         <p:spPr>
           <a:xfrm>
-            <a:off x="1097280" y="1188720"/>
-            <a:ext cx="9144000" cy="411480"/>
-          </a:xfrm>
-          <a:prstGeom prst="rect">
-            <a:avLst/>
-          </a:prstGeom>
-          <a:noFill/>
-          <a:ln/>
-        </p:spPr>
-        <p:txBody>
-          <a:bodyPr wrap="square" rtlCol="0" anchor="ctr"/>
-          <a:lstStyle/>
-          <a:p>
-            <a:pPr indent="0" marL="0">
-              <a:buNone/>
-            </a:pPr>
-            <a:r>
-              <a:rPr lang="en-US" sz="1800" b="1" dirty="0">
+            <a:off x="822960" y="1188720"/>
+            <a:ext cx="3200400" cy="502920"/>
+          </a:xfrm>
+          <a:prstGeom prst="rect">
+            <a:avLst/>
+          </a:prstGeom>
+          <a:noFill/>
+          <a:ln/>
+        </p:spPr>
+        <p:txBody>
+          <a:bodyPr wrap="square" rtlCol="0" anchor="ctr"/>
+          <a:lstStyle/>
+          <a:p>
+            <a:pPr indent="0" marL="0">
+              <a:buNone/>
+            </a:pPr>
+            <a:r>
+              <a:rPr lang="en-US" sz="1400" b="1" dirty="0">
+                <a:solidFill>
+                  <a:srgbClr val="00E676"/>
+                </a:solidFill>
+                <a:latin typeface="Arial" pitchFamily="34" charset="0"/>
+                <a:ea typeface="Arial" pitchFamily="34" charset="-122"/>
+                <a:cs typeface="Arial" pitchFamily="34" charset="-120"/>
+              </a:rPr>
+              <a:t>Backend</a:t>
+            </a:r>
+            <a:endParaRPr lang="en-US" sz="1400" dirty="0"/>
+          </a:p>
+        </p:txBody>
+      </p:sp>
+      <p:sp>
+        <p:nvSpPr>
+          <p:cNvPr id="5" name="Text 3"/>
+          <p:cNvSpPr/>
+          <p:nvPr/>
+        </p:nvSpPr>
+        <p:spPr>
+          <a:xfrm>
+            <a:off x="4114800" y="1188720"/>
+            <a:ext cx="3200400" cy="502920"/>
+          </a:xfrm>
+          <a:prstGeom prst="rect">
+            <a:avLst/>
+          </a:prstGeom>
+          <a:noFill/>
+          <a:ln/>
+        </p:spPr>
+        <p:txBody>
+          <a:bodyPr wrap="square" rtlCol="0" anchor="ctr"/>
+          <a:lstStyle/>
+          <a:p>
+            <a:pPr indent="0" marL="0">
+              <a:buNone/>
+            </a:pPr>
+            <a:r>
+              <a:rPr lang="en-US" sz="1400" b="1" dirty="0">
+                <a:solidFill>
+                  <a:srgbClr val="00E676"/>
+                </a:solidFill>
+                <a:latin typeface="Arial" pitchFamily="34" charset="0"/>
+                <a:ea typeface="Arial" pitchFamily="34" charset="-122"/>
+                <a:cs typeface="Arial" pitchFamily="34" charset="-120"/>
+              </a:rPr>
+              <a:t>XNNPACK (CPU)</a:t>
+            </a:r>
+            <a:endParaRPr lang="en-US" sz="1400" dirty="0"/>
+          </a:p>
+        </p:txBody>
+      </p:sp>
+      <p:sp>
+        <p:nvSpPr>
+          <p:cNvPr id="6" name="Text 4"/>
+          <p:cNvSpPr/>
+          <p:nvPr/>
+        </p:nvSpPr>
+        <p:spPr>
+          <a:xfrm>
+            <a:off x="7315200" y="1188720"/>
+            <a:ext cx="3657600" cy="502920"/>
+          </a:xfrm>
+          <a:prstGeom prst="rect">
+            <a:avLst/>
+          </a:prstGeom>
+          <a:noFill/>
+          <a:ln/>
+        </p:spPr>
+        <p:txBody>
+          <a:bodyPr wrap="square" rtlCol="0" anchor="ctr"/>
+          <a:lstStyle/>
+          <a:p>
+            <a:pPr indent="0" marL="0">
+              <a:buNone/>
+            </a:pPr>
+            <a:r>
+              <a:rPr lang="en-US" sz="1400" b="1" dirty="0">
+                <a:solidFill>
+                  <a:srgbClr val="00E676"/>
+                </a:solidFill>
+                <a:latin typeface="Arial" pitchFamily="34" charset="0"/>
+                <a:ea typeface="Arial" pitchFamily="34" charset="-122"/>
+                <a:cs typeface="Arial" pitchFamily="34" charset="-120"/>
+              </a:rPr>
+              <a:t>QNN HTP (NPU)</a:t>
+            </a:r>
+            <a:endParaRPr lang="en-US" sz="1400" dirty="0"/>
+          </a:p>
+        </p:txBody>
+      </p:sp>
+      <p:sp>
+        <p:nvSpPr>
+          <p:cNvPr id="7" name="Shape 5"/>
+          <p:cNvSpPr/>
+          <p:nvPr/>
+        </p:nvSpPr>
+        <p:spPr>
+          <a:xfrm>
+            <a:off x="731520" y="1719072"/>
+            <a:ext cx="10424160" cy="502920"/>
+          </a:xfrm>
+          <a:prstGeom prst="rect">
+            <a:avLst/>
+          </a:prstGeom>
+          <a:solidFill>
+            <a:srgbClr val="0D1117"/>
+          </a:solidFill>
+          <a:ln/>
+        </p:spPr>
+      </p:sp>
+      <p:sp>
+        <p:nvSpPr>
+          <p:cNvPr id="8" name="Text 6"/>
+          <p:cNvSpPr/>
+          <p:nvPr/>
+        </p:nvSpPr>
+        <p:spPr>
+          <a:xfrm>
+            <a:off x="822960" y="1719072"/>
+            <a:ext cx="3200400" cy="502920"/>
+          </a:xfrm>
+          <a:prstGeom prst="rect">
+            <a:avLst/>
+          </a:prstGeom>
+          <a:noFill/>
+          <a:ln/>
+        </p:spPr>
+        <p:txBody>
+          <a:bodyPr wrap="square" rtlCol="0" anchor="ctr"/>
+          <a:lstStyle/>
+          <a:p>
+            <a:pPr indent="0" marL="0">
+              <a:buNone/>
+            </a:pPr>
+            <a:r>
+              <a:rPr lang="en-US" sz="1400" dirty="0">
                 <a:solidFill>
                   <a:srgbClr val="FFFFFF"/>
                 </a:solidFill>
@@ -3964,38 +3218,38 @@
                 <a:ea typeface="Arial" pitchFamily="34" charset="-122"/>
                 <a:cs typeface="Arial" pitchFamily="34" charset="-120"/>
               </a:rPr>
-              <a:t>Fine-grained Port Classification</a:t>
-            </a:r>
-            <a:endParaRPr lang="en-US" sz="1800" dirty="0"/>
-          </a:p>
-        </p:txBody>
-      </p:sp>
-      <p:sp>
-        <p:nvSpPr>
-          <p:cNvPr id="5" name="Text 3"/>
-          <p:cNvSpPr/>
-          <p:nvPr/>
-        </p:nvSpPr>
-        <p:spPr>
-          <a:xfrm>
-            <a:off x="1097280" y="1600200"/>
-            <a:ext cx="9144000" cy="365760"/>
-          </a:xfrm>
-          <a:prstGeom prst="rect">
-            <a:avLst/>
-          </a:prstGeom>
-          <a:noFill/>
-          <a:ln/>
-        </p:spPr>
-        <p:txBody>
-          <a:bodyPr wrap="square" rtlCol="0" anchor="ctr"/>
-          <a:lstStyle/>
-          <a:p>
-            <a:pPr indent="0" marL="0">
-              <a:buNone/>
-            </a:pPr>
-            <a:r>
-              <a:rPr lang="en-US" sz="1300" dirty="0">
+              <a:t>Model</a:t>
+            </a:r>
+            <a:endParaRPr lang="en-US" sz="1400" dirty="0"/>
+          </a:p>
+        </p:txBody>
+      </p:sp>
+      <p:sp>
+        <p:nvSpPr>
+          <p:cNvPr id="9" name="Text 7"/>
+          <p:cNvSpPr/>
+          <p:nvPr/>
+        </p:nvSpPr>
+        <p:spPr>
+          <a:xfrm>
+            <a:off x="4114800" y="1719072"/>
+            <a:ext cx="3200400" cy="502920"/>
+          </a:xfrm>
+          <a:prstGeom prst="rect">
+            <a:avLst/>
+          </a:prstGeom>
+          <a:noFill/>
+          <a:ln/>
+        </p:spPr>
+        <p:txBody>
+          <a:bodyPr wrap="square" rtlCol="0" anchor="ctr"/>
+          <a:lstStyle/>
+          <a:p>
+            <a:pPr indent="0" marL="0">
+              <a:buNone/>
+            </a:pPr>
+            <a:r>
+              <a:rPr lang="en-US" sz="1400" dirty="0">
                 <a:solidFill>
                   <a:srgbClr val="8B949E"/>
                 </a:solidFill>
@@ -4003,58 +3257,97 @@
                 <a:ea typeface="Arial" pitchFamily="34" charset="-122"/>
                 <a:cs typeface="Arial" pitchFamily="34" charset="-120"/>
               </a:rPr>
-              <a:t>Split 'network port' into HDMI, USB-A, USB-C, RJ45, SFP individually</a:t>
-            </a:r>
-            <a:endParaRPr lang="en-US" sz="1300" dirty="0"/>
-          </a:p>
-        </p:txBody>
-      </p:sp>
-      <p:sp>
-        <p:nvSpPr>
-          <p:cNvPr id="6" name="Shape 4"/>
-          <p:cNvSpPr/>
-          <p:nvPr/>
-        </p:nvSpPr>
-        <p:spPr>
-          <a:xfrm>
-            <a:off x="731520" y="2103120"/>
-            <a:ext cx="54864" cy="640080"/>
+              <a:t>YOLOv8n-seg</a:t>
+            </a:r>
+            <a:endParaRPr lang="en-US" sz="1400" dirty="0"/>
+          </a:p>
+        </p:txBody>
+      </p:sp>
+      <p:sp>
+        <p:nvSpPr>
+          <p:cNvPr id="10" name="Text 8"/>
+          <p:cNvSpPr/>
+          <p:nvPr/>
+        </p:nvSpPr>
+        <p:spPr>
+          <a:xfrm>
+            <a:off x="7315200" y="1719072"/>
+            <a:ext cx="3657600" cy="502920"/>
+          </a:xfrm>
+          <a:prstGeom prst="rect">
+            <a:avLst/>
+          </a:prstGeom>
+          <a:noFill/>
+          <a:ln/>
+        </p:spPr>
+        <p:txBody>
+          <a:bodyPr wrap="square" rtlCol="0" anchor="ctr"/>
+          <a:lstStyle/>
+          <a:p>
+            <a:pPr indent="0" marL="0">
+              <a:buNone/>
+            </a:pPr>
+            <a:r>
+              <a:rPr lang="en-US" sz="1400" b="1" dirty="0">
+                <a:solidFill>
+                  <a:srgbClr val="00E676"/>
+                </a:solidFill>
+                <a:latin typeface="Arial" pitchFamily="34" charset="0"/>
+                <a:ea typeface="Arial" pitchFamily="34" charset="-122"/>
+                <a:cs typeface="Arial" pitchFamily="34" charset="-120"/>
+              </a:rPr>
+              <a:t>RetinaNet</a:t>
+            </a:r>
+            <a:endParaRPr lang="en-US" sz="1400" dirty="0"/>
+          </a:p>
+        </p:txBody>
+      </p:sp>
+      <p:sp>
+        <p:nvSpPr>
+          <p:cNvPr id="11" name="Shape 9"/>
+          <p:cNvSpPr/>
+          <p:nvPr/>
+        </p:nvSpPr>
+        <p:spPr>
+          <a:xfrm>
+            <a:off x="731520" y="2249424"/>
+            <a:ext cx="10424160" cy="502920"/>
           </a:xfrm>
           <a:prstGeom prst="rect">
             <a:avLst/>
           </a:prstGeom>
           <a:solidFill>
-            <a:srgbClr val="00E676"/>
+            <a:srgbClr val="161B22"/>
           </a:solidFill>
           <a:ln/>
         </p:spPr>
       </p:sp>
       <p:sp>
         <p:nvSpPr>
-          <p:cNvPr id="7" name="Text 5"/>
-          <p:cNvSpPr/>
-          <p:nvPr/>
-        </p:nvSpPr>
-        <p:spPr>
-          <a:xfrm>
-            <a:off x="1097280" y="2057400"/>
-            <a:ext cx="9144000" cy="411480"/>
-          </a:xfrm>
-          <a:prstGeom prst="rect">
-            <a:avLst/>
-          </a:prstGeom>
-          <a:noFill/>
-          <a:ln/>
-        </p:spPr>
-        <p:txBody>
-          <a:bodyPr wrap="square" rtlCol="0" anchor="ctr"/>
-          <a:lstStyle/>
-          <a:p>
-            <a:pPr indent="0" marL="0">
-              <a:buNone/>
-            </a:pPr>
-            <a:r>
-              <a:rPr lang="en-US" sz="1800" b="1" dirty="0">
+          <p:cNvPr id="12" name="Text 10"/>
+          <p:cNvSpPr/>
+          <p:nvPr/>
+        </p:nvSpPr>
+        <p:spPr>
+          <a:xfrm>
+            <a:off x="822960" y="2249424"/>
+            <a:ext cx="3200400" cy="502920"/>
+          </a:xfrm>
+          <a:prstGeom prst="rect">
+            <a:avLst/>
+          </a:prstGeom>
+          <a:noFill/>
+          <a:ln/>
+        </p:spPr>
+        <p:txBody>
+          <a:bodyPr wrap="square" rtlCol="0" anchor="ctr"/>
+          <a:lstStyle/>
+          <a:p>
+            <a:pPr indent="0" marL="0">
+              <a:buNone/>
+            </a:pPr>
+            <a:r>
+              <a:rPr lang="en-US" sz="1400" dirty="0">
                 <a:solidFill>
                   <a:srgbClr val="FFFFFF"/>
                 </a:solidFill>
@@ -4062,38 +3355,38 @@
                 <a:ea typeface="Arial" pitchFamily="34" charset="-122"/>
                 <a:cs typeface="Arial" pitchFamily="34" charset="-120"/>
               </a:rPr>
-              <a:t>LED State Detection</a:t>
-            </a:r>
-            <a:endParaRPr lang="en-US" sz="1800" dirty="0"/>
-          </a:p>
-        </p:txBody>
-      </p:sp>
-      <p:sp>
-        <p:nvSpPr>
-          <p:cNvPr id="8" name="Text 6"/>
-          <p:cNvSpPr/>
-          <p:nvPr/>
-        </p:nvSpPr>
-        <p:spPr>
-          <a:xfrm>
-            <a:off x="1097280" y="2468880"/>
-            <a:ext cx="9144000" cy="365760"/>
-          </a:xfrm>
-          <a:prstGeom prst="rect">
-            <a:avLst/>
-          </a:prstGeom>
-          <a:noFill/>
-          <a:ln/>
-        </p:spPr>
-        <p:txBody>
-          <a:bodyPr wrap="square" rtlCol="0" anchor="ctr"/>
-          <a:lstStyle/>
-          <a:p>
-            <a:pPr indent="0" marL="0">
-              <a:buNone/>
-            </a:pPr>
-            <a:r>
-              <a:rPr lang="en-US" sz="1300" dirty="0">
+              <a:t>Size</a:t>
+            </a:r>
+            <a:endParaRPr lang="en-US" sz="1400" dirty="0"/>
+          </a:p>
+        </p:txBody>
+      </p:sp>
+      <p:sp>
+        <p:nvSpPr>
+          <p:cNvPr id="13" name="Text 11"/>
+          <p:cNvSpPr/>
+          <p:nvPr/>
+        </p:nvSpPr>
+        <p:spPr>
+          <a:xfrm>
+            <a:off x="4114800" y="2249424"/>
+            <a:ext cx="3200400" cy="502920"/>
+          </a:xfrm>
+          <a:prstGeom prst="rect">
+            <a:avLst/>
+          </a:prstGeom>
+          <a:noFill/>
+          <a:ln/>
+        </p:spPr>
+        <p:txBody>
+          <a:bodyPr wrap="square" rtlCol="0" anchor="ctr"/>
+          <a:lstStyle/>
+          <a:p>
+            <a:pPr indent="0" marL="0">
+              <a:buNone/>
+            </a:pPr>
+            <a:r>
+              <a:rPr lang="en-US" sz="1400" dirty="0">
                 <a:solidFill>
                   <a:srgbClr val="8B949E"/>
                 </a:solidFill>
@@ -4101,58 +3394,97 @@
                 <a:ea typeface="Arial" pitchFamily="34" charset="-122"/>
                 <a:cs typeface="Arial" pitchFamily="34" charset="-120"/>
               </a:rPr>
-              <a:t>Classify LED colors (green/amber/red) and blink patterns for health scoring</a:t>
-            </a:r>
-            <a:endParaRPr lang="en-US" sz="1300" dirty="0"/>
-          </a:p>
-        </p:txBody>
-      </p:sp>
-      <p:sp>
-        <p:nvSpPr>
-          <p:cNvPr id="9" name="Shape 7"/>
-          <p:cNvSpPr/>
-          <p:nvPr/>
-        </p:nvSpPr>
-        <p:spPr>
-          <a:xfrm>
-            <a:off x="731520" y="2971800"/>
-            <a:ext cx="54864" cy="640080"/>
+              <a:t>13 MB</a:t>
+            </a:r>
+            <a:endParaRPr lang="en-US" sz="1400" dirty="0"/>
+          </a:p>
+        </p:txBody>
+      </p:sp>
+      <p:sp>
+        <p:nvSpPr>
+          <p:cNvPr id="14" name="Text 12"/>
+          <p:cNvSpPr/>
+          <p:nvPr/>
+        </p:nvSpPr>
+        <p:spPr>
+          <a:xfrm>
+            <a:off x="7315200" y="2249424"/>
+            <a:ext cx="3657600" cy="502920"/>
+          </a:xfrm>
+          <a:prstGeom prst="rect">
+            <a:avLst/>
+          </a:prstGeom>
+          <a:noFill/>
+          <a:ln/>
+        </p:spPr>
+        <p:txBody>
+          <a:bodyPr wrap="square" rtlCol="0" anchor="ctr"/>
+          <a:lstStyle/>
+          <a:p>
+            <a:pPr indent="0" marL="0">
+              <a:buNone/>
+            </a:pPr>
+            <a:r>
+              <a:rPr lang="en-US" sz="1400" b="1" dirty="0">
+                <a:solidFill>
+                  <a:srgbClr val="00E676"/>
+                </a:solidFill>
+                <a:latin typeface="Arial" pitchFamily="34" charset="0"/>
+                <a:ea typeface="Arial" pitchFamily="34" charset="-122"/>
+                <a:cs typeface="Arial" pitchFamily="34" charset="-120"/>
+              </a:rPr>
+              <a:t>36 MB</a:t>
+            </a:r>
+            <a:endParaRPr lang="en-US" sz="1400" dirty="0"/>
+          </a:p>
+        </p:txBody>
+      </p:sp>
+      <p:sp>
+        <p:nvSpPr>
+          <p:cNvPr id="15" name="Shape 13"/>
+          <p:cNvSpPr/>
+          <p:nvPr/>
+        </p:nvSpPr>
+        <p:spPr>
+          <a:xfrm>
+            <a:off x="731520" y="2779776"/>
+            <a:ext cx="10424160" cy="502920"/>
           </a:xfrm>
           <a:prstGeom prst="rect">
             <a:avLst/>
           </a:prstGeom>
           <a:solidFill>
-            <a:srgbClr val="00E676"/>
+            <a:srgbClr val="0D1117"/>
           </a:solidFill>
           <a:ln/>
         </p:spPr>
       </p:sp>
       <p:sp>
         <p:nvSpPr>
-          <p:cNvPr id="10" name="Text 8"/>
-          <p:cNvSpPr/>
-          <p:nvPr/>
-        </p:nvSpPr>
-        <p:spPr>
-          <a:xfrm>
-            <a:off x="1097280" y="2926080"/>
-            <a:ext cx="9144000" cy="411480"/>
-          </a:xfrm>
-          <a:prstGeom prst="rect">
-            <a:avLst/>
-          </a:prstGeom>
-          <a:noFill/>
-          <a:ln/>
-        </p:spPr>
-        <p:txBody>
-          <a:bodyPr wrap="square" rtlCol="0" anchor="ctr"/>
-          <a:lstStyle/>
-          <a:p>
-            <a:pPr indent="0" marL="0">
-              <a:buNone/>
-            </a:pPr>
-            <a:r>
-              <a:rPr lang="en-US" sz="1800" b="1" dirty="0">
+          <p:cNvPr id="16" name="Text 14"/>
+          <p:cNvSpPr/>
+          <p:nvPr/>
+        </p:nvSpPr>
+        <p:spPr>
+          <a:xfrm>
+            <a:off x="822960" y="2779776"/>
+            <a:ext cx="3200400" cy="502920"/>
+          </a:xfrm>
+          <a:prstGeom prst="rect">
+            <a:avLst/>
+          </a:prstGeom>
+          <a:noFill/>
+          <a:ln/>
+        </p:spPr>
+        <p:txBody>
+          <a:bodyPr wrap="square" rtlCol="0" anchor="ctr"/>
+          <a:lstStyle/>
+          <a:p>
+            <a:pPr indent="0" marL="0">
+              <a:buNone/>
+            </a:pPr>
+            <a:r>
+              <a:rPr lang="en-US" sz="1400" dirty="0">
                 <a:solidFill>
                   <a:srgbClr val="FFFFFF"/>
                 </a:solidFill>
@@ -4160,38 +3492,38 @@
                 <a:ea typeface="Arial" pitchFamily="34" charset="-122"/>
                 <a:cs typeface="Arial" pitchFamily="34" charset="-120"/>
               </a:rPr>
-              <a:t>On-Device LLM Integration</a:t>
-            </a:r>
-            <a:endParaRPr lang="en-US" sz="1800" dirty="0"/>
-          </a:p>
-        </p:txBody>
-      </p:sp>
-      <p:sp>
-        <p:nvSpPr>
-          <p:cNvPr id="11" name="Text 9"/>
-          <p:cNvSpPr/>
-          <p:nvPr/>
-        </p:nvSpPr>
-        <p:spPr>
-          <a:xfrm>
-            <a:off x="1097280" y="3337560"/>
-            <a:ext cx="9144000" cy="365760"/>
-          </a:xfrm>
-          <a:prstGeom prst="rect">
-            <a:avLst/>
-          </a:prstGeom>
-          <a:noFill/>
-          <a:ln/>
-        </p:spPr>
-        <p:txBody>
-          <a:bodyPr wrap="square" rtlCol="0" anchor="ctr"/>
-          <a:lstStyle/>
-          <a:p>
-            <a:pPr indent="0" marL="0">
-              <a:buNone/>
-            </a:pPr>
-            <a:r>
-              <a:rPr lang="en-US" sz="1300" dirty="0">
+              <a:t>Quantization</a:t>
+            </a:r>
+            <a:endParaRPr lang="en-US" sz="1400" dirty="0"/>
+          </a:p>
+        </p:txBody>
+      </p:sp>
+      <p:sp>
+        <p:nvSpPr>
+          <p:cNvPr id="17" name="Text 15"/>
+          <p:cNvSpPr/>
+          <p:nvPr/>
+        </p:nvSpPr>
+        <p:spPr>
+          <a:xfrm>
+            <a:off x="4114800" y="2779776"/>
+            <a:ext cx="3200400" cy="502920"/>
+          </a:xfrm>
+          <a:prstGeom prst="rect">
+            <a:avLst/>
+          </a:prstGeom>
+          <a:noFill/>
+          <a:ln/>
+        </p:spPr>
+        <p:txBody>
+          <a:bodyPr wrap="square" rtlCol="0" anchor="ctr"/>
+          <a:lstStyle/>
+          <a:p>
+            <a:pPr indent="0" marL="0">
+              <a:buNone/>
+            </a:pPr>
+            <a:r>
+              <a:rPr lang="en-US" sz="1400" dirty="0">
                 <a:solidFill>
                   <a:srgbClr val="8B949E"/>
                 </a:solidFill>
@@ -4199,58 +3531,234 @@
                 <a:ea typeface="Arial" pitchFamily="34" charset="-122"/>
                 <a:cs typeface="Arial" pitchFamily="34" charset="-120"/>
               </a:rPr>
-              <a:t>LLaMA 3.2 1B via ExecuTorch for natural language troubleshooting Q&amp;A</a:t>
-            </a:r>
-            <a:endParaRPr lang="en-US" sz="1300" dirty="0"/>
-          </a:p>
-        </p:txBody>
-      </p:sp>
-      <p:sp>
-        <p:nvSpPr>
-          <p:cNvPr id="12" name="Shape 10"/>
+              <a:t>FP32</a:t>
+            </a:r>
+            <a:endParaRPr lang="en-US" sz="1400" dirty="0"/>
+          </a:p>
+        </p:txBody>
+      </p:sp>
+      <p:sp>
+        <p:nvSpPr>
+          <p:cNvPr id="18" name="Text 16"/>
+          <p:cNvSpPr/>
+          <p:nvPr/>
+        </p:nvSpPr>
+        <p:spPr>
+          <a:xfrm>
+            <a:off x="7315200" y="2779776"/>
+            <a:ext cx="3657600" cy="502920"/>
+          </a:xfrm>
+          <a:prstGeom prst="rect">
+            <a:avLst/>
+          </a:prstGeom>
+          <a:noFill/>
+          <a:ln/>
+        </p:spPr>
+        <p:txBody>
+          <a:bodyPr wrap="square" rtlCol="0" anchor="ctr"/>
+          <a:lstStyle/>
+          <a:p>
+            <a:pPr indent="0" marL="0">
+              <a:buNone/>
+            </a:pPr>
+            <a:r>
+              <a:rPr lang="en-US" sz="1400" b="1" dirty="0">
+                <a:solidFill>
+                  <a:srgbClr val="00E676"/>
+                </a:solidFill>
+                <a:latin typeface="Arial" pitchFamily="34" charset="0"/>
+                <a:ea typeface="Arial" pitchFamily="34" charset="-122"/>
+                <a:cs typeface="Arial" pitchFamily="34" charset="-120"/>
+              </a:rPr>
+              <a:t>INT8</a:t>
+            </a:r>
+            <a:endParaRPr lang="en-US" sz="1400" dirty="0"/>
+          </a:p>
+        </p:txBody>
+      </p:sp>
+      <p:sp>
+        <p:nvSpPr>
+          <p:cNvPr id="19" name="Shape 17"/>
+          <p:cNvSpPr/>
+          <p:nvPr/>
+        </p:nvSpPr>
+        <p:spPr>
+          <a:xfrm>
+            <a:off x="731520" y="3310128"/>
+            <a:ext cx="10424160" cy="502920"/>
+          </a:xfrm>
+          <a:prstGeom prst="rect">
+            <a:avLst/>
+          </a:prstGeom>
+          <a:solidFill>
+            <a:srgbClr val="161B22"/>
+          </a:solidFill>
+          <a:ln/>
+        </p:spPr>
+      </p:sp>
+      <p:sp>
+        <p:nvSpPr>
+          <p:cNvPr id="20" name="Text 18"/>
+          <p:cNvSpPr/>
+          <p:nvPr/>
+        </p:nvSpPr>
+        <p:spPr>
+          <a:xfrm>
+            <a:off x="822960" y="3310128"/>
+            <a:ext cx="3200400" cy="502920"/>
+          </a:xfrm>
+          <a:prstGeom prst="rect">
+            <a:avLst/>
+          </a:prstGeom>
+          <a:noFill/>
+          <a:ln/>
+        </p:spPr>
+        <p:txBody>
+          <a:bodyPr wrap="square" rtlCol="0" anchor="ctr"/>
+          <a:lstStyle/>
+          <a:p>
+            <a:pPr indent="0" marL="0">
+              <a:buNone/>
+            </a:pPr>
+            <a:r>
+              <a:rPr lang="en-US" sz="1400" dirty="0">
+                <a:solidFill>
+                  <a:srgbClr val="FFFFFF"/>
+                </a:solidFill>
+                <a:latin typeface="Arial" pitchFamily="34" charset="0"/>
+                <a:ea typeface="Arial" pitchFamily="34" charset="-122"/>
+                <a:cs typeface="Arial" pitchFamily="34" charset="-120"/>
+              </a:rPr>
+              <a:t>Est. Latency</a:t>
+            </a:r>
+            <a:endParaRPr lang="en-US" sz="1400" dirty="0"/>
+          </a:p>
+        </p:txBody>
+      </p:sp>
+      <p:sp>
+        <p:nvSpPr>
+          <p:cNvPr id="21" name="Text 19"/>
+          <p:cNvSpPr/>
+          <p:nvPr/>
+        </p:nvSpPr>
+        <p:spPr>
+          <a:xfrm>
+            <a:off x="4114800" y="3310128"/>
+            <a:ext cx="3200400" cy="502920"/>
+          </a:xfrm>
+          <a:prstGeom prst="rect">
+            <a:avLst/>
+          </a:prstGeom>
+          <a:noFill/>
+          <a:ln/>
+        </p:spPr>
+        <p:txBody>
+          <a:bodyPr wrap="square" rtlCol="0" anchor="ctr"/>
+          <a:lstStyle/>
+          <a:p>
+            <a:pPr indent="0" marL="0">
+              <a:buNone/>
+            </a:pPr>
+            <a:r>
+              <a:rPr lang="en-US" sz="1400" dirty="0">
+                <a:solidFill>
+                  <a:srgbClr val="8B949E"/>
+                </a:solidFill>
+                <a:latin typeface="Arial" pitchFamily="34" charset="0"/>
+                <a:ea typeface="Arial" pitchFamily="34" charset="-122"/>
+                <a:cs typeface="Arial" pitchFamily="34" charset="-120"/>
+              </a:rPr>
+              <a:t>~15-30ms</a:t>
+            </a:r>
+            <a:endParaRPr lang="en-US" sz="1400" dirty="0"/>
+          </a:p>
+        </p:txBody>
+      </p:sp>
+      <p:sp>
+        <p:nvSpPr>
+          <p:cNvPr id="22" name="Text 20"/>
+          <p:cNvSpPr/>
+          <p:nvPr/>
+        </p:nvSpPr>
+        <p:spPr>
+          <a:xfrm>
+            <a:off x="7315200" y="3310128"/>
+            <a:ext cx="3657600" cy="502920"/>
+          </a:xfrm>
+          <a:prstGeom prst="rect">
+            <a:avLst/>
+          </a:prstGeom>
+          <a:noFill/>
+          <a:ln/>
+        </p:spPr>
+        <p:txBody>
+          <a:bodyPr wrap="square" rtlCol="0" anchor="ctr"/>
+          <a:lstStyle/>
+          <a:p>
+            <a:pPr indent="0" marL="0">
+              <a:buNone/>
+            </a:pPr>
+            <a:r>
+              <a:rPr lang="en-US" sz="1400" b="1" dirty="0">
+                <a:solidFill>
+                  <a:srgbClr val="00E676"/>
+                </a:solidFill>
+                <a:latin typeface="Arial" pitchFamily="34" charset="0"/>
+                <a:ea typeface="Arial" pitchFamily="34" charset="-122"/>
+                <a:cs typeface="Arial" pitchFamily="34" charset="-120"/>
+              </a:rPr>
+              <a:t>~3-5ms</a:t>
+            </a:r>
+            <a:endParaRPr lang="en-US" sz="1400" dirty="0"/>
+          </a:p>
+        </p:txBody>
+      </p:sp>
+      <p:sp>
+        <p:nvSpPr>
+          <p:cNvPr id="23" name="Shape 21"/>
           <p:cNvSpPr/>
           <p:nvPr/>
         </p:nvSpPr>
         <p:spPr>
           <a:xfrm>
             <a:off x="731520" y="3840480"/>
-            <a:ext cx="54864" cy="640080"/>
+            <a:ext cx="10424160" cy="502920"/>
           </a:xfrm>
           <a:prstGeom prst="rect">
             <a:avLst/>
           </a:prstGeom>
           <a:solidFill>
-            <a:srgbClr val="00E676"/>
+            <a:srgbClr val="0D1117"/>
           </a:solidFill>
           <a:ln/>
         </p:spPr>
       </p:sp>
       <p:sp>
         <p:nvSpPr>
-          <p:cNvPr id="13" name="Text 11"/>
-          <p:cNvSpPr/>
-          <p:nvPr/>
-        </p:nvSpPr>
-        <p:spPr>
-          <a:xfrm>
-            <a:off x="1097280" y="3794760"/>
-            <a:ext cx="9144000" cy="411480"/>
-          </a:xfrm>
-          <a:prstGeom prst="rect">
-            <a:avLst/>
-          </a:prstGeom>
-          <a:noFill/>
-          <a:ln/>
-        </p:spPr>
-        <p:txBody>
-          <a:bodyPr wrap="square" rtlCol="0" anchor="ctr"/>
-          <a:lstStyle/>
-          <a:p>
-            <a:pPr indent="0" marL="0">
-              <a:buNone/>
-            </a:pPr>
-            <a:r>
-              <a:rPr lang="en-US" sz="1800" b="1" dirty="0">
+          <p:cNvPr id="24" name="Text 22"/>
+          <p:cNvSpPr/>
+          <p:nvPr/>
+        </p:nvSpPr>
+        <p:spPr>
+          <a:xfrm>
+            <a:off x="822960" y="3840480"/>
+            <a:ext cx="3200400" cy="502920"/>
+          </a:xfrm>
+          <a:prstGeom prst="rect">
+            <a:avLst/>
+          </a:prstGeom>
+          <a:noFill/>
+          <a:ln/>
+        </p:spPr>
+        <p:txBody>
+          <a:bodyPr wrap="square" rtlCol="0" anchor="ctr"/>
+          <a:lstStyle/>
+          <a:p>
+            <a:pPr indent="0" marL="0">
+              <a:buNone/>
+            </a:pPr>
+            <a:r>
+              <a:rPr lang="en-US" sz="1400" dirty="0">
                 <a:solidFill>
                   <a:srgbClr val="FFFFFF"/>
                 </a:solidFill>
@@ -4258,38 +3766,38 @@
                 <a:ea typeface="Arial" pitchFamily="34" charset="-122"/>
                 <a:cs typeface="Arial" pitchFamily="34" charset="-120"/>
               </a:rPr>
-              <a:t>Audit Log + Reporting</a:t>
-            </a:r>
-            <a:endParaRPr lang="en-US" sz="1800" dirty="0"/>
-          </a:p>
-        </p:txBody>
-      </p:sp>
-      <p:sp>
-        <p:nvSpPr>
-          <p:cNvPr id="14" name="Text 12"/>
-          <p:cNvSpPr/>
-          <p:nvPr/>
-        </p:nvSpPr>
-        <p:spPr>
-          <a:xfrm>
-            <a:off x="1097280" y="4206240"/>
-            <a:ext cx="9144000" cy="365760"/>
-          </a:xfrm>
-          <a:prstGeom prst="rect">
-            <a:avLst/>
-          </a:prstGeom>
-          <a:noFill/>
-          <a:ln/>
-        </p:spPr>
-        <p:txBody>
-          <a:bodyPr wrap="square" rtlCol="0" anchor="ctr"/>
-          <a:lstStyle/>
-          <a:p>
-            <a:pPr indent="0" marL="0">
-              <a:buNone/>
-            </a:pPr>
-            <a:r>
-              <a:rPr lang="en-US" sz="1300" dirty="0">
+              <a:t>Est. FPS</a:t>
+            </a:r>
+            <a:endParaRPr lang="en-US" sz="1400" dirty="0"/>
+          </a:p>
+        </p:txBody>
+      </p:sp>
+      <p:sp>
+        <p:nvSpPr>
+          <p:cNvPr id="25" name="Text 23"/>
+          <p:cNvSpPr/>
+          <p:nvPr/>
+        </p:nvSpPr>
+        <p:spPr>
+          <a:xfrm>
+            <a:off x="4114800" y="3840480"/>
+            <a:ext cx="3200400" cy="502920"/>
+          </a:xfrm>
+          <a:prstGeom prst="rect">
+            <a:avLst/>
+          </a:prstGeom>
+          <a:noFill/>
+          <a:ln/>
+        </p:spPr>
+        <p:txBody>
+          <a:bodyPr wrap="square" rtlCol="0" anchor="ctr"/>
+          <a:lstStyle/>
+          <a:p>
+            <a:pPr indent="0" marL="0">
+              <a:buNone/>
+            </a:pPr>
+            <a:r>
+              <a:rPr lang="en-US" sz="1400" dirty="0">
                 <a:solidFill>
                   <a:srgbClr val="8B949E"/>
                 </a:solidFill>
@@ -4297,58 +3805,97 @@
                 <a:ea typeface="Arial" pitchFamily="34" charset="-122"/>
                 <a:cs typeface="Arial" pitchFamily="34" charset="-120"/>
               </a:rPr>
-              <a:t>SQLite database of all inspections, exportable via secure channel</a:t>
-            </a:r>
-            <a:endParaRPr lang="en-US" sz="1300" dirty="0"/>
-          </a:p>
-        </p:txBody>
-      </p:sp>
-      <p:sp>
-        <p:nvSpPr>
-          <p:cNvPr id="15" name="Shape 13"/>
-          <p:cNvSpPr/>
-          <p:nvPr/>
-        </p:nvSpPr>
-        <p:spPr>
-          <a:xfrm>
-            <a:off x="731520" y="4709160"/>
-            <a:ext cx="54864" cy="640080"/>
+              <a:t>~30-60</a:t>
+            </a:r>
+            <a:endParaRPr lang="en-US" sz="1400" dirty="0"/>
+          </a:p>
+        </p:txBody>
+      </p:sp>
+      <p:sp>
+        <p:nvSpPr>
+          <p:cNvPr id="26" name="Text 24"/>
+          <p:cNvSpPr/>
+          <p:nvPr/>
+        </p:nvSpPr>
+        <p:spPr>
+          <a:xfrm>
+            <a:off x="7315200" y="3840480"/>
+            <a:ext cx="3657600" cy="502920"/>
+          </a:xfrm>
+          <a:prstGeom prst="rect">
+            <a:avLst/>
+          </a:prstGeom>
+          <a:noFill/>
+          <a:ln/>
+        </p:spPr>
+        <p:txBody>
+          <a:bodyPr wrap="square" rtlCol="0" anchor="ctr"/>
+          <a:lstStyle/>
+          <a:p>
+            <a:pPr indent="0" marL="0">
+              <a:buNone/>
+            </a:pPr>
+            <a:r>
+              <a:rPr lang="en-US" sz="1400" b="1" dirty="0">
+                <a:solidFill>
+                  <a:srgbClr val="00E676"/>
+                </a:solidFill>
+                <a:latin typeface="Arial" pitchFamily="34" charset="0"/>
+                <a:ea typeface="Arial" pitchFamily="34" charset="-122"/>
+                <a:cs typeface="Arial" pitchFamily="34" charset="-120"/>
+              </a:rPr>
+              <a:t>~100+</a:t>
+            </a:r>
+            <a:endParaRPr lang="en-US" sz="1400" dirty="0"/>
+          </a:p>
+        </p:txBody>
+      </p:sp>
+      <p:sp>
+        <p:nvSpPr>
+          <p:cNvPr id="27" name="Shape 25"/>
+          <p:cNvSpPr/>
+          <p:nvPr/>
+        </p:nvSpPr>
+        <p:spPr>
+          <a:xfrm>
+            <a:off x="731520" y="4370832"/>
+            <a:ext cx="10424160" cy="502920"/>
           </a:xfrm>
           <a:prstGeom prst="rect">
             <a:avLst/>
           </a:prstGeom>
           <a:solidFill>
-            <a:srgbClr val="00E676"/>
+            <a:srgbClr val="161B22"/>
           </a:solidFill>
           <a:ln/>
         </p:spPr>
       </p:sp>
       <p:sp>
         <p:nvSpPr>
-          <p:cNvPr id="16" name="Text 14"/>
-          <p:cNvSpPr/>
-          <p:nvPr/>
-        </p:nvSpPr>
-        <p:spPr>
-          <a:xfrm>
-            <a:off x="1097280" y="4663440"/>
-            <a:ext cx="9144000" cy="411480"/>
-          </a:xfrm>
-          <a:prstGeom prst="rect">
-            <a:avLst/>
-          </a:prstGeom>
-          <a:noFill/>
-          <a:ln/>
-        </p:spPr>
-        <p:txBody>
-          <a:bodyPr wrap="square" rtlCol="0" anchor="ctr"/>
-          <a:lstStyle/>
-          <a:p>
-            <a:pPr indent="0" marL="0">
-              <a:buNone/>
-            </a:pPr>
-            <a:r>
-              <a:rPr lang="en-US" sz="1800" b="1" dirty="0">
+          <p:cNvPr id="28" name="Text 26"/>
+          <p:cNvSpPr/>
+          <p:nvPr/>
+        </p:nvSpPr>
+        <p:spPr>
+          <a:xfrm>
+            <a:off x="822960" y="4370832"/>
+            <a:ext cx="3200400" cy="502920"/>
+          </a:xfrm>
+          <a:prstGeom prst="rect">
+            <a:avLst/>
+          </a:prstGeom>
+          <a:noFill/>
+          <a:ln/>
+        </p:spPr>
+        <p:txBody>
+          <a:bodyPr wrap="square" rtlCol="0" anchor="ctr"/>
+          <a:lstStyle/>
+          <a:p>
+            <a:pPr indent="0" marL="0">
+              <a:buNone/>
+            </a:pPr>
+            <a:r>
+              <a:rPr lang="en-US" sz="1400" dirty="0">
                 <a:solidFill>
                   <a:srgbClr val="FFFFFF"/>
                 </a:solidFill>
@@ -4356,38 +3903,38 @@
                 <a:ea typeface="Arial" pitchFamily="34" charset="-122"/>
                 <a:cs typeface="Arial" pitchFamily="34" charset="-120"/>
               </a:rPr>
-              <a:t>Multi-Rack Mapping</a:t>
-            </a:r>
-            <a:endParaRPr lang="en-US" sz="1800" dirty="0"/>
-          </a:p>
-        </p:txBody>
-      </p:sp>
-      <p:sp>
-        <p:nvSpPr>
-          <p:cNvPr id="17" name="Text 15"/>
-          <p:cNvSpPr/>
-          <p:nvPr/>
-        </p:nvSpPr>
-        <p:spPr>
-          <a:xfrm>
-            <a:off x="1097280" y="5074920"/>
-            <a:ext cx="9144000" cy="365760"/>
-          </a:xfrm>
-          <a:prstGeom prst="rect">
-            <a:avLst/>
-          </a:prstGeom>
-          <a:noFill/>
-          <a:ln/>
-        </p:spPr>
-        <p:txBody>
-          <a:bodyPr wrap="square" rtlCol="0" anchor="ctr"/>
-          <a:lstStyle/>
-          <a:p>
-            <a:pPr indent="0" marL="0">
-              <a:buNone/>
-            </a:pPr>
-            <a:r>
-              <a:rPr lang="en-US" sz="1300" dirty="0">
+              <a:t>Power</a:t>
+            </a:r>
+            <a:endParaRPr lang="en-US" sz="1400" dirty="0"/>
+          </a:p>
+        </p:txBody>
+      </p:sp>
+      <p:sp>
+        <p:nvSpPr>
+          <p:cNvPr id="29" name="Text 27"/>
+          <p:cNvSpPr/>
+          <p:nvPr/>
+        </p:nvSpPr>
+        <p:spPr>
+          <a:xfrm>
+            <a:off x="4114800" y="4370832"/>
+            <a:ext cx="3200400" cy="502920"/>
+          </a:xfrm>
+          <a:prstGeom prst="rect">
+            <a:avLst/>
+          </a:prstGeom>
+          <a:noFill/>
+          <a:ln/>
+        </p:spPr>
+        <p:txBody>
+          <a:bodyPr wrap="square" rtlCol="0" anchor="ctr"/>
+          <a:lstStyle/>
+          <a:p>
+            <a:pPr indent="0" marL="0">
+              <a:buNone/>
+            </a:pPr>
+            <a:r>
+              <a:rPr lang="en-US" sz="1400" dirty="0">
                 <a:solidFill>
                   <a:srgbClr val="8B949E"/>
                 </a:solidFill>
@@ -4395,9 +3942,185 @@
                 <a:ea typeface="Arial" pitchFamily="34" charset="-122"/>
                 <a:cs typeface="Arial" pitchFamily="34" charset="-120"/>
               </a:rPr>
-              <a:t>Combine depth estimation + detection for spatial rack layout understanding</a:t>
-            </a:r>
-            <a:endParaRPr lang="en-US" sz="1300" dirty="0"/>
+              <a:t>Higher drain</a:t>
+            </a:r>
+            <a:endParaRPr lang="en-US" sz="1400" dirty="0"/>
+          </a:p>
+        </p:txBody>
+      </p:sp>
+      <p:sp>
+        <p:nvSpPr>
+          <p:cNvPr id="30" name="Text 28"/>
+          <p:cNvSpPr/>
+          <p:nvPr/>
+        </p:nvSpPr>
+        <p:spPr>
+          <a:xfrm>
+            <a:off x="7315200" y="4370832"/>
+            <a:ext cx="3657600" cy="502920"/>
+          </a:xfrm>
+          <a:prstGeom prst="rect">
+            <a:avLst/>
+          </a:prstGeom>
+          <a:noFill/>
+          <a:ln/>
+        </p:spPr>
+        <p:txBody>
+          <a:bodyPr wrap="square" rtlCol="0" anchor="ctr"/>
+          <a:lstStyle/>
+          <a:p>
+            <a:pPr indent="0" marL="0">
+              <a:buNone/>
+            </a:pPr>
+            <a:r>
+              <a:rPr lang="en-US" sz="1400" b="1" dirty="0">
+                <a:solidFill>
+                  <a:srgbClr val="00E676"/>
+                </a:solidFill>
+                <a:latin typeface="Arial" pitchFamily="34" charset="0"/>
+                <a:ea typeface="Arial" pitchFamily="34" charset="-122"/>
+                <a:cs typeface="Arial" pitchFamily="34" charset="-120"/>
+              </a:rPr>
+              <a:t>4-5x efficient</a:t>
+            </a:r>
+            <a:endParaRPr lang="en-US" sz="1400" dirty="0"/>
+          </a:p>
+        </p:txBody>
+      </p:sp>
+      <p:sp>
+        <p:nvSpPr>
+          <p:cNvPr id="31" name="Shape 29"/>
+          <p:cNvSpPr/>
+          <p:nvPr/>
+        </p:nvSpPr>
+        <p:spPr>
+          <a:xfrm>
+            <a:off x="731520" y="4901184"/>
+            <a:ext cx="10424160" cy="502920"/>
+          </a:xfrm>
+          <a:prstGeom prst="rect">
+            <a:avLst/>
+          </a:prstGeom>
+          <a:solidFill>
+            <a:srgbClr val="0D1117"/>
+          </a:solidFill>
+          <a:ln/>
+        </p:spPr>
+      </p:sp>
+      <p:sp>
+        <p:nvSpPr>
+          <p:cNvPr id="32" name="Text 30"/>
+          <p:cNvSpPr/>
+          <p:nvPr/>
+        </p:nvSpPr>
+        <p:spPr>
+          <a:xfrm>
+            <a:off x="822960" y="4901184"/>
+            <a:ext cx="3200400" cy="502920"/>
+          </a:xfrm>
+          <a:prstGeom prst="rect">
+            <a:avLst/>
+          </a:prstGeom>
+          <a:noFill/>
+          <a:ln/>
+        </p:spPr>
+        <p:txBody>
+          <a:bodyPr wrap="square" rtlCol="0" anchor="ctr"/>
+          <a:lstStyle/>
+          <a:p>
+            <a:pPr indent="0" marL="0">
+              <a:buNone/>
+            </a:pPr>
+            <a:r>
+              <a:rPr lang="en-US" sz="1400" dirty="0">
+                <a:solidFill>
+                  <a:srgbClr val="FFFFFF"/>
+                </a:solidFill>
+                <a:latin typeface="Arial" pitchFamily="34" charset="0"/>
+                <a:ea typeface="Arial" pitchFamily="34" charset="-122"/>
+                <a:cs typeface="Arial" pitchFamily="34" charset="-120"/>
+              </a:rPr>
+              <a:t>Hardware</a:t>
+            </a:r>
+            <a:endParaRPr lang="en-US" sz="1400" dirty="0"/>
+          </a:p>
+        </p:txBody>
+      </p:sp>
+      <p:sp>
+        <p:nvSpPr>
+          <p:cNvPr id="33" name="Text 31"/>
+          <p:cNvSpPr/>
+          <p:nvPr/>
+        </p:nvSpPr>
+        <p:spPr>
+          <a:xfrm>
+            <a:off x="4114800" y="4901184"/>
+            <a:ext cx="3200400" cy="502920"/>
+          </a:xfrm>
+          <a:prstGeom prst="rect">
+            <a:avLst/>
+          </a:prstGeom>
+          <a:noFill/>
+          <a:ln/>
+        </p:spPr>
+        <p:txBody>
+          <a:bodyPr wrap="square" rtlCol="0" anchor="ctr"/>
+          <a:lstStyle/>
+          <a:p>
+            <a:pPr indent="0" marL="0">
+              <a:buNone/>
+            </a:pPr>
+            <a:r>
+              <a:rPr lang="en-US" sz="1400" dirty="0">
+                <a:solidFill>
+                  <a:srgbClr val="8B949E"/>
+                </a:solidFill>
+                <a:latin typeface="Arial" pitchFamily="34" charset="0"/>
+                <a:ea typeface="Arial" pitchFamily="34" charset="-122"/>
+                <a:cs typeface="Arial" pitchFamily="34" charset="-120"/>
+              </a:rPr>
+              <a:t>ARM Kryo cores</a:t>
+            </a:r>
+            <a:endParaRPr lang="en-US" sz="1400" dirty="0"/>
+          </a:p>
+        </p:txBody>
+      </p:sp>
+      <p:sp>
+        <p:nvSpPr>
+          <p:cNvPr id="34" name="Text 32"/>
+          <p:cNvSpPr/>
+          <p:nvPr/>
+        </p:nvSpPr>
+        <p:spPr>
+          <a:xfrm>
+            <a:off x="7315200" y="4901184"/>
+            <a:ext cx="3657600" cy="502920"/>
+          </a:xfrm>
+          <a:prstGeom prst="rect">
+            <a:avLst/>
+          </a:prstGeom>
+          <a:noFill/>
+          <a:ln/>
+        </p:spPr>
+        <p:txBody>
+          <a:bodyPr wrap="square" rtlCol="0" anchor="ctr"/>
+          <a:lstStyle/>
+          <a:p>
+            <a:pPr indent="0" marL="0">
+              <a:buNone/>
+            </a:pPr>
+            <a:r>
+              <a:rPr lang="en-US" sz="1400" b="1" dirty="0">
+                <a:solidFill>
+                  <a:srgbClr val="00E676"/>
+                </a:solidFill>
+                <a:latin typeface="Arial" pitchFamily="34" charset="0"/>
+                <a:ea typeface="Arial" pitchFamily="34" charset="-122"/>
+                <a:cs typeface="Arial" pitchFamily="34" charset="-120"/>
+              </a:rPr>
+              <a:t>Hexagon HTP v79</a:t>
+            </a:r>
+            <a:endParaRPr lang="en-US" sz="1400" dirty="0"/>
           </a:p>
         </p:txBody>
       </p:sp>
@@ -4412,6 +4135,567 @@
 <file path=ppt/slides/slide13.xml><?xml version="1.0" encoding="utf-8"?>
 <p:sld xmlns:a="http://schemas.openxmlformats.org/drawingml/2006/main" xmlns:r="http://schemas.openxmlformats.org/officeDocument/2006/relationships" xmlns:p="http://schemas.openxmlformats.org/presentationml/2006/main">
   <p:cSld name="Slide 13">
+    <p:bg>
+      <p:bgPr>
+        <a:solidFill>
+          <a:srgbClr val="0D1117"/>
+        </a:solidFill>
+      </p:bgPr>
+    </p:bg>
+    <p:spTree>
+      <p:nvGrpSpPr>
+        <p:cNvPr id="1" name=""/>
+        <p:cNvGrpSpPr/>
+        <p:nvPr/>
+      </p:nvGrpSpPr>
+      <p:grpSpPr>
+        <a:xfrm>
+          <a:off x="0" y="0"/>
+          <a:ext cx="0" cy="0"/>
+          <a:chOff x="0" y="0"/>
+          <a:chExt cx="0" cy="0"/>
+        </a:xfrm>
+      </p:grpSpPr>
+      <p:sp>
+        <p:nvSpPr>
+          <p:cNvPr id="2" name="Text 0"/>
+          <p:cNvSpPr/>
+          <p:nvPr/>
+        </p:nvSpPr>
+        <p:spPr>
+          <a:xfrm>
+            <a:off x="731520" y="365760"/>
+            <a:ext cx="10058400" cy="640080"/>
+          </a:xfrm>
+          <a:prstGeom prst="rect">
+            <a:avLst/>
+          </a:prstGeom>
+          <a:noFill/>
+          <a:ln/>
+        </p:spPr>
+        <p:txBody>
+          <a:bodyPr wrap="square" rtlCol="0" anchor="ctr"/>
+          <a:lstStyle/>
+          <a:p>
+            <a:pPr indent="0" marL="0">
+              <a:buNone/>
+            </a:pPr>
+            <a:r>
+              <a:rPr lang="en-US" sz="3600" b="1" dirty="0">
+                <a:solidFill>
+                  <a:srgbClr val="00E676"/>
+                </a:solidFill>
+                <a:latin typeface="Arial Black" pitchFamily="34" charset="0"/>
+                <a:ea typeface="Arial Black" pitchFamily="34" charset="-122"/>
+                <a:cs typeface="Arial Black" pitchFamily="34" charset="-120"/>
+              </a:rPr>
+              <a:t>WHAT'S NEXT</a:t>
+            </a:r>
+            <a:endParaRPr lang="en-US" sz="3600" dirty="0"/>
+          </a:p>
+        </p:txBody>
+      </p:sp>
+      <p:sp>
+        <p:nvSpPr>
+          <p:cNvPr id="3" name="Shape 1"/>
+          <p:cNvSpPr/>
+          <p:nvPr/>
+        </p:nvSpPr>
+        <p:spPr>
+          <a:xfrm>
+            <a:off x="731520" y="1234440"/>
+            <a:ext cx="54864" cy="640080"/>
+          </a:xfrm>
+          <a:prstGeom prst="rect">
+            <a:avLst/>
+          </a:prstGeom>
+          <a:solidFill>
+            <a:srgbClr val="00E676"/>
+          </a:solidFill>
+          <a:ln/>
+        </p:spPr>
+      </p:sp>
+      <p:sp>
+        <p:nvSpPr>
+          <p:cNvPr id="4" name="Text 2"/>
+          <p:cNvSpPr/>
+          <p:nvPr/>
+        </p:nvSpPr>
+        <p:spPr>
+          <a:xfrm>
+            <a:off x="1097280" y="1188720"/>
+            <a:ext cx="9144000" cy="411480"/>
+          </a:xfrm>
+          <a:prstGeom prst="rect">
+            <a:avLst/>
+          </a:prstGeom>
+          <a:noFill/>
+          <a:ln/>
+        </p:spPr>
+        <p:txBody>
+          <a:bodyPr wrap="square" rtlCol="0" anchor="ctr"/>
+          <a:lstStyle/>
+          <a:p>
+            <a:pPr indent="0" marL="0">
+              <a:buNone/>
+            </a:pPr>
+            <a:r>
+              <a:rPr lang="en-US" sz="1800" b="1" dirty="0">
+                <a:solidFill>
+                  <a:srgbClr val="FFFFFF"/>
+                </a:solidFill>
+                <a:latin typeface="Arial" pitchFamily="34" charset="0"/>
+                <a:ea typeface="Arial" pitchFamily="34" charset="-122"/>
+                <a:cs typeface="Arial" pitchFamily="34" charset="-120"/>
+              </a:rPr>
+              <a:t>Fine-grained Port Classification</a:t>
+            </a:r>
+            <a:endParaRPr lang="en-US" sz="1800" dirty="0"/>
+          </a:p>
+        </p:txBody>
+      </p:sp>
+      <p:sp>
+        <p:nvSpPr>
+          <p:cNvPr id="5" name="Text 3"/>
+          <p:cNvSpPr/>
+          <p:nvPr/>
+        </p:nvSpPr>
+        <p:spPr>
+          <a:xfrm>
+            <a:off x="1097280" y="1600200"/>
+            <a:ext cx="9144000" cy="365760"/>
+          </a:xfrm>
+          <a:prstGeom prst="rect">
+            <a:avLst/>
+          </a:prstGeom>
+          <a:noFill/>
+          <a:ln/>
+        </p:spPr>
+        <p:txBody>
+          <a:bodyPr wrap="square" rtlCol="0" anchor="ctr"/>
+          <a:lstStyle/>
+          <a:p>
+            <a:pPr indent="0" marL="0">
+              <a:buNone/>
+            </a:pPr>
+            <a:r>
+              <a:rPr lang="en-US" sz="1300" dirty="0">
+                <a:solidFill>
+                  <a:srgbClr val="8B949E"/>
+                </a:solidFill>
+                <a:latin typeface="Arial" pitchFamily="34" charset="0"/>
+                <a:ea typeface="Arial" pitchFamily="34" charset="-122"/>
+                <a:cs typeface="Arial" pitchFamily="34" charset="-120"/>
+              </a:rPr>
+              <a:t>Split 'network port' into HDMI, USB-A, USB-C, RJ45, SFP individually</a:t>
+            </a:r>
+            <a:endParaRPr lang="en-US" sz="1300" dirty="0"/>
+          </a:p>
+        </p:txBody>
+      </p:sp>
+      <p:sp>
+        <p:nvSpPr>
+          <p:cNvPr id="6" name="Shape 4"/>
+          <p:cNvSpPr/>
+          <p:nvPr/>
+        </p:nvSpPr>
+        <p:spPr>
+          <a:xfrm>
+            <a:off x="731520" y="2103120"/>
+            <a:ext cx="54864" cy="640080"/>
+          </a:xfrm>
+          <a:prstGeom prst="rect">
+            <a:avLst/>
+          </a:prstGeom>
+          <a:solidFill>
+            <a:srgbClr val="00E676"/>
+          </a:solidFill>
+          <a:ln/>
+        </p:spPr>
+      </p:sp>
+      <p:sp>
+        <p:nvSpPr>
+          <p:cNvPr id="7" name="Text 5"/>
+          <p:cNvSpPr/>
+          <p:nvPr/>
+        </p:nvSpPr>
+        <p:spPr>
+          <a:xfrm>
+            <a:off x="1097280" y="2057400"/>
+            <a:ext cx="9144000" cy="411480"/>
+          </a:xfrm>
+          <a:prstGeom prst="rect">
+            <a:avLst/>
+          </a:prstGeom>
+          <a:noFill/>
+          <a:ln/>
+        </p:spPr>
+        <p:txBody>
+          <a:bodyPr wrap="square" rtlCol="0" anchor="ctr"/>
+          <a:lstStyle/>
+          <a:p>
+            <a:pPr indent="0" marL="0">
+              <a:buNone/>
+            </a:pPr>
+            <a:r>
+              <a:rPr lang="en-US" sz="1800" b="1" dirty="0">
+                <a:solidFill>
+                  <a:srgbClr val="FFFFFF"/>
+                </a:solidFill>
+                <a:latin typeface="Arial" pitchFamily="34" charset="0"/>
+                <a:ea typeface="Arial" pitchFamily="34" charset="-122"/>
+                <a:cs typeface="Arial" pitchFamily="34" charset="-120"/>
+              </a:rPr>
+              <a:t>LED State Detection</a:t>
+            </a:r>
+            <a:endParaRPr lang="en-US" sz="1800" dirty="0"/>
+          </a:p>
+        </p:txBody>
+      </p:sp>
+      <p:sp>
+        <p:nvSpPr>
+          <p:cNvPr id="8" name="Text 6"/>
+          <p:cNvSpPr/>
+          <p:nvPr/>
+        </p:nvSpPr>
+        <p:spPr>
+          <a:xfrm>
+            <a:off x="1097280" y="2468880"/>
+            <a:ext cx="9144000" cy="365760"/>
+          </a:xfrm>
+          <a:prstGeom prst="rect">
+            <a:avLst/>
+          </a:prstGeom>
+          <a:noFill/>
+          <a:ln/>
+        </p:spPr>
+        <p:txBody>
+          <a:bodyPr wrap="square" rtlCol="0" anchor="ctr"/>
+          <a:lstStyle/>
+          <a:p>
+            <a:pPr indent="0" marL="0">
+              <a:buNone/>
+            </a:pPr>
+            <a:r>
+              <a:rPr lang="en-US" sz="1300" dirty="0">
+                <a:solidFill>
+                  <a:srgbClr val="8B949E"/>
+                </a:solidFill>
+                <a:latin typeface="Arial" pitchFamily="34" charset="0"/>
+                <a:ea typeface="Arial" pitchFamily="34" charset="-122"/>
+                <a:cs typeface="Arial" pitchFamily="34" charset="-120"/>
+              </a:rPr>
+              <a:t>Classify LED colors (green/amber/red) and blink patterns for health scoring</a:t>
+            </a:r>
+            <a:endParaRPr lang="en-US" sz="1300" dirty="0"/>
+          </a:p>
+        </p:txBody>
+      </p:sp>
+      <p:sp>
+        <p:nvSpPr>
+          <p:cNvPr id="9" name="Shape 7"/>
+          <p:cNvSpPr/>
+          <p:nvPr/>
+        </p:nvSpPr>
+        <p:spPr>
+          <a:xfrm>
+            <a:off x="731520" y="2971800"/>
+            <a:ext cx="54864" cy="640080"/>
+          </a:xfrm>
+          <a:prstGeom prst="rect">
+            <a:avLst/>
+          </a:prstGeom>
+          <a:solidFill>
+            <a:srgbClr val="00E676"/>
+          </a:solidFill>
+          <a:ln/>
+        </p:spPr>
+      </p:sp>
+      <p:sp>
+        <p:nvSpPr>
+          <p:cNvPr id="10" name="Text 8"/>
+          <p:cNvSpPr/>
+          <p:nvPr/>
+        </p:nvSpPr>
+        <p:spPr>
+          <a:xfrm>
+            <a:off x="1097280" y="2926080"/>
+            <a:ext cx="9144000" cy="411480"/>
+          </a:xfrm>
+          <a:prstGeom prst="rect">
+            <a:avLst/>
+          </a:prstGeom>
+          <a:noFill/>
+          <a:ln/>
+        </p:spPr>
+        <p:txBody>
+          <a:bodyPr wrap="square" rtlCol="0" anchor="ctr"/>
+          <a:lstStyle/>
+          <a:p>
+            <a:pPr indent="0" marL="0">
+              <a:buNone/>
+            </a:pPr>
+            <a:r>
+              <a:rPr lang="en-US" sz="1800" b="1" dirty="0">
+                <a:solidFill>
+                  <a:srgbClr val="FFFFFF"/>
+                </a:solidFill>
+                <a:latin typeface="Arial" pitchFamily="34" charset="0"/>
+                <a:ea typeface="Arial" pitchFamily="34" charset="-122"/>
+                <a:cs typeface="Arial" pitchFamily="34" charset="-120"/>
+              </a:rPr>
+              <a:t>On-Device LLM Integration</a:t>
+            </a:r>
+            <a:endParaRPr lang="en-US" sz="1800" dirty="0"/>
+          </a:p>
+        </p:txBody>
+      </p:sp>
+      <p:sp>
+        <p:nvSpPr>
+          <p:cNvPr id="11" name="Text 9"/>
+          <p:cNvSpPr/>
+          <p:nvPr/>
+        </p:nvSpPr>
+        <p:spPr>
+          <a:xfrm>
+            <a:off x="1097280" y="3337560"/>
+            <a:ext cx="9144000" cy="365760"/>
+          </a:xfrm>
+          <a:prstGeom prst="rect">
+            <a:avLst/>
+          </a:prstGeom>
+          <a:noFill/>
+          <a:ln/>
+        </p:spPr>
+        <p:txBody>
+          <a:bodyPr wrap="square" rtlCol="0" anchor="ctr"/>
+          <a:lstStyle/>
+          <a:p>
+            <a:pPr indent="0" marL="0">
+              <a:buNone/>
+            </a:pPr>
+            <a:r>
+              <a:rPr lang="en-US" sz="1300" dirty="0">
+                <a:solidFill>
+                  <a:srgbClr val="8B949E"/>
+                </a:solidFill>
+                <a:latin typeface="Arial" pitchFamily="34" charset="0"/>
+                <a:ea typeface="Arial" pitchFamily="34" charset="-122"/>
+                <a:cs typeface="Arial" pitchFamily="34" charset="-120"/>
+              </a:rPr>
+              <a:t>LLaMA 3.2 1B via ExecuTorch for natural language troubleshooting Q&amp;A</a:t>
+            </a:r>
+            <a:endParaRPr lang="en-US" sz="1300" dirty="0"/>
+          </a:p>
+        </p:txBody>
+      </p:sp>
+      <p:sp>
+        <p:nvSpPr>
+          <p:cNvPr id="12" name="Shape 10"/>
+          <p:cNvSpPr/>
+          <p:nvPr/>
+        </p:nvSpPr>
+        <p:spPr>
+          <a:xfrm>
+            <a:off x="731520" y="3840480"/>
+            <a:ext cx="54864" cy="640080"/>
+          </a:xfrm>
+          <a:prstGeom prst="rect">
+            <a:avLst/>
+          </a:prstGeom>
+          <a:solidFill>
+            <a:srgbClr val="00E676"/>
+          </a:solidFill>
+          <a:ln/>
+        </p:spPr>
+      </p:sp>
+      <p:sp>
+        <p:nvSpPr>
+          <p:cNvPr id="13" name="Text 11"/>
+          <p:cNvSpPr/>
+          <p:nvPr/>
+        </p:nvSpPr>
+        <p:spPr>
+          <a:xfrm>
+            <a:off x="1097280" y="3794760"/>
+            <a:ext cx="9144000" cy="411480"/>
+          </a:xfrm>
+          <a:prstGeom prst="rect">
+            <a:avLst/>
+          </a:prstGeom>
+          <a:noFill/>
+          <a:ln/>
+        </p:spPr>
+        <p:txBody>
+          <a:bodyPr wrap="square" rtlCol="0" anchor="ctr"/>
+          <a:lstStyle/>
+          <a:p>
+            <a:pPr indent="0" marL="0">
+              <a:buNone/>
+            </a:pPr>
+            <a:r>
+              <a:rPr lang="en-US" sz="1800" b="1" dirty="0">
+                <a:solidFill>
+                  <a:srgbClr val="FFFFFF"/>
+                </a:solidFill>
+                <a:latin typeface="Arial" pitchFamily="34" charset="0"/>
+                <a:ea typeface="Arial" pitchFamily="34" charset="-122"/>
+                <a:cs typeface="Arial" pitchFamily="34" charset="-120"/>
+              </a:rPr>
+              <a:t>Audit Log + Reporting</a:t>
+            </a:r>
+            <a:endParaRPr lang="en-US" sz="1800" dirty="0"/>
+          </a:p>
+        </p:txBody>
+      </p:sp>
+      <p:sp>
+        <p:nvSpPr>
+          <p:cNvPr id="14" name="Text 12"/>
+          <p:cNvSpPr/>
+          <p:nvPr/>
+        </p:nvSpPr>
+        <p:spPr>
+          <a:xfrm>
+            <a:off x="1097280" y="4206240"/>
+            <a:ext cx="9144000" cy="365760"/>
+          </a:xfrm>
+          <a:prstGeom prst="rect">
+            <a:avLst/>
+          </a:prstGeom>
+          <a:noFill/>
+          <a:ln/>
+        </p:spPr>
+        <p:txBody>
+          <a:bodyPr wrap="square" rtlCol="0" anchor="ctr"/>
+          <a:lstStyle/>
+          <a:p>
+            <a:pPr indent="0" marL="0">
+              <a:buNone/>
+            </a:pPr>
+            <a:r>
+              <a:rPr lang="en-US" sz="1300" dirty="0">
+                <a:solidFill>
+                  <a:srgbClr val="8B949E"/>
+                </a:solidFill>
+                <a:latin typeface="Arial" pitchFamily="34" charset="0"/>
+                <a:ea typeface="Arial" pitchFamily="34" charset="-122"/>
+                <a:cs typeface="Arial" pitchFamily="34" charset="-120"/>
+              </a:rPr>
+              <a:t>SQLite database of all inspections, exportable via secure channel</a:t>
+            </a:r>
+            <a:endParaRPr lang="en-US" sz="1300" dirty="0"/>
+          </a:p>
+        </p:txBody>
+      </p:sp>
+      <p:sp>
+        <p:nvSpPr>
+          <p:cNvPr id="15" name="Shape 13"/>
+          <p:cNvSpPr/>
+          <p:nvPr/>
+        </p:nvSpPr>
+        <p:spPr>
+          <a:xfrm>
+            <a:off x="731520" y="4709160"/>
+            <a:ext cx="54864" cy="640080"/>
+          </a:xfrm>
+          <a:prstGeom prst="rect">
+            <a:avLst/>
+          </a:prstGeom>
+          <a:solidFill>
+            <a:srgbClr val="00E676"/>
+          </a:solidFill>
+          <a:ln/>
+        </p:spPr>
+      </p:sp>
+      <p:sp>
+        <p:nvSpPr>
+          <p:cNvPr id="16" name="Text 14"/>
+          <p:cNvSpPr/>
+          <p:nvPr/>
+        </p:nvSpPr>
+        <p:spPr>
+          <a:xfrm>
+            <a:off x="1097280" y="4663440"/>
+            <a:ext cx="9144000" cy="411480"/>
+          </a:xfrm>
+          <a:prstGeom prst="rect">
+            <a:avLst/>
+          </a:prstGeom>
+          <a:noFill/>
+          <a:ln/>
+        </p:spPr>
+        <p:txBody>
+          <a:bodyPr wrap="square" rtlCol="0" anchor="ctr"/>
+          <a:lstStyle/>
+          <a:p>
+            <a:pPr indent="0" marL="0">
+              <a:buNone/>
+            </a:pPr>
+            <a:r>
+              <a:rPr lang="en-US" sz="1800" b="1" dirty="0">
+                <a:solidFill>
+                  <a:srgbClr val="FFFFFF"/>
+                </a:solidFill>
+                <a:latin typeface="Arial" pitchFamily="34" charset="0"/>
+                <a:ea typeface="Arial" pitchFamily="34" charset="-122"/>
+                <a:cs typeface="Arial" pitchFamily="34" charset="-120"/>
+              </a:rPr>
+              <a:t>Multi-Rack Mapping</a:t>
+            </a:r>
+            <a:endParaRPr lang="en-US" sz="1800" dirty="0"/>
+          </a:p>
+        </p:txBody>
+      </p:sp>
+      <p:sp>
+        <p:nvSpPr>
+          <p:cNvPr id="17" name="Text 15"/>
+          <p:cNvSpPr/>
+          <p:nvPr/>
+        </p:nvSpPr>
+        <p:spPr>
+          <a:xfrm>
+            <a:off x="1097280" y="5074920"/>
+            <a:ext cx="9144000" cy="365760"/>
+          </a:xfrm>
+          <a:prstGeom prst="rect">
+            <a:avLst/>
+          </a:prstGeom>
+          <a:noFill/>
+          <a:ln/>
+        </p:spPr>
+        <p:txBody>
+          <a:bodyPr wrap="square" rtlCol="0" anchor="ctr"/>
+          <a:lstStyle/>
+          <a:p>
+            <a:pPr indent="0" marL="0">
+              <a:buNone/>
+            </a:pPr>
+            <a:r>
+              <a:rPr lang="en-US" sz="1300" dirty="0">
+                <a:solidFill>
+                  <a:srgbClr val="8B949E"/>
+                </a:solidFill>
+                <a:latin typeface="Arial" pitchFamily="34" charset="0"/>
+                <a:ea typeface="Arial" pitchFamily="34" charset="-122"/>
+                <a:cs typeface="Arial" pitchFamily="34" charset="-120"/>
+              </a:rPr>
+              <a:t>Combine depth estimation + detection for spatial rack layout understanding</a:t>
+            </a:r>
+            <a:endParaRPr lang="en-US" sz="1300" dirty="0"/>
+          </a:p>
+        </p:txBody>
+      </p:sp>
+    </p:spTree>
+  </p:cSld>
+  <p:clrMapOvr>
+    <a:masterClrMapping/>
+  </p:clrMapOvr>
+</p:sld>
+</file>
+
+<file path=ppt/slides/slide14.xml><?xml version="1.0" encoding="utf-8"?>
+<p:sld xmlns:a="http://schemas.openxmlformats.org/drawingml/2006/main" xmlns:r="http://schemas.openxmlformats.org/officeDocument/2006/relationships" xmlns:p="http://schemas.openxmlformats.org/presentationml/2006/main">
+  <p:cSld name="Slide 14">
     <p:bg>
       <p:bgPr>
         <a:solidFill>

</xml_diff>

<commit_message>
Deck: add BrightData data pipeline + shoutout, honest CPU/NPU labels
- Slide 7: two-phase pipeline — BrightData web scraping + Grounding
  DINO/SAM auto-labeling (bootstrap) → Roboflow human-labeled (final)
  with BrightData sponsor shoutout
- Slide 12: separate measured facts from estimated perf numbers;
  add footnote that latency/FPS/power are Qualcomm estimates, not
  measured on our model

Co-Authored-By: Claude Opus 4.8 <noreply@anthropic.com>
</commit_message>
<xml_diff>
--- a/presentation/dc_ops_pitch.pptx
+++ b/presentation/dc_ops_pitch.pptx
@@ -3037,7 +3037,7 @@
         <p:spPr>
           <a:xfrm>
             <a:off x="731520" y="1188720"/>
-            <a:ext cx="10424160" cy="502920"/>
+            <a:ext cx="10424160" cy="457200"/>
           </a:xfrm>
           <a:prstGeom prst="rect">
             <a:avLst/>
@@ -3057,7 +3057,7 @@
         <p:spPr>
           <a:xfrm>
             <a:off x="822960" y="1188720"/>
-            <a:ext cx="3200400" cy="502920"/>
+            <a:ext cx="3200400" cy="457200"/>
           </a:xfrm>
           <a:prstGeom prst="rect">
             <a:avLst/>
@@ -3096,7 +3096,7 @@
         <p:spPr>
           <a:xfrm>
             <a:off x="4114800" y="1188720"/>
-            <a:ext cx="3200400" cy="502920"/>
+            <a:ext cx="3200400" cy="457200"/>
           </a:xfrm>
           <a:prstGeom prst="rect">
             <a:avLst/>
@@ -3135,7 +3135,7 @@
         <p:spPr>
           <a:xfrm>
             <a:off x="7315200" y="1188720"/>
-            <a:ext cx="3657600" cy="502920"/>
+            <a:ext cx="3657600" cy="457200"/>
           </a:xfrm>
           <a:prstGeom prst="rect">
             <a:avLst/>
@@ -3173,8 +3173,8 @@
         </p:nvSpPr>
         <p:spPr>
           <a:xfrm>
-            <a:off x="731520" y="1719072"/>
-            <a:ext cx="10424160" cy="502920"/>
+            <a:off x="731520" y="1664208"/>
+            <a:ext cx="10424160" cy="457200"/>
           </a:xfrm>
           <a:prstGeom prst="rect">
             <a:avLst/>
@@ -3193,8 +3193,8 @@
         </p:nvSpPr>
         <p:spPr>
           <a:xfrm>
-            <a:off x="822960" y="1719072"/>
-            <a:ext cx="3200400" cy="502920"/>
+            <a:off x="822960" y="1664208"/>
+            <a:ext cx="3200400" cy="457200"/>
           </a:xfrm>
           <a:prstGeom prst="rect">
             <a:avLst/>
@@ -3232,8 +3232,8 @@
         </p:nvSpPr>
         <p:spPr>
           <a:xfrm>
-            <a:off x="4114800" y="1719072"/>
-            <a:ext cx="3200400" cy="502920"/>
+            <a:off x="4114800" y="1664208"/>
+            <a:ext cx="3200400" cy="457200"/>
           </a:xfrm>
           <a:prstGeom prst="rect">
             <a:avLst/>
@@ -3251,7 +3251,7 @@
             <a:r>
               <a:rPr lang="en-US" sz="1400" dirty="0">
                 <a:solidFill>
-                  <a:srgbClr val="8B949E"/>
+                  <a:srgbClr val="FFFFFF"/>
                 </a:solidFill>
                 <a:latin typeface="Arial" pitchFamily="34" charset="0"/>
                 <a:ea typeface="Arial" pitchFamily="34" charset="-122"/>
@@ -3271,8 +3271,8 @@
         </p:nvSpPr>
         <p:spPr>
           <a:xfrm>
-            <a:off x="7315200" y="1719072"/>
-            <a:ext cx="3657600" cy="502920"/>
+            <a:off x="7315200" y="1664208"/>
+            <a:ext cx="3657600" cy="457200"/>
           </a:xfrm>
           <a:prstGeom prst="rect">
             <a:avLst/>
@@ -3310,8 +3310,8 @@
         </p:nvSpPr>
         <p:spPr>
           <a:xfrm>
-            <a:off x="731520" y="2249424"/>
-            <a:ext cx="10424160" cy="502920"/>
+            <a:off x="731520" y="2139696"/>
+            <a:ext cx="10424160" cy="457200"/>
           </a:xfrm>
           <a:prstGeom prst="rect">
             <a:avLst/>
@@ -3330,8 +3330,8 @@
         </p:nvSpPr>
         <p:spPr>
           <a:xfrm>
-            <a:off x="822960" y="2249424"/>
-            <a:ext cx="3200400" cy="502920"/>
+            <a:off x="822960" y="2139696"/>
+            <a:ext cx="3200400" cy="457200"/>
           </a:xfrm>
           <a:prstGeom prst="rect">
             <a:avLst/>
@@ -3369,8 +3369,8 @@
         </p:nvSpPr>
         <p:spPr>
           <a:xfrm>
-            <a:off x="4114800" y="2249424"/>
-            <a:ext cx="3200400" cy="502920"/>
+            <a:off x="4114800" y="2139696"/>
+            <a:ext cx="3200400" cy="457200"/>
           </a:xfrm>
           <a:prstGeom prst="rect">
             <a:avLst/>
@@ -3388,7 +3388,7 @@
             <a:r>
               <a:rPr lang="en-US" sz="1400" dirty="0">
                 <a:solidFill>
-                  <a:srgbClr val="8B949E"/>
+                  <a:srgbClr val="FFFFFF"/>
                 </a:solidFill>
                 <a:latin typeface="Arial" pitchFamily="34" charset="0"/>
                 <a:ea typeface="Arial" pitchFamily="34" charset="-122"/>
@@ -3408,8 +3408,8 @@
         </p:nvSpPr>
         <p:spPr>
           <a:xfrm>
-            <a:off x="7315200" y="2249424"/>
-            <a:ext cx="3657600" cy="502920"/>
+            <a:off x="7315200" y="2139696"/>
+            <a:ext cx="3657600" cy="457200"/>
           </a:xfrm>
           <a:prstGeom prst="rect">
             <a:avLst/>
@@ -3447,8 +3447,8 @@
         </p:nvSpPr>
         <p:spPr>
           <a:xfrm>
-            <a:off x="731520" y="2779776"/>
-            <a:ext cx="10424160" cy="502920"/>
+            <a:off x="731520" y="2615184"/>
+            <a:ext cx="10424160" cy="457200"/>
           </a:xfrm>
           <a:prstGeom prst="rect">
             <a:avLst/>
@@ -3467,8 +3467,8 @@
         </p:nvSpPr>
         <p:spPr>
           <a:xfrm>
-            <a:off x="822960" y="2779776"/>
-            <a:ext cx="3200400" cy="502920"/>
+            <a:off x="822960" y="2615184"/>
+            <a:ext cx="3200400" cy="457200"/>
           </a:xfrm>
           <a:prstGeom prst="rect">
             <a:avLst/>
@@ -3506,8 +3506,8 @@
         </p:nvSpPr>
         <p:spPr>
           <a:xfrm>
-            <a:off x="4114800" y="2779776"/>
-            <a:ext cx="3200400" cy="502920"/>
+            <a:off x="4114800" y="2615184"/>
+            <a:ext cx="3200400" cy="457200"/>
           </a:xfrm>
           <a:prstGeom prst="rect">
             <a:avLst/>
@@ -3525,7 +3525,7 @@
             <a:r>
               <a:rPr lang="en-US" sz="1400" dirty="0">
                 <a:solidFill>
-                  <a:srgbClr val="8B949E"/>
+                  <a:srgbClr val="FFFFFF"/>
                 </a:solidFill>
                 <a:latin typeface="Arial" pitchFamily="34" charset="0"/>
                 <a:ea typeface="Arial" pitchFamily="34" charset="-122"/>
@@ -3545,8 +3545,8 @@
         </p:nvSpPr>
         <p:spPr>
           <a:xfrm>
-            <a:off x="7315200" y="2779776"/>
-            <a:ext cx="3657600" cy="502920"/>
+            <a:off x="7315200" y="2615184"/>
+            <a:ext cx="3657600" cy="457200"/>
           </a:xfrm>
           <a:prstGeom prst="rect">
             <a:avLst/>
@@ -3584,8 +3584,8 @@
         </p:nvSpPr>
         <p:spPr>
           <a:xfrm>
-            <a:off x="731520" y="3310128"/>
-            <a:ext cx="10424160" cy="502920"/>
+            <a:off x="731520" y="3090672"/>
+            <a:ext cx="10424160" cy="457200"/>
           </a:xfrm>
           <a:prstGeom prst="rect">
             <a:avLst/>
@@ -3604,8 +3604,8 @@
         </p:nvSpPr>
         <p:spPr>
           <a:xfrm>
-            <a:off x="822960" y="3310128"/>
-            <a:ext cx="3200400" cy="502920"/>
+            <a:off x="822960" y="3090672"/>
+            <a:ext cx="3200400" cy="457200"/>
           </a:xfrm>
           <a:prstGeom prst="rect">
             <a:avLst/>
@@ -3629,7 +3629,7 @@
                 <a:ea typeface="Arial" pitchFamily="34" charset="-122"/>
                 <a:cs typeface="Arial" pitchFamily="34" charset="-120"/>
               </a:rPr>
-              <a:t>Est. Latency</a:t>
+              <a:t>Hardware</a:t>
             </a:r>
             <a:endParaRPr lang="en-US" sz="1400" dirty="0"/>
           </a:p>
@@ -3643,8 +3643,8 @@
         </p:nvSpPr>
         <p:spPr>
           <a:xfrm>
-            <a:off x="4114800" y="3310128"/>
-            <a:ext cx="3200400" cy="502920"/>
+            <a:off x="4114800" y="3090672"/>
+            <a:ext cx="3200400" cy="457200"/>
           </a:xfrm>
           <a:prstGeom prst="rect">
             <a:avLst/>
@@ -3662,13 +3662,13 @@
             <a:r>
               <a:rPr lang="en-US" sz="1400" dirty="0">
                 <a:solidFill>
-                  <a:srgbClr val="8B949E"/>
-                </a:solidFill>
-                <a:latin typeface="Arial" pitchFamily="34" charset="0"/>
-                <a:ea typeface="Arial" pitchFamily="34" charset="-122"/>
-                <a:cs typeface="Arial" pitchFamily="34" charset="-120"/>
-              </a:rPr>
-              <a:t>~15-30ms</a:t>
+                  <a:srgbClr val="FFFFFF"/>
+                </a:solidFill>
+                <a:latin typeface="Arial" pitchFamily="34" charset="0"/>
+                <a:ea typeface="Arial" pitchFamily="34" charset="-122"/>
+                <a:cs typeface="Arial" pitchFamily="34" charset="-120"/>
+              </a:rPr>
+              <a:t>ARM Kryo cores</a:t>
             </a:r>
             <a:endParaRPr lang="en-US" sz="1400" dirty="0"/>
           </a:p>
@@ -3682,8 +3682,8 @@
         </p:nvSpPr>
         <p:spPr>
           <a:xfrm>
-            <a:off x="7315200" y="3310128"/>
-            <a:ext cx="3657600" cy="502920"/>
+            <a:off x="7315200" y="3090672"/>
+            <a:ext cx="3657600" cy="457200"/>
           </a:xfrm>
           <a:prstGeom prst="rect">
             <a:avLst/>
@@ -3707,7 +3707,7 @@
                 <a:ea typeface="Arial" pitchFamily="34" charset="-122"/>
                 <a:cs typeface="Arial" pitchFamily="34" charset="-120"/>
               </a:rPr>
-              <a:t>~3-5ms</a:t>
+              <a:t>Hexagon HTP v79</a:t>
             </a:r>
             <a:endParaRPr lang="en-US" sz="1400" dirty="0"/>
           </a:p>
@@ -3721,8 +3721,8 @@
         </p:nvSpPr>
         <p:spPr>
           <a:xfrm>
-            <a:off x="731520" y="3840480"/>
-            <a:ext cx="10424160" cy="502920"/>
+            <a:off x="731520" y="3566160"/>
+            <a:ext cx="10424160" cy="457200"/>
           </a:xfrm>
           <a:prstGeom prst="rect">
             <a:avLst/>
@@ -3741,8 +3741,8 @@
         </p:nvSpPr>
         <p:spPr>
           <a:xfrm>
-            <a:off x="822960" y="3840480"/>
-            <a:ext cx="3200400" cy="502920"/>
+            <a:off x="822960" y="3566160"/>
+            <a:ext cx="3200400" cy="457200"/>
           </a:xfrm>
           <a:prstGeom prst="rect">
             <a:avLst/>
@@ -3760,13 +3760,13 @@
             <a:r>
               <a:rPr lang="en-US" sz="1400" dirty="0">
                 <a:solidFill>
-                  <a:srgbClr val="FFFFFF"/>
-                </a:solidFill>
-                <a:latin typeface="Arial" pitchFamily="34" charset="0"/>
-                <a:ea typeface="Arial" pitchFamily="34" charset="-122"/>
-                <a:cs typeface="Arial" pitchFamily="34" charset="-120"/>
-              </a:rPr>
-              <a:t>Est. FPS</a:t>
+                  <a:srgbClr val="8B949E"/>
+                </a:solidFill>
+                <a:latin typeface="Arial" pitchFamily="34" charset="0"/>
+                <a:ea typeface="Arial" pitchFamily="34" charset="-122"/>
+                <a:cs typeface="Arial" pitchFamily="34" charset="-120"/>
+              </a:rPr>
+              <a:t>Latency †</a:t>
             </a:r>
             <a:endParaRPr lang="en-US" sz="1400" dirty="0"/>
           </a:p>
@@ -3780,8 +3780,8 @@
         </p:nvSpPr>
         <p:spPr>
           <a:xfrm>
-            <a:off x="4114800" y="3840480"/>
-            <a:ext cx="3200400" cy="502920"/>
+            <a:off x="4114800" y="3566160"/>
+            <a:ext cx="3200400" cy="457200"/>
           </a:xfrm>
           <a:prstGeom prst="rect">
             <a:avLst/>
@@ -3805,7 +3805,7 @@
                 <a:ea typeface="Arial" pitchFamily="34" charset="-122"/>
                 <a:cs typeface="Arial" pitchFamily="34" charset="-120"/>
               </a:rPr>
-              <a:t>~30-60</a:t>
+              <a:t>~15-30 ms</a:t>
             </a:r>
             <a:endParaRPr lang="en-US" sz="1400" dirty="0"/>
           </a:p>
@@ -3819,8 +3819,8 @@
         </p:nvSpPr>
         <p:spPr>
           <a:xfrm>
-            <a:off x="7315200" y="3840480"/>
-            <a:ext cx="3657600" cy="502920"/>
+            <a:off x="7315200" y="3566160"/>
+            <a:ext cx="3657600" cy="457200"/>
           </a:xfrm>
           <a:prstGeom prst="rect">
             <a:avLst/>
@@ -3844,7 +3844,7 @@
                 <a:ea typeface="Arial" pitchFamily="34" charset="-122"/>
                 <a:cs typeface="Arial" pitchFamily="34" charset="-120"/>
               </a:rPr>
-              <a:t>~100+</a:t>
+              <a:t>~3-5 ms</a:t>
             </a:r>
             <a:endParaRPr lang="en-US" sz="1400" dirty="0"/>
           </a:p>
@@ -3858,8 +3858,8 @@
         </p:nvSpPr>
         <p:spPr>
           <a:xfrm>
-            <a:off x="731520" y="4370832"/>
-            <a:ext cx="10424160" cy="502920"/>
+            <a:off x="731520" y="4041648"/>
+            <a:ext cx="10424160" cy="457200"/>
           </a:xfrm>
           <a:prstGeom prst="rect">
             <a:avLst/>
@@ -3878,8 +3878,8 @@
         </p:nvSpPr>
         <p:spPr>
           <a:xfrm>
-            <a:off x="822960" y="4370832"/>
-            <a:ext cx="3200400" cy="502920"/>
+            <a:off x="822960" y="4041648"/>
+            <a:ext cx="3200400" cy="457200"/>
           </a:xfrm>
           <a:prstGeom prst="rect">
             <a:avLst/>
@@ -3897,13 +3897,13 @@
             <a:r>
               <a:rPr lang="en-US" sz="1400" dirty="0">
                 <a:solidFill>
-                  <a:srgbClr val="FFFFFF"/>
-                </a:solidFill>
-                <a:latin typeface="Arial" pitchFamily="34" charset="0"/>
-                <a:ea typeface="Arial" pitchFamily="34" charset="-122"/>
-                <a:cs typeface="Arial" pitchFamily="34" charset="-120"/>
-              </a:rPr>
-              <a:t>Power</a:t>
+                  <a:srgbClr val="8B949E"/>
+                </a:solidFill>
+                <a:latin typeface="Arial" pitchFamily="34" charset="0"/>
+                <a:ea typeface="Arial" pitchFamily="34" charset="-122"/>
+                <a:cs typeface="Arial" pitchFamily="34" charset="-120"/>
+              </a:rPr>
+              <a:t>Throughput †</a:t>
             </a:r>
             <a:endParaRPr lang="en-US" sz="1400" dirty="0"/>
           </a:p>
@@ -3917,8 +3917,8 @@
         </p:nvSpPr>
         <p:spPr>
           <a:xfrm>
-            <a:off x="4114800" y="4370832"/>
-            <a:ext cx="3200400" cy="502920"/>
+            <a:off x="4114800" y="4041648"/>
+            <a:ext cx="3200400" cy="457200"/>
           </a:xfrm>
           <a:prstGeom prst="rect">
             <a:avLst/>
@@ -3942,7 +3942,7 @@
                 <a:ea typeface="Arial" pitchFamily="34" charset="-122"/>
                 <a:cs typeface="Arial" pitchFamily="34" charset="-120"/>
               </a:rPr>
-              <a:t>Higher drain</a:t>
+              <a:t>~30-60 FPS</a:t>
             </a:r>
             <a:endParaRPr lang="en-US" sz="1400" dirty="0"/>
           </a:p>
@@ -3956,8 +3956,8 @@
         </p:nvSpPr>
         <p:spPr>
           <a:xfrm>
-            <a:off x="7315200" y="4370832"/>
-            <a:ext cx="3657600" cy="502920"/>
+            <a:off x="7315200" y="4041648"/>
+            <a:ext cx="3657600" cy="457200"/>
           </a:xfrm>
           <a:prstGeom prst="rect">
             <a:avLst/>
@@ -3981,7 +3981,7 @@
                 <a:ea typeface="Arial" pitchFamily="34" charset="-122"/>
                 <a:cs typeface="Arial" pitchFamily="34" charset="-120"/>
               </a:rPr>
-              <a:t>4-5x efficient</a:t>
+              <a:t>~100+ FPS</a:t>
             </a:r>
             <a:endParaRPr lang="en-US" sz="1400" dirty="0"/>
           </a:p>
@@ -3995,8 +3995,8 @@
         </p:nvSpPr>
         <p:spPr>
           <a:xfrm>
-            <a:off x="731520" y="4901184"/>
-            <a:ext cx="10424160" cy="502920"/>
+            <a:off x="731520" y="4517136"/>
+            <a:ext cx="10424160" cy="457200"/>
           </a:xfrm>
           <a:prstGeom prst="rect">
             <a:avLst/>
@@ -4015,8 +4015,8 @@
         </p:nvSpPr>
         <p:spPr>
           <a:xfrm>
-            <a:off x="822960" y="4901184"/>
-            <a:ext cx="3200400" cy="502920"/>
+            <a:off x="822960" y="4517136"/>
+            <a:ext cx="3200400" cy="457200"/>
           </a:xfrm>
           <a:prstGeom prst="rect">
             <a:avLst/>
@@ -4034,13 +4034,13 @@
             <a:r>
               <a:rPr lang="en-US" sz="1400" dirty="0">
                 <a:solidFill>
-                  <a:srgbClr val="FFFFFF"/>
-                </a:solidFill>
-                <a:latin typeface="Arial" pitchFamily="34" charset="0"/>
-                <a:ea typeface="Arial" pitchFamily="34" charset="-122"/>
-                <a:cs typeface="Arial" pitchFamily="34" charset="-120"/>
-              </a:rPr>
-              <a:t>Hardware</a:t>
+                  <a:srgbClr val="8B949E"/>
+                </a:solidFill>
+                <a:latin typeface="Arial" pitchFamily="34" charset="0"/>
+                <a:ea typeface="Arial" pitchFamily="34" charset="-122"/>
+                <a:cs typeface="Arial" pitchFamily="34" charset="-120"/>
+              </a:rPr>
+              <a:t>Power †</a:t>
             </a:r>
             <a:endParaRPr lang="en-US" sz="1400" dirty="0"/>
           </a:p>
@@ -4054,8 +4054,8 @@
         </p:nvSpPr>
         <p:spPr>
           <a:xfrm>
-            <a:off x="4114800" y="4901184"/>
-            <a:ext cx="3200400" cy="502920"/>
+            <a:off x="4114800" y="4517136"/>
+            <a:ext cx="3200400" cy="457200"/>
           </a:xfrm>
           <a:prstGeom prst="rect">
             <a:avLst/>
@@ -4079,7 +4079,7 @@
                 <a:ea typeface="Arial" pitchFamily="34" charset="-122"/>
                 <a:cs typeface="Arial" pitchFamily="34" charset="-120"/>
               </a:rPr>
-              <a:t>ARM Kryo cores</a:t>
+              <a:t>Baseline</a:t>
             </a:r>
             <a:endParaRPr lang="en-US" sz="1400" dirty="0"/>
           </a:p>
@@ -4093,8 +4093,8 @@
         </p:nvSpPr>
         <p:spPr>
           <a:xfrm>
-            <a:off x="7315200" y="4901184"/>
-            <a:ext cx="3657600" cy="502920"/>
+            <a:off x="7315200" y="4517136"/>
+            <a:ext cx="3657600" cy="457200"/>
           </a:xfrm>
           <a:prstGeom prst="rect">
             <a:avLst/>
@@ -4118,9 +4118,48 @@
                 <a:ea typeface="Arial" pitchFamily="34" charset="-122"/>
                 <a:cs typeface="Arial" pitchFamily="34" charset="-120"/>
               </a:rPr>
-              <a:t>Hexagon HTP v79</a:t>
+              <a:t>4-5x efficient</a:t>
             </a:r>
             <a:endParaRPr lang="en-US" sz="1400" dirty="0"/>
+          </a:p>
+        </p:txBody>
+      </p:sp>
+      <p:sp>
+        <p:nvSpPr>
+          <p:cNvPr id="35" name="Text 33"/>
+          <p:cNvSpPr/>
+          <p:nvPr/>
+        </p:nvSpPr>
+        <p:spPr>
+          <a:xfrm>
+            <a:off x="731520" y="5166360"/>
+            <a:ext cx="10424160" cy="457200"/>
+          </a:xfrm>
+          <a:prstGeom prst="rect">
+            <a:avLst/>
+          </a:prstGeom>
+          <a:noFill/>
+          <a:ln/>
+        </p:spPr>
+        <p:txBody>
+          <a:bodyPr wrap="square" rtlCol="0" anchor="ctr"/>
+          <a:lstStyle/>
+          <a:p>
+            <a:pPr indent="0" marL="0">
+              <a:buNone/>
+            </a:pPr>
+            <a:r>
+              <a:rPr lang="en-US" sz="1200" i="1" dirty="0">
+                <a:solidFill>
+                  <a:srgbClr val="8B949E"/>
+                </a:solidFill>
+                <a:latin typeface="Arial" pitchFamily="34" charset="0"/>
+                <a:ea typeface="Arial" pitchFamily="34" charset="-122"/>
+                <a:cs typeface="Arial" pitchFamily="34" charset="-120"/>
+              </a:rPr>
+              <a:t>† Estimated from Qualcomm QNN HTP benchmarks — not yet measured on our specific model. Measured FPS shown live in-app.</a:t>
+            </a:r>
+            <a:endParaRPr lang="en-US" sz="1200" dirty="0"/>
           </a:p>
         </p:txBody>
       </p:sp>
@@ -8705,190 +8744,295 @@
       </p:sp>
       <p:sp>
         <p:nvSpPr>
-          <p:cNvPr id="3" name="Text 1"/>
+          <p:cNvPr id="3" name="Shape 1"/>
           <p:cNvSpPr/>
           <p:nvPr/>
         </p:nvSpPr>
         <p:spPr>
           <a:xfrm>
             <a:off x="731520" y="1097280"/>
-            <a:ext cx="10058400" cy="457200"/>
-          </a:xfrm>
-          <a:prstGeom prst="rect">
-            <a:avLst/>
-          </a:prstGeom>
-          <a:noFill/>
-          <a:ln/>
-        </p:spPr>
-        <p:txBody>
-          <a:bodyPr wrap="square" rtlCol="0" anchor="ctr"/>
-          <a:lstStyle/>
-          <a:p>
-            <a:pPr indent="0" marL="0">
-              <a:buNone/>
-            </a:pPr>
-            <a:r>
-              <a:rPr lang="en-US" sz="1600" dirty="0">
-                <a:solidFill>
-                  <a:srgbClr val="FFFFFF"/>
-                </a:solidFill>
-                <a:latin typeface="Arial" pitchFamily="34" charset="0"/>
-                <a:ea typeface="Arial" pitchFamily="34" charset="-122"/>
-                <a:cs typeface="Arial" pitchFamily="34" charset="-120"/>
-              </a:rPr>
-              <a:t>2,036 human-labeled images from 4 Roboflow datasets (CC BY 4.0)</a:t>
-            </a:r>
-            <a:endParaRPr lang="en-US" sz="1600" dirty="0"/>
-          </a:p>
-        </p:txBody>
-      </p:sp>
-      <p:sp>
-        <p:nvSpPr>
-          <p:cNvPr id="4" name="Text 2"/>
-          <p:cNvSpPr/>
-          <p:nvPr/>
-        </p:nvSpPr>
-        <p:spPr>
-          <a:xfrm>
-            <a:off x="731520" y="1828800"/>
-            <a:ext cx="2286000" cy="457200"/>
-          </a:xfrm>
-          <a:prstGeom prst="rect">
-            <a:avLst/>
-          </a:prstGeom>
-          <a:noFill/>
-          <a:ln/>
-        </p:spPr>
-        <p:txBody>
-          <a:bodyPr wrap="square" rtlCol="0" anchor="ctr"/>
-          <a:lstStyle/>
-          <a:p>
-            <a:pPr indent="0" marL="0">
-              <a:buNone/>
-            </a:pPr>
-            <a:r>
-              <a:rPr lang="en-US" sz="1400" b="1" dirty="0">
-                <a:solidFill>
-                  <a:srgbClr val="FFFFFF"/>
-                </a:solidFill>
-                <a:latin typeface="Arial" pitchFamily="34" charset="0"/>
-                <a:ea typeface="Arial" pitchFamily="34" charset="-122"/>
-                <a:cs typeface="Arial" pitchFamily="34" charset="-120"/>
-              </a:rPr>
-              <a:t>Server Vision</a:t>
-            </a:r>
-            <a:endParaRPr lang="en-US" sz="1400" dirty="0"/>
-          </a:p>
-        </p:txBody>
-      </p:sp>
-      <p:sp>
-        <p:nvSpPr>
-          <p:cNvPr id="5" name="Text 3"/>
-          <p:cNvSpPr/>
-          <p:nvPr/>
-        </p:nvSpPr>
-        <p:spPr>
-          <a:xfrm>
-            <a:off x="3017520" y="1828800"/>
-            <a:ext cx="1371600" cy="457200"/>
-          </a:xfrm>
-          <a:prstGeom prst="rect">
-            <a:avLst/>
-          </a:prstGeom>
-          <a:noFill/>
-          <a:ln/>
-        </p:spPr>
-        <p:txBody>
-          <a:bodyPr wrap="square" rtlCol="0" anchor="ctr"/>
-          <a:lstStyle/>
-          <a:p>
-            <a:pPr indent="0" marL="0">
-              <a:buNone/>
-            </a:pPr>
-            <a:r>
-              <a:rPr lang="en-US" sz="1400" dirty="0">
-                <a:solidFill>
-                  <a:srgbClr val="00E676"/>
-                </a:solidFill>
-                <a:latin typeface="Arial" pitchFamily="34" charset="0"/>
-                <a:ea typeface="Arial" pitchFamily="34" charset="-122"/>
-                <a:cs typeface="Arial" pitchFamily="34" charset="-120"/>
-              </a:rPr>
-              <a:t>1,293 imgs</a:t>
-            </a:r>
-            <a:endParaRPr lang="en-US" sz="1400" dirty="0"/>
-          </a:p>
-        </p:txBody>
-      </p:sp>
-      <p:sp>
-        <p:nvSpPr>
-          <p:cNvPr id="6" name="Text 4"/>
-          <p:cNvSpPr/>
-          <p:nvPr/>
-        </p:nvSpPr>
-        <p:spPr>
-          <a:xfrm>
-            <a:off x="4389120" y="1828800"/>
-            <a:ext cx="4572000" cy="457200"/>
-          </a:xfrm>
-          <a:prstGeom prst="rect">
-            <a:avLst/>
-          </a:prstGeom>
-          <a:noFill/>
-          <a:ln/>
-        </p:spPr>
-        <p:txBody>
-          <a:bodyPr wrap="square" rtlCol="0" anchor="ctr"/>
-          <a:lstStyle/>
-          <a:p>
-            <a:pPr indent="0" marL="0">
-              <a:buNone/>
-            </a:pPr>
-            <a:r>
-              <a:rPr lang="en-US" sz="1200" dirty="0">
-                <a:solidFill>
-                  <a:srgbClr val="8B949E"/>
-                </a:solidFill>
-                <a:latin typeface="Arial" pitchFamily="34" charset="0"/>
-                <a:ea typeface="Arial" pitchFamily="34" charset="-122"/>
-                <a:cs typeface="Arial" pitchFamily="34" charset="-120"/>
-              </a:rPr>
-              <a:t>30 classes (CPU, DIMM, fans, PSUs, drives)</a:t>
-            </a:r>
-            <a:endParaRPr lang="en-US" sz="1200" dirty="0"/>
-          </a:p>
-        </p:txBody>
-      </p:sp>
-      <p:sp>
-        <p:nvSpPr>
-          <p:cNvPr id="7" name="Shape 5"/>
-          <p:cNvSpPr/>
-          <p:nvPr/>
-        </p:nvSpPr>
-        <p:spPr>
-          <a:xfrm>
-            <a:off x="9144000" y="1965960"/>
-            <a:ext cx="1828800" cy="182880"/>
-          </a:xfrm>
-          <a:prstGeom prst="rect">
-            <a:avLst/>
+            <a:ext cx="10424160" cy="1051560"/>
+          </a:xfrm>
+          <a:prstGeom prst="roundRect">
+            <a:avLst>
+              <a:gd name="adj" fmla="val 8696"/>
+            </a:avLst>
           </a:prstGeom>
           <a:solidFill>
             <a:srgbClr val="161B22"/>
           </a:solidFill>
-          <a:ln/>
-        </p:spPr>
-      </p:sp>
-      <p:sp>
-        <p:nvSpPr>
-          <p:cNvPr id="8" name="Shape 6"/>
-          <p:cNvSpPr/>
-          <p:nvPr/>
-        </p:nvSpPr>
-        <p:spPr>
-          <a:xfrm>
-            <a:off x="9144000" y="1965960"/>
-            <a:ext cx="1170432" cy="182880"/>
+          <a:ln w="19050">
+            <a:solidFill>
+              <a:srgbClr val="FF9800"/>
+            </a:solidFill>
+            <a:prstDash val="solid"/>
+          </a:ln>
+        </p:spPr>
+      </p:sp>
+      <p:sp>
+        <p:nvSpPr>
+          <p:cNvPr id="4" name="Text 2"/>
+          <p:cNvSpPr/>
+          <p:nvPr/>
+        </p:nvSpPr>
+        <p:spPr>
+          <a:xfrm>
+            <a:off x="914400" y="1207008"/>
+            <a:ext cx="2743200" cy="365760"/>
+          </a:xfrm>
+          <a:prstGeom prst="rect">
+            <a:avLst/>
+          </a:prstGeom>
+          <a:noFill/>
+          <a:ln/>
+        </p:spPr>
+        <p:txBody>
+          <a:bodyPr wrap="square" rtlCol="0" anchor="ctr"/>
+          <a:lstStyle/>
+          <a:p>
+            <a:pPr indent="0" marL="0">
+              <a:buNone/>
+            </a:pPr>
+            <a:r>
+              <a:rPr lang="en-US" sz="1300" b="1" dirty="0">
+                <a:solidFill>
+                  <a:srgbClr val="FF9800"/>
+                </a:solidFill>
+                <a:latin typeface="Arial" pitchFamily="34" charset="0"/>
+                <a:ea typeface="Arial" pitchFamily="34" charset="-122"/>
+                <a:cs typeface="Arial" pitchFamily="34" charset="-120"/>
+              </a:rPr>
+              <a:t>PHASE 1 — Bootstrap</a:t>
+            </a:r>
+            <a:endParaRPr lang="en-US" sz="1300" dirty="0"/>
+          </a:p>
+        </p:txBody>
+      </p:sp>
+      <p:sp>
+        <p:nvSpPr>
+          <p:cNvPr id="5" name="Text 3"/>
+          <p:cNvSpPr/>
+          <p:nvPr/>
+        </p:nvSpPr>
+        <p:spPr>
+          <a:xfrm>
+            <a:off x="914400" y="1572768"/>
+            <a:ext cx="10058400" cy="457200"/>
+          </a:xfrm>
+          <a:prstGeom prst="rect">
+            <a:avLst/>
+          </a:prstGeom>
+          <a:noFill/>
+          <a:ln/>
+        </p:spPr>
+        <p:txBody>
+          <a:bodyPr wrap="square" rtlCol="0" anchor="ctr"/>
+          <a:lstStyle/>
+          <a:p>
+            <a:pPr indent="0" marL="0">
+              <a:buNone/>
+            </a:pPr>
+            <a:r>
+              <a:rPr lang="en-US" sz="1300" dirty="0">
+                <a:solidFill>
+                  <a:srgbClr val="C9D1D9"/>
+                </a:solidFill>
+                <a:latin typeface="Arial" pitchFamily="34" charset="0"/>
+                <a:ea typeface="Arial" pitchFamily="34" charset="-122"/>
+                <a:cs typeface="Arial" pitchFamily="34" charset="-120"/>
+              </a:rPr>
+              <a:t>BrightData Web Unlocker scraped 300+ data-center images  →  auto-labeled with Grounding DINO + SAM (3,045 polygons)</a:t>
+            </a:r>
+            <a:endParaRPr lang="en-US" sz="1300" dirty="0"/>
+          </a:p>
+        </p:txBody>
+      </p:sp>
+      <p:sp>
+        <p:nvSpPr>
+          <p:cNvPr id="6" name="Text 4"/>
+          <p:cNvSpPr/>
+          <p:nvPr/>
+        </p:nvSpPr>
+        <p:spPr>
+          <a:xfrm>
+            <a:off x="731520" y="2331720"/>
+            <a:ext cx="10424160" cy="365760"/>
+          </a:xfrm>
+          <a:prstGeom prst="rect">
+            <a:avLst/>
+          </a:prstGeom>
+          <a:noFill/>
+          <a:ln/>
+        </p:spPr>
+        <p:txBody>
+          <a:bodyPr wrap="square" rtlCol="0" anchor="ctr"/>
+          <a:lstStyle/>
+          <a:p>
+            <a:pPr indent="0" marL="0">
+              <a:buNone/>
+            </a:pPr>
+            <a:r>
+              <a:rPr lang="en-US" sz="1400" b="1" dirty="0">
+                <a:solidFill>
+                  <a:srgbClr val="00E676"/>
+                </a:solidFill>
+                <a:latin typeface="Arial" pitchFamily="34" charset="0"/>
+                <a:ea typeface="Arial" pitchFamily="34" charset="-122"/>
+                <a:cs typeface="Arial" pitchFamily="34" charset="-120"/>
+              </a:rPr>
+              <a:t>PHASE 2 — 2,036 human-labeled images from 4 Roboflow datasets (CC BY 4.0)  ·  used for final models</a:t>
+            </a:r>
+            <a:endParaRPr lang="en-US" sz="1400" dirty="0"/>
+          </a:p>
+        </p:txBody>
+      </p:sp>
+      <p:sp>
+        <p:nvSpPr>
+          <p:cNvPr id="7" name="Text 5"/>
+          <p:cNvSpPr/>
+          <p:nvPr/>
+        </p:nvSpPr>
+        <p:spPr>
+          <a:xfrm>
+            <a:off x="731520" y="2834640"/>
+            <a:ext cx="2286000" cy="457200"/>
+          </a:xfrm>
+          <a:prstGeom prst="rect">
+            <a:avLst/>
+          </a:prstGeom>
+          <a:noFill/>
+          <a:ln/>
+        </p:spPr>
+        <p:txBody>
+          <a:bodyPr wrap="square" rtlCol="0" anchor="ctr"/>
+          <a:lstStyle/>
+          <a:p>
+            <a:pPr indent="0" marL="0">
+              <a:buNone/>
+            </a:pPr>
+            <a:r>
+              <a:rPr lang="en-US" sz="1300" b="1" dirty="0">
+                <a:solidFill>
+                  <a:srgbClr val="FFFFFF"/>
+                </a:solidFill>
+                <a:latin typeface="Arial" pitchFamily="34" charset="0"/>
+                <a:ea typeface="Arial" pitchFamily="34" charset="-122"/>
+                <a:cs typeface="Arial" pitchFamily="34" charset="-120"/>
+              </a:rPr>
+              <a:t>Server Vision</a:t>
+            </a:r>
+            <a:endParaRPr lang="en-US" sz="1300" dirty="0"/>
+          </a:p>
+        </p:txBody>
+      </p:sp>
+      <p:sp>
+        <p:nvSpPr>
+          <p:cNvPr id="8" name="Text 6"/>
+          <p:cNvSpPr/>
+          <p:nvPr/>
+        </p:nvSpPr>
+        <p:spPr>
+          <a:xfrm>
+            <a:off x="3017520" y="2834640"/>
+            <a:ext cx="1371600" cy="457200"/>
+          </a:xfrm>
+          <a:prstGeom prst="rect">
+            <a:avLst/>
+          </a:prstGeom>
+          <a:noFill/>
+          <a:ln/>
+        </p:spPr>
+        <p:txBody>
+          <a:bodyPr wrap="square" rtlCol="0" anchor="ctr"/>
+          <a:lstStyle/>
+          <a:p>
+            <a:pPr indent="0" marL="0">
+              <a:buNone/>
+            </a:pPr>
+            <a:r>
+              <a:rPr lang="en-US" sz="1300" dirty="0">
+                <a:solidFill>
+                  <a:srgbClr val="00E676"/>
+                </a:solidFill>
+                <a:latin typeface="Arial" pitchFamily="34" charset="0"/>
+                <a:ea typeface="Arial" pitchFamily="34" charset="-122"/>
+                <a:cs typeface="Arial" pitchFamily="34" charset="-120"/>
+              </a:rPr>
+              <a:t>1,293 imgs</a:t>
+            </a:r>
+            <a:endParaRPr lang="en-US" sz="1300" dirty="0"/>
+          </a:p>
+        </p:txBody>
+      </p:sp>
+      <p:sp>
+        <p:nvSpPr>
+          <p:cNvPr id="9" name="Text 7"/>
+          <p:cNvSpPr/>
+          <p:nvPr/>
+        </p:nvSpPr>
+        <p:spPr>
+          <a:xfrm>
+            <a:off x="4389120" y="2834640"/>
+            <a:ext cx="4572000" cy="457200"/>
+          </a:xfrm>
+          <a:prstGeom prst="rect">
+            <a:avLst/>
+          </a:prstGeom>
+          <a:noFill/>
+          <a:ln/>
+        </p:spPr>
+        <p:txBody>
+          <a:bodyPr wrap="square" rtlCol="0" anchor="ctr"/>
+          <a:lstStyle/>
+          <a:p>
+            <a:pPr indent="0" marL="0">
+              <a:buNone/>
+            </a:pPr>
+            <a:r>
+              <a:rPr lang="en-US" sz="1100" dirty="0">
+                <a:solidFill>
+                  <a:srgbClr val="8B949E"/>
+                </a:solidFill>
+                <a:latin typeface="Arial" pitchFamily="34" charset="0"/>
+                <a:ea typeface="Arial" pitchFamily="34" charset="-122"/>
+                <a:cs typeface="Arial" pitchFamily="34" charset="-120"/>
+              </a:rPr>
+              <a:t>30 classes (CPU, DIMM, fans, PSUs, drives)</a:t>
+            </a:r>
+            <a:endParaRPr lang="en-US" sz="1100" dirty="0"/>
+          </a:p>
+        </p:txBody>
+      </p:sp>
+      <p:sp>
+        <p:nvSpPr>
+          <p:cNvPr id="10" name="Shape 8"/>
+          <p:cNvSpPr/>
+          <p:nvPr/>
+        </p:nvSpPr>
+        <p:spPr>
+          <a:xfrm>
+            <a:off x="9144000" y="2944368"/>
+            <a:ext cx="1828800" cy="164592"/>
+          </a:xfrm>
+          <a:prstGeom prst="rect">
+            <a:avLst/>
+          </a:prstGeom>
+          <a:solidFill>
+            <a:srgbClr val="161B22"/>
+          </a:solidFill>
+          <a:ln/>
+        </p:spPr>
+      </p:sp>
+      <p:sp>
+        <p:nvSpPr>
+          <p:cNvPr id="11" name="Shape 9"/>
+          <p:cNvSpPr/>
+          <p:nvPr/>
+        </p:nvSpPr>
+        <p:spPr>
+          <a:xfrm>
+            <a:off x="9144000" y="2944368"/>
+            <a:ext cx="1170432" cy="164592"/>
           </a:xfrm>
           <a:prstGeom prst="rect">
             <a:avLst/>
@@ -8901,13 +9045,13 @@
       </p:sp>
       <p:sp>
         <p:nvSpPr>
-          <p:cNvPr id="9" name="Text 7"/>
-          <p:cNvSpPr/>
-          <p:nvPr/>
-        </p:nvSpPr>
-        <p:spPr>
-          <a:xfrm>
-            <a:off x="731520" y="2651760"/>
+          <p:cNvPr id="12" name="Text 10"/>
+          <p:cNvSpPr/>
+          <p:nvPr/>
+        </p:nvSpPr>
+        <p:spPr>
+          <a:xfrm>
+            <a:off x="731520" y="3401568"/>
             <a:ext cx="2286000" cy="457200"/>
           </a:xfrm>
           <a:prstGeom prst="rect">
@@ -8924,7 +9068,7 @@
               <a:buNone/>
             </a:pPr>
             <a:r>
-              <a:rPr lang="en-US" sz="1400" b="1" dirty="0">
+              <a:rPr lang="en-US" sz="1300" b="1" dirty="0">
                 <a:solidFill>
                   <a:srgbClr val="FFFFFF"/>
                 </a:solidFill>
@@ -8934,19 +9078,19 @@
               </a:rPr>
               <a:t>PC Ports</a:t>
             </a:r>
-            <a:endParaRPr lang="en-US" sz="1400" dirty="0"/>
-          </a:p>
-        </p:txBody>
-      </p:sp>
-      <p:sp>
-        <p:nvSpPr>
-          <p:cNvPr id="10" name="Text 8"/>
-          <p:cNvSpPr/>
-          <p:nvPr/>
-        </p:nvSpPr>
-        <p:spPr>
-          <a:xfrm>
-            <a:off x="3017520" y="2651760"/>
+            <a:endParaRPr lang="en-US" sz="1300" dirty="0"/>
+          </a:p>
+        </p:txBody>
+      </p:sp>
+      <p:sp>
+        <p:nvSpPr>
+          <p:cNvPr id="13" name="Text 11"/>
+          <p:cNvSpPr/>
+          <p:nvPr/>
+        </p:nvSpPr>
+        <p:spPr>
+          <a:xfrm>
+            <a:off x="3017520" y="3401568"/>
             <a:ext cx="1371600" cy="457200"/>
           </a:xfrm>
           <a:prstGeom prst="rect">
@@ -8963,7 +9107,7 @@
               <a:buNone/>
             </a:pPr>
             <a:r>
-              <a:rPr lang="en-US" sz="1400" dirty="0">
+              <a:rPr lang="en-US" sz="1300" dirty="0">
                 <a:solidFill>
                   <a:srgbClr val="00E676"/>
                 </a:solidFill>
@@ -8973,19 +9117,19 @@
               </a:rPr>
               <a:t>327 imgs</a:t>
             </a:r>
-            <a:endParaRPr lang="en-US" sz="1400" dirty="0"/>
-          </a:p>
-        </p:txBody>
-      </p:sp>
-      <p:sp>
-        <p:nvSpPr>
-          <p:cNvPr id="11" name="Text 9"/>
-          <p:cNvSpPr/>
-          <p:nvPr/>
-        </p:nvSpPr>
-        <p:spPr>
-          <a:xfrm>
-            <a:off x="4389120" y="2651760"/>
+            <a:endParaRPr lang="en-US" sz="1300" dirty="0"/>
+          </a:p>
+        </p:txBody>
+      </p:sp>
+      <p:sp>
+        <p:nvSpPr>
+          <p:cNvPr id="14" name="Text 12"/>
+          <p:cNvSpPr/>
+          <p:nvPr/>
+        </p:nvSpPr>
+        <p:spPr>
+          <a:xfrm>
+            <a:off x="4389120" y="3401568"/>
             <a:ext cx="4572000" cy="457200"/>
           </a:xfrm>
           <a:prstGeom prst="rect">
@@ -9002,7 +9146,7 @@
               <a:buNone/>
             </a:pPr>
             <a:r>
-              <a:rPr lang="en-US" sz="1200" dirty="0">
+              <a:rPr lang="en-US" sz="1100" dirty="0">
                 <a:solidFill>
                   <a:srgbClr val="8B949E"/>
                 </a:solidFill>
@@ -9012,20 +9156,20 @@
               </a:rPr>
               <a:t>4 classes (HDMI, RJ45, USB-A, USB-C)</a:t>
             </a:r>
-            <a:endParaRPr lang="en-US" sz="1200" dirty="0"/>
-          </a:p>
-        </p:txBody>
-      </p:sp>
-      <p:sp>
-        <p:nvSpPr>
-          <p:cNvPr id="12" name="Shape 10"/>
-          <p:cNvSpPr/>
-          <p:nvPr/>
-        </p:nvSpPr>
-        <p:spPr>
-          <a:xfrm>
-            <a:off x="9144000" y="2788920"/>
-            <a:ext cx="1828800" cy="182880"/>
+            <a:endParaRPr lang="en-US" sz="1100" dirty="0"/>
+          </a:p>
+        </p:txBody>
+      </p:sp>
+      <p:sp>
+        <p:nvSpPr>
+          <p:cNvPr id="15" name="Shape 13"/>
+          <p:cNvSpPr/>
+          <p:nvPr/>
+        </p:nvSpPr>
+        <p:spPr>
+          <a:xfrm>
+            <a:off x="9144000" y="3511296"/>
+            <a:ext cx="1828800" cy="164592"/>
           </a:xfrm>
           <a:prstGeom prst="rect">
             <a:avLst/>
@@ -9038,14 +9182,14 @@
       </p:sp>
       <p:sp>
         <p:nvSpPr>
-          <p:cNvPr id="13" name="Shape 11"/>
-          <p:cNvSpPr/>
-          <p:nvPr/>
-        </p:nvSpPr>
-        <p:spPr>
-          <a:xfrm>
-            <a:off x="9144000" y="2788920"/>
-            <a:ext cx="292608" cy="182880"/>
+          <p:cNvPr id="16" name="Shape 14"/>
+          <p:cNvSpPr/>
+          <p:nvPr/>
+        </p:nvSpPr>
+        <p:spPr>
+          <a:xfrm>
+            <a:off x="9144000" y="3511296"/>
+            <a:ext cx="292608" cy="164592"/>
           </a:xfrm>
           <a:prstGeom prst="rect">
             <a:avLst/>
@@ -9058,13 +9202,13 @@
       </p:sp>
       <p:sp>
         <p:nvSpPr>
-          <p:cNvPr id="14" name="Text 12"/>
-          <p:cNvSpPr/>
-          <p:nvPr/>
-        </p:nvSpPr>
-        <p:spPr>
-          <a:xfrm>
-            <a:off x="731520" y="3474720"/>
+          <p:cNvPr id="17" name="Text 15"/>
+          <p:cNvSpPr/>
+          <p:nvPr/>
+        </p:nvSpPr>
+        <p:spPr>
+          <a:xfrm>
+            <a:off x="731520" y="3968496"/>
             <a:ext cx="2286000" cy="457200"/>
           </a:xfrm>
           <a:prstGeom prst="rect">
@@ -9081,7 +9225,7 @@
               <a:buNone/>
             </a:pPr>
             <a:r>
-              <a:rPr lang="en-US" sz="1400" b="1" dirty="0">
+              <a:rPr lang="en-US" sz="1300" b="1" dirty="0">
                 <a:solidFill>
                   <a:srgbClr val="FFFFFF"/>
                 </a:solidFill>
@@ -9091,19 +9235,19 @@
               </a:rPr>
               <a:t>Ports (ym)</a:t>
             </a:r>
-            <a:endParaRPr lang="en-US" sz="1400" dirty="0"/>
-          </a:p>
-        </p:txBody>
-      </p:sp>
-      <p:sp>
-        <p:nvSpPr>
-          <p:cNvPr id="15" name="Text 13"/>
-          <p:cNvSpPr/>
-          <p:nvPr/>
-        </p:nvSpPr>
-        <p:spPr>
-          <a:xfrm>
-            <a:off x="3017520" y="3474720"/>
+            <a:endParaRPr lang="en-US" sz="1300" dirty="0"/>
+          </a:p>
+        </p:txBody>
+      </p:sp>
+      <p:sp>
+        <p:nvSpPr>
+          <p:cNvPr id="18" name="Text 16"/>
+          <p:cNvSpPr/>
+          <p:nvPr/>
+        </p:nvSpPr>
+        <p:spPr>
+          <a:xfrm>
+            <a:off x="3017520" y="3968496"/>
             <a:ext cx="1371600" cy="457200"/>
           </a:xfrm>
           <a:prstGeom prst="rect">
@@ -9120,7 +9264,7 @@
               <a:buNone/>
             </a:pPr>
             <a:r>
-              <a:rPr lang="en-US" sz="1400" dirty="0">
+              <a:rPr lang="en-US" sz="1300" dirty="0">
                 <a:solidFill>
                   <a:srgbClr val="00E676"/>
                 </a:solidFill>
@@ -9130,19 +9274,19 @@
               </a:rPr>
               <a:t>138 imgs</a:t>
             </a:r>
-            <a:endParaRPr lang="en-US" sz="1400" dirty="0"/>
-          </a:p>
-        </p:txBody>
-      </p:sp>
-      <p:sp>
-        <p:nvSpPr>
-          <p:cNvPr id="16" name="Text 14"/>
-          <p:cNvSpPr/>
-          <p:nvPr/>
-        </p:nvSpPr>
-        <p:spPr>
-          <a:xfrm>
-            <a:off x="4389120" y="3474720"/>
+            <a:endParaRPr lang="en-US" sz="1300" dirty="0"/>
+          </a:p>
+        </p:txBody>
+      </p:sp>
+      <p:sp>
+        <p:nvSpPr>
+          <p:cNvPr id="19" name="Text 17"/>
+          <p:cNvSpPr/>
+          <p:nvPr/>
+        </p:nvSpPr>
+        <p:spPr>
+          <a:xfrm>
+            <a:off x="4389120" y="3968496"/>
             <a:ext cx="4572000" cy="457200"/>
           </a:xfrm>
           <a:prstGeom prst="rect">
@@ -9159,7 +9303,7 @@
               <a:buNone/>
             </a:pPr>
             <a:r>
-              <a:rPr lang="en-US" sz="1200" dirty="0">
+              <a:rPr lang="en-US" sz="1100" dirty="0">
                 <a:solidFill>
                   <a:srgbClr val="8B949E"/>
                 </a:solidFill>
@@ -9169,20 +9313,20 @@
               </a:rPr>
               <a:t>7 classes (DP, ethernet, power, USB)</a:t>
             </a:r>
-            <a:endParaRPr lang="en-US" sz="1200" dirty="0"/>
-          </a:p>
-        </p:txBody>
-      </p:sp>
-      <p:sp>
-        <p:nvSpPr>
-          <p:cNvPr id="17" name="Shape 15"/>
-          <p:cNvSpPr/>
-          <p:nvPr/>
-        </p:nvSpPr>
-        <p:spPr>
-          <a:xfrm>
-            <a:off x="9144000" y="3611880"/>
-            <a:ext cx="1828800" cy="182880"/>
+            <a:endParaRPr lang="en-US" sz="1100" dirty="0"/>
+          </a:p>
+        </p:txBody>
+      </p:sp>
+      <p:sp>
+        <p:nvSpPr>
+          <p:cNvPr id="20" name="Shape 18"/>
+          <p:cNvSpPr/>
+          <p:nvPr/>
+        </p:nvSpPr>
+        <p:spPr>
+          <a:xfrm>
+            <a:off x="9144000" y="4078224"/>
+            <a:ext cx="1828800" cy="164592"/>
           </a:xfrm>
           <a:prstGeom prst="rect">
             <a:avLst/>
@@ -9195,14 +9339,14 @@
       </p:sp>
       <p:sp>
         <p:nvSpPr>
-          <p:cNvPr id="18" name="Shape 16"/>
-          <p:cNvSpPr/>
-          <p:nvPr/>
-        </p:nvSpPr>
-        <p:spPr>
-          <a:xfrm>
-            <a:off x="9144000" y="3611880"/>
-            <a:ext cx="128016" cy="182880"/>
+          <p:cNvPr id="21" name="Shape 19"/>
+          <p:cNvSpPr/>
+          <p:nvPr/>
+        </p:nvSpPr>
+        <p:spPr>
+          <a:xfrm>
+            <a:off x="9144000" y="4078224"/>
+            <a:ext cx="128016" cy="164592"/>
           </a:xfrm>
           <a:prstGeom prst="rect">
             <a:avLst/>
@@ -9215,13 +9359,13 @@
       </p:sp>
       <p:sp>
         <p:nvSpPr>
-          <p:cNvPr id="19" name="Text 17"/>
-          <p:cNvSpPr/>
-          <p:nvPr/>
-        </p:nvSpPr>
-        <p:spPr>
-          <a:xfrm>
-            <a:off x="731520" y="4297680"/>
+          <p:cNvPr id="22" name="Text 20"/>
+          <p:cNvSpPr/>
+          <p:nvPr/>
+        </p:nvSpPr>
+        <p:spPr>
+          <a:xfrm>
+            <a:off x="731520" y="4535424"/>
             <a:ext cx="2286000" cy="457200"/>
           </a:xfrm>
           <a:prstGeom prst="rect">
@@ -9238,7 +9382,7 @@
               <a:buNone/>
             </a:pPr>
             <a:r>
-              <a:rPr lang="en-US" sz="1400" b="1" dirty="0">
+              <a:rPr lang="en-US" sz="1300" b="1" dirty="0">
                 <a:solidFill>
                   <a:srgbClr val="FFFFFF"/>
                 </a:solidFill>
@@ -9248,19 +9392,19 @@
               </a:rPr>
               <a:t>Server Detection</a:t>
             </a:r>
-            <a:endParaRPr lang="en-US" sz="1400" dirty="0"/>
-          </a:p>
-        </p:txBody>
-      </p:sp>
-      <p:sp>
-        <p:nvSpPr>
-          <p:cNvPr id="20" name="Text 18"/>
-          <p:cNvSpPr/>
-          <p:nvPr/>
-        </p:nvSpPr>
-        <p:spPr>
-          <a:xfrm>
-            <a:off x="3017520" y="4297680"/>
+            <a:endParaRPr lang="en-US" sz="1300" dirty="0"/>
+          </a:p>
+        </p:txBody>
+      </p:sp>
+      <p:sp>
+        <p:nvSpPr>
+          <p:cNvPr id="23" name="Text 21"/>
+          <p:cNvSpPr/>
+          <p:nvPr/>
+        </p:nvSpPr>
+        <p:spPr>
+          <a:xfrm>
+            <a:off x="3017520" y="4535424"/>
             <a:ext cx="1371600" cy="457200"/>
           </a:xfrm>
           <a:prstGeom prst="rect">
@@ -9277,7 +9421,7 @@
               <a:buNone/>
             </a:pPr>
             <a:r>
-              <a:rPr lang="en-US" sz="1400" dirty="0">
+              <a:rPr lang="en-US" sz="1300" dirty="0">
                 <a:solidFill>
                   <a:srgbClr val="00E676"/>
                 </a:solidFill>
@@ -9287,19 +9431,19 @@
               </a:rPr>
               <a:t>54 imgs</a:t>
             </a:r>
-            <a:endParaRPr lang="en-US" sz="1400" dirty="0"/>
-          </a:p>
-        </p:txBody>
-      </p:sp>
-      <p:sp>
-        <p:nvSpPr>
-          <p:cNvPr id="21" name="Text 19"/>
-          <p:cNvSpPr/>
-          <p:nvPr/>
-        </p:nvSpPr>
-        <p:spPr>
-          <a:xfrm>
-            <a:off x="4389120" y="4297680"/>
+            <a:endParaRPr lang="en-US" sz="1300" dirty="0"/>
+          </a:p>
+        </p:txBody>
+      </p:sp>
+      <p:sp>
+        <p:nvSpPr>
+          <p:cNvPr id="24" name="Text 22"/>
+          <p:cNvSpPr/>
+          <p:nvPr/>
+        </p:nvSpPr>
+        <p:spPr>
+          <a:xfrm>
+            <a:off x="4389120" y="4535424"/>
             <a:ext cx="4572000" cy="457200"/>
           </a:xfrm>
           <a:prstGeom prst="rect">
@@ -9316,7 +9460,7 @@
               <a:buNone/>
             </a:pPr>
             <a:r>
-              <a:rPr lang="en-US" sz="1200" dirty="0">
+              <a:rPr lang="en-US" sz="1100" dirty="0">
                 <a:solidFill>
                   <a:srgbClr val="8B949E"/>
                 </a:solidFill>
@@ -9326,20 +9470,20 @@
               </a:rPr>
               <a:t>9 classes (SFP, XFP, patch panels)</a:t>
             </a:r>
-            <a:endParaRPr lang="en-US" sz="1200" dirty="0"/>
-          </a:p>
-        </p:txBody>
-      </p:sp>
-      <p:sp>
-        <p:nvSpPr>
-          <p:cNvPr id="22" name="Shape 20"/>
-          <p:cNvSpPr/>
-          <p:nvPr/>
-        </p:nvSpPr>
-        <p:spPr>
-          <a:xfrm>
-            <a:off x="9144000" y="4434840"/>
-            <a:ext cx="1828800" cy="182880"/>
+            <a:endParaRPr lang="en-US" sz="1100" dirty="0"/>
+          </a:p>
+        </p:txBody>
+      </p:sp>
+      <p:sp>
+        <p:nvSpPr>
+          <p:cNvPr id="25" name="Shape 23"/>
+          <p:cNvSpPr/>
+          <p:nvPr/>
+        </p:nvSpPr>
+        <p:spPr>
+          <a:xfrm>
+            <a:off x="9144000" y="4645152"/>
+            <a:ext cx="1828800" cy="164592"/>
           </a:xfrm>
           <a:prstGeom prst="rect">
             <a:avLst/>
@@ -9352,14 +9496,14 @@
       </p:sp>
       <p:sp>
         <p:nvSpPr>
-          <p:cNvPr id="23" name="Shape 21"/>
-          <p:cNvSpPr/>
-          <p:nvPr/>
-        </p:nvSpPr>
-        <p:spPr>
-          <a:xfrm>
-            <a:off x="9144000" y="4434840"/>
-            <a:ext cx="54864" cy="182880"/>
+          <p:cNvPr id="26" name="Shape 24"/>
+          <p:cNvSpPr/>
+          <p:nvPr/>
+        </p:nvSpPr>
+        <p:spPr>
+          <a:xfrm>
+            <a:off x="9144000" y="4645152"/>
+            <a:ext cx="54864" cy="164592"/>
           </a:xfrm>
           <a:prstGeom prst="rect">
             <a:avLst/>
@@ -9372,33 +9516,30 @@
       </p:sp>
       <p:sp>
         <p:nvSpPr>
-          <p:cNvPr id="24" name="Text 22"/>
-          <p:cNvSpPr/>
-          <p:nvPr/>
-        </p:nvSpPr>
-        <p:spPr>
-          <a:xfrm>
-            <a:off x="731520" y="4572000"/>
-            <a:ext cx="10058400" cy="731520"/>
-          </a:xfrm>
-          <a:prstGeom prst="rect">
-            <a:avLst/>
-          </a:prstGeom>
-          <a:noFill/>
-          <a:ln/>
-        </p:spPr>
-        <p:txBody>
-          <a:bodyPr wrap="square" rtlCol="0" anchor="ctr"/>
-          <a:lstStyle/>
-          <a:p>
-            <a:pPr indent="0" marL="0">
-              <a:lnSpc>
-                <a:spcPct val="140000"/>
-              </a:lnSpc>
-              <a:buNone/>
-            </a:pPr>
-            <a:r>
-              <a:rPr lang="en-US" sz="1300" dirty="0">
+          <p:cNvPr id="27" name="Text 25"/>
+          <p:cNvSpPr/>
+          <p:nvPr/>
+        </p:nvSpPr>
+        <p:spPr>
+          <a:xfrm>
+            <a:off x="731520" y="5212080"/>
+            <a:ext cx="10424160" cy="365760"/>
+          </a:xfrm>
+          <a:prstGeom prst="rect">
+            <a:avLst/>
+          </a:prstGeom>
+          <a:noFill/>
+          <a:ln/>
+        </p:spPr>
+        <p:txBody>
+          <a:bodyPr wrap="square" rtlCol="0" anchor="ctr"/>
+          <a:lstStyle/>
+          <a:p>
+            <a:pPr indent="0" marL="0">
+              <a:buNone/>
+            </a:pPr>
+            <a:r>
+              <a:rPr lang="en-US" sz="1200" dirty="0">
                 <a:solidFill>
                   <a:srgbClr val="C9D1D9"/>
                 </a:solidFill>
@@ -9406,27 +9547,46 @@
                 <a:ea typeface="Arial" pitchFamily="34" charset="-122"/>
                 <a:cs typeface="Arial" pitchFamily="34" charset="-120"/>
               </a:rPr>
-              <a:t>50+ source classes → mapped to 16 DC-Ops classes</a:t>
-            </a:r>
-            <a:endParaRPr lang="en-US" sz="1300" dirty="0"/>
-          </a:p>
-          <a:p>
-            <a:pPr indent="0" marL="0">
-              <a:lnSpc>
-                <a:spcPct val="140000"/>
-              </a:lnSpc>
-              <a:buNone/>
-            </a:pPr>
-            <a:r>
-              <a:rPr lang="en-US" sz="1300" dirty="0">
-                <a:solidFill>
-                  <a:srgbClr val="C9D1D9"/>
-                </a:solidFill>
-                <a:latin typeface="Arial" pitchFamily="34" charset="0"/>
-                <a:ea typeface="Arial" pitchFamily="34" charset="-122"/>
-                <a:cs typeface="Arial" pitchFamily="34" charset="-120"/>
-              </a:rPr>
-              <a:t>Augmentations: Moiré patterns, screen glare, brightness variation, color tint, scanlines</a:t>
+              <a:t>50+ source classes → mapped to 16 DC-Ops classes   ·   Augmentations: Moiré, screen glare, brightness, color tint, scanlines</a:t>
+            </a:r>
+            <a:endParaRPr lang="en-US" sz="1200" dirty="0"/>
+          </a:p>
+        </p:txBody>
+      </p:sp>
+      <p:sp>
+        <p:nvSpPr>
+          <p:cNvPr id="28" name="Text 26"/>
+          <p:cNvSpPr/>
+          <p:nvPr/>
+        </p:nvSpPr>
+        <p:spPr>
+          <a:xfrm>
+            <a:off x="731520" y="5669280"/>
+            <a:ext cx="10424160" cy="365760"/>
+          </a:xfrm>
+          <a:prstGeom prst="rect">
+            <a:avLst/>
+          </a:prstGeom>
+          <a:noFill/>
+          <a:ln/>
+        </p:spPr>
+        <p:txBody>
+          <a:bodyPr wrap="square" rtlCol="0" anchor="ctr"/>
+          <a:lstStyle/>
+          <a:p>
+            <a:pPr indent="0" marL="0">
+              <a:buNone/>
+            </a:pPr>
+            <a:r>
+              <a:rPr lang="en-US" sz="1300" b="1" i="1" dirty="0">
+                <a:solidFill>
+                  <a:srgbClr val="FF9800"/>
+                </a:solidFill>
+                <a:latin typeface="Arial" pitchFamily="34" charset="0"/>
+                <a:ea typeface="Arial" pitchFamily="34" charset="-122"/>
+                <a:cs typeface="Arial" pitchFamily="34" charset="-120"/>
+              </a:rPr>
+              <a:t>⚡ Powered by BrightData — web data infrastructure for the bootstrap dataset</a:t>
             </a:r>
             <a:endParaRPr lang="en-US" sz="1300" dirty="0"/>
           </a:p>

</xml_diff>